<commit_message>
Update perfetto_ppt/: rebuild CPU page as two-panel vertical layout
Summary:
- Rework the CPU page to mirror the source deck: left panel with a
  vertical 4-step diagnosis route (numbered nodes on a connector),
  right panel listing the three common outputs.
- Replace the previous two horizontal card rows, which lost the
  vertical progression of the original layout.
- All 26 pages re-verified: structural QA (overflow/overlap) passes.

Signed-off-by: xiaodong03.zhang <xiaodong03.zhang@d-robotics.cc>
</commit_message>
<xml_diff>
--- a/perfetto_ppt/Perfetto_Agent_Skills_地瓜模板_26页.pptx
+++ b/perfetto_ppt/Perfetto_Agent_Skills_地瓜模板_26页.pptx
@@ -10681,51 +10681,14 @@
       </p:sp>
       <p:sp>
         <p:nvSpPr>
-          <p:cNvPr id="13" name="TextBox 12"/>
-          <p:cNvSpPr txBox="1"/>
+          <p:cNvPr id="13" name="Rounded Rectangle 12"/>
+          <p:cNvSpPr/>
           <p:nvPr/>
         </p:nvSpPr>
         <p:spPr>
           <a:xfrm>
             <a:off x="868680" y="1828800"/>
-            <a:ext cx="7315200" cy="320040"/>
-          </a:xfrm>
-          <a:prstGeom prst="rect">
-            <a:avLst/>
-          </a:prstGeom>
-          <a:noFill/>
-        </p:spPr>
-        <p:txBody>
-          <a:bodyPr wrap="square" lIns="0" rIns="0" tIns="0" bIns="0" anchor="t">
-            <a:spAutoFit/>
-          </a:bodyPr>
-          <a:lstStyle/>
-          <a:p>
-            <a:pPr algn="l"/>
-            <a:r>
-              <a:rPr sz="2100" b="1">
-                <a:solidFill>
-                  <a:srgbClr val="572D26"/>
-                </a:solidFill>
-                <a:latin typeface="微软雅黑"/>
-                <a:ea typeface="微软雅黑"/>
-                <a:cs typeface="微软雅黑"/>
-              </a:rPr>
-              <a:t>一条常见的诊断路线</a:t>
-            </a:r>
-          </a:p>
-        </p:txBody>
-      </p:sp>
-      <p:sp>
-        <p:nvSpPr>
-          <p:cNvPr id="14" name="Rounded Rectangle 13"/>
-          <p:cNvSpPr/>
-          <p:nvPr/>
-        </p:nvSpPr>
-        <p:spPr>
-          <a:xfrm>
-            <a:off x="868680" y="2240280"/>
-            <a:ext cx="3424428" cy="1874519"/>
+            <a:ext cx="8869680" cy="5760720"/>
           </a:xfrm>
           <a:prstGeom prst="roundRect">
             <a:avLst>
@@ -10764,13 +10727,94 @@
       </p:sp>
       <p:sp>
         <p:nvSpPr>
-          <p:cNvPr id="15" name="Oval 14"/>
+          <p:cNvPr id="14" name="TextBox 13"/>
+          <p:cNvSpPr txBox="1"/>
+          <p:nvPr/>
+        </p:nvSpPr>
+        <p:spPr>
+          <a:xfrm>
+            <a:off x="1188720" y="2084831"/>
+            <a:ext cx="7315200" cy="365760"/>
+          </a:xfrm>
+          <a:prstGeom prst="rect">
+            <a:avLst/>
+          </a:prstGeom>
+          <a:noFill/>
+        </p:spPr>
+        <p:txBody>
+          <a:bodyPr wrap="square" lIns="0" rIns="0" tIns="0" bIns="0" anchor="t">
+            <a:spAutoFit/>
+          </a:bodyPr>
+          <a:lstStyle/>
+          <a:p>
+            <a:pPr algn="l"/>
+            <a:r>
+              <a:rPr sz="2100" b="1">
+                <a:solidFill>
+                  <a:srgbClr val="572D26"/>
+                </a:solidFill>
+                <a:latin typeface="微软雅黑"/>
+                <a:ea typeface="微软雅黑"/>
+                <a:cs typeface="微软雅黑"/>
+              </a:rPr>
+              <a:t>一条常见的诊断路线</a:t>
+            </a:r>
+          </a:p>
+        </p:txBody>
+      </p:sp>
+      <p:sp>
+        <p:nvSpPr>
+          <p:cNvPr id="15" name="Rectangle 14"/>
           <p:cNvSpPr/>
           <p:nvPr/>
         </p:nvSpPr>
         <p:spPr>
           <a:xfrm>
-            <a:off x="1124712" y="2450592"/>
+            <a:off x="1463040" y="3017520"/>
+            <a:ext cx="27432" cy="3163824"/>
+          </a:xfrm>
+          <a:prstGeom prst="rect">
+            <a:avLst/>
+          </a:prstGeom>
+          <a:solidFill>
+            <a:srgbClr val="FFD393"/>
+          </a:solidFill>
+          <a:ln>
+            <a:noFill/>
+          </a:ln>
+          <a:effectLst/>
+        </p:spPr>
+        <p:style>
+          <a:lnRef idx="1">
+            <a:schemeClr val="accent1"/>
+          </a:lnRef>
+          <a:fillRef idx="3">
+            <a:schemeClr val="accent1"/>
+          </a:fillRef>
+          <a:effectRef idx="2">
+            <a:schemeClr val="accent1"/>
+          </a:effectRef>
+          <a:fontRef idx="minor">
+            <a:schemeClr val="lt1"/>
+          </a:fontRef>
+        </p:style>
+        <p:txBody>
+          <a:bodyPr rtlCol="0" anchor="ctr"/>
+          <a:lstStyle/>
+          <a:p>
+            <a:pPr algn="ctr"/>
+          </a:p>
+        </p:txBody>
+      </p:sp>
+      <p:sp>
+        <p:nvSpPr>
+          <p:cNvPr id="16" name="Oval 15"/>
+          <p:cNvSpPr/>
+          <p:nvPr/>
+        </p:nvSpPr>
+        <p:spPr>
+          <a:xfrm>
+            <a:off x="1188720" y="2743200"/>
             <a:ext cx="566928" cy="566928"/>
           </a:xfrm>
           <a:prstGeom prst="ellipse">
@@ -10808,13 +10852,13 @@
       </p:sp>
       <p:sp>
         <p:nvSpPr>
-          <p:cNvPr id="16" name="TextBox 15"/>
-          <p:cNvSpPr txBox="1"/>
-          <p:nvPr/>
-        </p:nvSpPr>
-        <p:spPr>
-          <a:xfrm>
-            <a:off x="1124712" y="2450592"/>
+          <p:cNvPr id="17" name="TextBox 16"/>
+          <p:cNvSpPr txBox="1"/>
+          <p:nvPr/>
+        </p:nvSpPr>
+        <p:spPr>
+          <a:xfrm>
+            <a:off x="1188720" y="2743200"/>
             <a:ext cx="566928" cy="566928"/>
           </a:xfrm>
           <a:prstGeom prst="rect">
@@ -10845,22 +10889,22 @@
       </p:sp>
       <p:sp>
         <p:nvSpPr>
-          <p:cNvPr id="17" name="TextBox 16"/>
-          <p:cNvSpPr txBox="1"/>
-          <p:nvPr/>
-        </p:nvSpPr>
-        <p:spPr>
-          <a:xfrm>
-            <a:off x="1124712" y="3145536"/>
-            <a:ext cx="2912364" cy="365760"/>
-          </a:xfrm>
-          <a:prstGeom prst="rect">
-            <a:avLst/>
-          </a:prstGeom>
-          <a:noFill/>
-        </p:spPr>
-        <p:txBody>
-          <a:bodyPr wrap="square" lIns="0" rIns="0" tIns="0" bIns="0" anchor="t">
+          <p:cNvPr id="18" name="TextBox 17"/>
+          <p:cNvSpPr txBox="1"/>
+          <p:nvPr/>
+        </p:nvSpPr>
+        <p:spPr>
+          <a:xfrm>
+            <a:off x="1965960" y="2761488"/>
+            <a:ext cx="2743200" cy="365760"/>
+          </a:xfrm>
+          <a:prstGeom prst="rect">
+            <a:avLst/>
+          </a:prstGeom>
+          <a:noFill/>
+        </p:spPr>
+        <p:txBody>
+          <a:bodyPr wrap="square" lIns="0" rIns="0" tIns="0" bIns="0" anchor="ctr">
             <a:spAutoFit/>
           </a:bodyPr>
           <a:lstStyle/>
@@ -10882,29 +10926,29 @@
       </p:sp>
       <p:sp>
         <p:nvSpPr>
-          <p:cNvPr id="18" name="TextBox 17"/>
-          <p:cNvSpPr txBox="1"/>
-          <p:nvPr/>
-        </p:nvSpPr>
-        <p:spPr>
-          <a:xfrm>
-            <a:off x="1124712" y="3547872"/>
-            <a:ext cx="2912364" cy="502920"/>
-          </a:xfrm>
-          <a:prstGeom prst="rect">
-            <a:avLst/>
-          </a:prstGeom>
-          <a:noFill/>
-        </p:spPr>
-        <p:txBody>
-          <a:bodyPr wrap="square" lIns="0" rIns="0" tIns="0" bIns="0" anchor="t">
+          <p:cNvPr id="19" name="TextBox 18"/>
+          <p:cNvSpPr txBox="1"/>
+          <p:nvPr/>
+        </p:nvSpPr>
+        <p:spPr>
+          <a:xfrm>
+            <a:off x="4800600" y="2798064"/>
+            <a:ext cx="4663440" cy="365760"/>
+          </a:xfrm>
+          <a:prstGeom prst="rect">
+            <a:avLst/>
+          </a:prstGeom>
+          <a:noFill/>
+        </p:spPr>
+        <p:txBody>
+          <a:bodyPr wrap="square" lIns="0" rIns="0" tIns="0" bIns="0" anchor="ctr">
             <a:spAutoFit/>
           </a:bodyPr>
           <a:lstStyle/>
           <a:p>
             <a:pPr algn="l"/>
             <a:r>
-              <a:rPr sz="1200" b="0">
+              <a:rPr sz="1400" b="0">
                 <a:solidFill>
                   <a:srgbClr val="572D26"/>
                 </a:solidFill>
@@ -10919,14 +10963,58 @@
       </p:sp>
       <p:sp>
         <p:nvSpPr>
-          <p:cNvPr id="19" name="TextBox 18"/>
-          <p:cNvSpPr txBox="1"/>
-          <p:nvPr/>
-        </p:nvSpPr>
-        <p:spPr>
-          <a:xfrm>
-            <a:off x="4311396" y="2926080"/>
-            <a:ext cx="237744" cy="411480"/>
+          <p:cNvPr id="20" name="Oval 19"/>
+          <p:cNvSpPr/>
+          <p:nvPr/>
+        </p:nvSpPr>
+        <p:spPr>
+          <a:xfrm>
+            <a:off x="1188720" y="3794760"/>
+            <a:ext cx="566928" cy="566928"/>
+          </a:xfrm>
+          <a:prstGeom prst="ellipse">
+            <a:avLst/>
+          </a:prstGeom>
+          <a:solidFill>
+            <a:srgbClr val="FF3C00"/>
+          </a:solidFill>
+          <a:ln>
+            <a:noFill/>
+          </a:ln>
+          <a:effectLst/>
+        </p:spPr>
+        <p:style>
+          <a:lnRef idx="1">
+            <a:schemeClr val="accent1"/>
+          </a:lnRef>
+          <a:fillRef idx="3">
+            <a:schemeClr val="accent1"/>
+          </a:fillRef>
+          <a:effectRef idx="2">
+            <a:schemeClr val="accent1"/>
+          </a:effectRef>
+          <a:fontRef idx="minor">
+            <a:schemeClr val="lt1"/>
+          </a:fontRef>
+        </p:style>
+        <p:txBody>
+          <a:bodyPr rtlCol="0" anchor="ctr"/>
+          <a:lstStyle/>
+          <a:p>
+            <a:pPr algn="ctr"/>
+          </a:p>
+        </p:txBody>
+      </p:sp>
+      <p:sp>
+        <p:nvSpPr>
+          <p:cNvPr id="21" name="TextBox 20"/>
+          <p:cNvSpPr txBox="1"/>
+          <p:nvPr/>
+        </p:nvSpPr>
+        <p:spPr>
+          <a:xfrm>
+            <a:off x="1188720" y="3794760"/>
+            <a:ext cx="566928" cy="566928"/>
           </a:xfrm>
           <a:prstGeom prst="rect">
             <a:avLst/>
@@ -10943,27 +11031,411 @@
             <a:r>
               <a:rPr sz="1800" b="1">
                 <a:solidFill>
-                  <a:srgbClr val="FF3C00"/>
+                  <a:srgbClr val="FFFFFF"/>
                 </a:solidFill>
                 <a:latin typeface="Arial"/>
                 <a:ea typeface="Arial"/>
                 <a:cs typeface="Arial"/>
               </a:rPr>
-              <a:t>→</a:t>
-            </a:r>
-          </a:p>
-        </p:txBody>
-      </p:sp>
-      <p:sp>
-        <p:nvSpPr>
-          <p:cNvPr id="20" name="Rounded Rectangle 19"/>
+              <a:t>2</a:t>
+            </a:r>
+          </a:p>
+        </p:txBody>
+      </p:sp>
+      <p:sp>
+        <p:nvSpPr>
+          <p:cNvPr id="22" name="TextBox 21"/>
+          <p:cNvSpPr txBox="1"/>
+          <p:nvPr/>
+        </p:nvSpPr>
+        <p:spPr>
+          <a:xfrm>
+            <a:off x="1965960" y="3813048"/>
+            <a:ext cx="2743200" cy="365760"/>
+          </a:xfrm>
+          <a:prstGeom prst="rect">
+            <a:avLst/>
+          </a:prstGeom>
+          <a:noFill/>
+        </p:spPr>
+        <p:txBody>
+          <a:bodyPr wrap="square" lIns="0" rIns="0" tIns="0" bIns="0" anchor="ctr">
+            <a:spAutoFit/>
+          </a:bodyPr>
+          <a:lstStyle/>
+          <a:p>
+            <a:pPr algn="l"/>
+            <a:r>
+              <a:rPr sz="1800" b="1">
+                <a:solidFill>
+                  <a:srgbClr val="572D26"/>
+                </a:solidFill>
+                <a:latin typeface="微软雅黑"/>
+                <a:ea typeface="微软雅黑"/>
+                <a:cs typeface="微软雅黑"/>
+              </a:rPr>
+              <a:t>目标线程</a:t>
+            </a:r>
+          </a:p>
+        </p:txBody>
+      </p:sp>
+      <p:sp>
+        <p:nvSpPr>
+          <p:cNvPr id="23" name="TextBox 22"/>
+          <p:cNvSpPr txBox="1"/>
+          <p:nvPr/>
+        </p:nvSpPr>
+        <p:spPr>
+          <a:xfrm>
+            <a:off x="4800600" y="3849624"/>
+            <a:ext cx="4663440" cy="365760"/>
+          </a:xfrm>
+          <a:prstGeom prst="rect">
+            <a:avLst/>
+          </a:prstGeom>
+          <a:noFill/>
+        </p:spPr>
+        <p:txBody>
+          <a:bodyPr wrap="square" lIns="0" rIns="0" tIns="0" bIns="0" anchor="ctr">
+            <a:spAutoFit/>
+          </a:bodyPr>
+          <a:lstStyle/>
+          <a:p>
+            <a:pPr algn="l"/>
+            <a:r>
+              <a:rPr sz="1400" b="0">
+                <a:solidFill>
+                  <a:srgbClr val="572D26"/>
+                </a:solidFill>
+                <a:latin typeface="微软雅黑"/>
+                <a:ea typeface="微软雅黑"/>
+                <a:cs typeface="微软雅黑"/>
+              </a:rPr>
+              <a:t>比较各线程 On-CPU 时间</a:t>
+            </a:r>
+          </a:p>
+        </p:txBody>
+      </p:sp>
+      <p:sp>
+        <p:nvSpPr>
+          <p:cNvPr id="24" name="Oval 23"/>
           <p:cNvSpPr/>
           <p:nvPr/>
         </p:nvSpPr>
         <p:spPr>
           <a:xfrm>
-            <a:off x="4567428" y="2240280"/>
-            <a:ext cx="3424428" cy="1874519"/>
+            <a:off x="1188720" y="4846320"/>
+            <a:ext cx="566928" cy="566928"/>
+          </a:xfrm>
+          <a:prstGeom prst="ellipse">
+            <a:avLst/>
+          </a:prstGeom>
+          <a:solidFill>
+            <a:srgbClr val="FF3C00"/>
+          </a:solidFill>
+          <a:ln>
+            <a:noFill/>
+          </a:ln>
+          <a:effectLst/>
+        </p:spPr>
+        <p:style>
+          <a:lnRef idx="1">
+            <a:schemeClr val="accent1"/>
+          </a:lnRef>
+          <a:fillRef idx="3">
+            <a:schemeClr val="accent1"/>
+          </a:fillRef>
+          <a:effectRef idx="2">
+            <a:schemeClr val="accent1"/>
+          </a:effectRef>
+          <a:fontRef idx="minor">
+            <a:schemeClr val="lt1"/>
+          </a:fontRef>
+        </p:style>
+        <p:txBody>
+          <a:bodyPr rtlCol="0" anchor="ctr"/>
+          <a:lstStyle/>
+          <a:p>
+            <a:pPr algn="ctr"/>
+          </a:p>
+        </p:txBody>
+      </p:sp>
+      <p:sp>
+        <p:nvSpPr>
+          <p:cNvPr id="25" name="TextBox 24"/>
+          <p:cNvSpPr txBox="1"/>
+          <p:nvPr/>
+        </p:nvSpPr>
+        <p:spPr>
+          <a:xfrm>
+            <a:off x="1188720" y="4846320"/>
+            <a:ext cx="566928" cy="566928"/>
+          </a:xfrm>
+          <a:prstGeom prst="rect">
+            <a:avLst/>
+          </a:prstGeom>
+          <a:noFill/>
+        </p:spPr>
+        <p:txBody>
+          <a:bodyPr wrap="square" lIns="0" rIns="0" tIns="0" bIns="0" anchor="ctr">
+            <a:spAutoFit/>
+          </a:bodyPr>
+          <a:lstStyle/>
+          <a:p>
+            <a:pPr algn="ctr"/>
+            <a:r>
+              <a:rPr sz="1800" b="1">
+                <a:solidFill>
+                  <a:srgbClr val="FFFFFF"/>
+                </a:solidFill>
+                <a:latin typeface="Arial"/>
+                <a:ea typeface="Arial"/>
+                <a:cs typeface="Arial"/>
+              </a:rPr>
+              <a:t>3</a:t>
+            </a:r>
+          </a:p>
+        </p:txBody>
+      </p:sp>
+      <p:sp>
+        <p:nvSpPr>
+          <p:cNvPr id="26" name="TextBox 25"/>
+          <p:cNvSpPr txBox="1"/>
+          <p:nvPr/>
+        </p:nvSpPr>
+        <p:spPr>
+          <a:xfrm>
+            <a:off x="1965960" y="4864607"/>
+            <a:ext cx="2743200" cy="365760"/>
+          </a:xfrm>
+          <a:prstGeom prst="rect">
+            <a:avLst/>
+          </a:prstGeom>
+          <a:noFill/>
+        </p:spPr>
+        <p:txBody>
+          <a:bodyPr wrap="square" lIns="0" rIns="0" tIns="0" bIns="0" anchor="ctr">
+            <a:spAutoFit/>
+          </a:bodyPr>
+          <a:lstStyle/>
+          <a:p>
+            <a:pPr algn="l"/>
+            <a:r>
+              <a:rPr sz="1800" b="1">
+                <a:solidFill>
+                  <a:srgbClr val="572D26"/>
+                </a:solidFill>
+                <a:latin typeface="微软雅黑"/>
+                <a:ea typeface="微软雅黑"/>
+                <a:cs typeface="微软雅黑"/>
+              </a:rPr>
+              <a:t>调用栈</a:t>
+            </a:r>
+          </a:p>
+        </p:txBody>
+      </p:sp>
+      <p:sp>
+        <p:nvSpPr>
+          <p:cNvPr id="27" name="TextBox 26"/>
+          <p:cNvSpPr txBox="1"/>
+          <p:nvPr/>
+        </p:nvSpPr>
+        <p:spPr>
+          <a:xfrm>
+            <a:off x="4800600" y="4901183"/>
+            <a:ext cx="4663440" cy="365760"/>
+          </a:xfrm>
+          <a:prstGeom prst="rect">
+            <a:avLst/>
+          </a:prstGeom>
+          <a:noFill/>
+        </p:spPr>
+        <p:txBody>
+          <a:bodyPr wrap="square" lIns="0" rIns="0" tIns="0" bIns="0" anchor="ctr">
+            <a:spAutoFit/>
+          </a:bodyPr>
+          <a:lstStyle/>
+          <a:p>
+            <a:pPr algn="l"/>
+            <a:r>
+              <a:rPr sz="1400" b="0">
+                <a:solidFill>
+                  <a:srgbClr val="572D26"/>
+                </a:solidFill>
+                <a:latin typeface="微软雅黑"/>
+                <a:ea typeface="微软雅黑"/>
+                <a:cs typeface="微软雅黑"/>
+              </a:rPr>
+              <a:t>识别采样热点与函数路径</a:t>
+            </a:r>
+          </a:p>
+        </p:txBody>
+      </p:sp>
+      <p:sp>
+        <p:nvSpPr>
+          <p:cNvPr id="28" name="Oval 27"/>
+          <p:cNvSpPr/>
+          <p:nvPr/>
+        </p:nvSpPr>
+        <p:spPr>
+          <a:xfrm>
+            <a:off x="1188720" y="5897879"/>
+            <a:ext cx="566928" cy="566928"/>
+          </a:xfrm>
+          <a:prstGeom prst="ellipse">
+            <a:avLst/>
+          </a:prstGeom>
+          <a:solidFill>
+            <a:srgbClr val="FF3C00"/>
+          </a:solidFill>
+          <a:ln>
+            <a:noFill/>
+          </a:ln>
+          <a:effectLst/>
+        </p:spPr>
+        <p:style>
+          <a:lnRef idx="1">
+            <a:schemeClr val="accent1"/>
+          </a:lnRef>
+          <a:fillRef idx="3">
+            <a:schemeClr val="accent1"/>
+          </a:fillRef>
+          <a:effectRef idx="2">
+            <a:schemeClr val="accent1"/>
+          </a:effectRef>
+          <a:fontRef idx="minor">
+            <a:schemeClr val="lt1"/>
+          </a:fontRef>
+        </p:style>
+        <p:txBody>
+          <a:bodyPr rtlCol="0" anchor="ctr"/>
+          <a:lstStyle/>
+          <a:p>
+            <a:pPr algn="ctr"/>
+          </a:p>
+        </p:txBody>
+      </p:sp>
+      <p:sp>
+        <p:nvSpPr>
+          <p:cNvPr id="29" name="TextBox 28"/>
+          <p:cNvSpPr txBox="1"/>
+          <p:nvPr/>
+        </p:nvSpPr>
+        <p:spPr>
+          <a:xfrm>
+            <a:off x="1188720" y="5897879"/>
+            <a:ext cx="566928" cy="566928"/>
+          </a:xfrm>
+          <a:prstGeom prst="rect">
+            <a:avLst/>
+          </a:prstGeom>
+          <a:noFill/>
+        </p:spPr>
+        <p:txBody>
+          <a:bodyPr wrap="square" lIns="0" rIns="0" tIns="0" bIns="0" anchor="ctr">
+            <a:spAutoFit/>
+          </a:bodyPr>
+          <a:lstStyle/>
+          <a:p>
+            <a:pPr algn="ctr"/>
+            <a:r>
+              <a:rPr sz="1800" b="1">
+                <a:solidFill>
+                  <a:srgbClr val="FFFFFF"/>
+                </a:solidFill>
+                <a:latin typeface="Arial"/>
+                <a:ea typeface="Arial"/>
+                <a:cs typeface="Arial"/>
+              </a:rPr>
+              <a:t>4</a:t>
+            </a:r>
+          </a:p>
+        </p:txBody>
+      </p:sp>
+      <p:sp>
+        <p:nvSpPr>
+          <p:cNvPr id="30" name="TextBox 29"/>
+          <p:cNvSpPr txBox="1"/>
+          <p:nvPr/>
+        </p:nvSpPr>
+        <p:spPr>
+          <a:xfrm>
+            <a:off x="1965960" y="5916167"/>
+            <a:ext cx="2743200" cy="365760"/>
+          </a:xfrm>
+          <a:prstGeom prst="rect">
+            <a:avLst/>
+          </a:prstGeom>
+          <a:noFill/>
+        </p:spPr>
+        <p:txBody>
+          <a:bodyPr wrap="square" lIns="0" rIns="0" tIns="0" bIns="0" anchor="ctr">
+            <a:spAutoFit/>
+          </a:bodyPr>
+          <a:lstStyle/>
+          <a:p>
+            <a:pPr algn="l"/>
+            <a:r>
+              <a:rPr sz="1800" b="1">
+                <a:solidFill>
+                  <a:srgbClr val="572D26"/>
+                </a:solidFill>
+                <a:latin typeface="微软雅黑"/>
+                <a:ea typeface="微软雅黑"/>
+                <a:cs typeface="微软雅黑"/>
+              </a:rPr>
+              <a:t>源码验证</a:t>
+            </a:r>
+          </a:p>
+        </p:txBody>
+      </p:sp>
+      <p:sp>
+        <p:nvSpPr>
+          <p:cNvPr id="31" name="TextBox 30"/>
+          <p:cNvSpPr txBox="1"/>
+          <p:nvPr/>
+        </p:nvSpPr>
+        <p:spPr>
+          <a:xfrm>
+            <a:off x="4800600" y="5952743"/>
+            <a:ext cx="4663440" cy="365760"/>
+          </a:xfrm>
+          <a:prstGeom prst="rect">
+            <a:avLst/>
+          </a:prstGeom>
+          <a:noFill/>
+        </p:spPr>
+        <p:txBody>
+          <a:bodyPr wrap="square" lIns="0" rIns="0" tIns="0" bIns="0" anchor="ctr">
+            <a:spAutoFit/>
+          </a:bodyPr>
+          <a:lstStyle/>
+          <a:p>
+            <a:pPr algn="l"/>
+            <a:r>
+              <a:rPr sz="1400" b="0">
+                <a:solidFill>
+                  <a:srgbClr val="572D26"/>
+                </a:solidFill>
+                <a:latin typeface="微软雅黑"/>
+                <a:ea typeface="微软雅黑"/>
+                <a:cs typeface="微软雅黑"/>
+              </a:rPr>
+              <a:t>核对与实际调用逻辑一致</a:t>
+            </a:r>
+          </a:p>
+        </p:txBody>
+      </p:sp>
+      <p:sp>
+        <p:nvSpPr>
+          <p:cNvPr id="32" name="Rounded Rectangle 31"/>
+          <p:cNvSpPr/>
+          <p:nvPr/>
+        </p:nvSpPr>
+        <p:spPr>
+          <a:xfrm>
+            <a:off x="10012680" y="1828800"/>
+            <a:ext cx="5376672" cy="5760720"/>
           </a:xfrm>
           <a:prstGeom prst="roundRect">
             <a:avLst>
@@ -11002,95 +11474,88 @@
       </p:sp>
       <p:sp>
         <p:nvSpPr>
-          <p:cNvPr id="21" name="Oval 20"/>
-          <p:cNvSpPr/>
-          <p:nvPr/>
-        </p:nvSpPr>
-        <p:spPr>
-          <a:xfrm>
-            <a:off x="4823460" y="2450592"/>
-            <a:ext cx="566928" cy="566928"/>
-          </a:xfrm>
-          <a:prstGeom prst="ellipse">
-            <a:avLst/>
-          </a:prstGeom>
-          <a:solidFill>
-            <a:srgbClr val="FF3C00"/>
-          </a:solidFill>
-          <a:ln>
-            <a:noFill/>
-          </a:ln>
-          <a:effectLst/>
-        </p:spPr>
-        <p:style>
-          <a:lnRef idx="1">
-            <a:schemeClr val="accent1"/>
-          </a:lnRef>
-          <a:fillRef idx="3">
-            <a:schemeClr val="accent1"/>
-          </a:fillRef>
-          <a:effectRef idx="2">
-            <a:schemeClr val="accent1"/>
-          </a:effectRef>
-          <a:fontRef idx="minor">
-            <a:schemeClr val="lt1"/>
-          </a:fontRef>
-        </p:style>
-        <p:txBody>
-          <a:bodyPr rtlCol="0" anchor="ctr"/>
-          <a:lstStyle/>
-          <a:p>
-            <a:pPr algn="ctr"/>
-          </a:p>
-        </p:txBody>
-      </p:sp>
-      <p:sp>
-        <p:nvSpPr>
-          <p:cNvPr id="22" name="TextBox 21"/>
-          <p:cNvSpPr txBox="1"/>
-          <p:nvPr/>
-        </p:nvSpPr>
-        <p:spPr>
-          <a:xfrm>
-            <a:off x="4823460" y="2450592"/>
-            <a:ext cx="566928" cy="566928"/>
-          </a:xfrm>
-          <a:prstGeom prst="rect">
-            <a:avLst/>
-          </a:prstGeom>
-          <a:noFill/>
-        </p:spPr>
-        <p:txBody>
-          <a:bodyPr wrap="square" lIns="0" rIns="0" tIns="0" bIns="0" anchor="ctr">
-            <a:spAutoFit/>
-          </a:bodyPr>
-          <a:lstStyle/>
-          <a:p>
-            <a:pPr algn="ctr"/>
+          <p:cNvPr id="33" name="TextBox 32"/>
+          <p:cNvSpPr txBox="1"/>
+          <p:nvPr/>
+        </p:nvSpPr>
+        <p:spPr>
+          <a:xfrm>
+            <a:off x="10332720" y="2084831"/>
+            <a:ext cx="4754880" cy="365760"/>
+          </a:xfrm>
+          <a:prstGeom prst="rect">
+            <a:avLst/>
+          </a:prstGeom>
+          <a:noFill/>
+        </p:spPr>
+        <p:txBody>
+          <a:bodyPr wrap="square" lIns="0" rIns="0" tIns="0" bIns="0" anchor="t">
+            <a:spAutoFit/>
+          </a:bodyPr>
+          <a:lstStyle/>
+          <a:p>
+            <a:pPr algn="l"/>
+            <a:r>
+              <a:rPr sz="2100" b="1">
+                <a:solidFill>
+                  <a:srgbClr val="FF3C00"/>
+                </a:solidFill>
+                <a:latin typeface="微软雅黑"/>
+                <a:ea typeface="微软雅黑"/>
+                <a:cs typeface="微软雅黑"/>
+              </a:rPr>
+              <a:t>常见输出</a:t>
+            </a:r>
+          </a:p>
+        </p:txBody>
+      </p:sp>
+      <p:sp>
+        <p:nvSpPr>
+          <p:cNvPr id="34" name="TextBox 33"/>
+          <p:cNvSpPr txBox="1"/>
+          <p:nvPr/>
+        </p:nvSpPr>
+        <p:spPr>
+          <a:xfrm>
+            <a:off x="10332720" y="2788920"/>
+            <a:ext cx="4754880" cy="365760"/>
+          </a:xfrm>
+          <a:prstGeom prst="rect">
+            <a:avLst/>
+          </a:prstGeom>
+          <a:noFill/>
+        </p:spPr>
+        <p:txBody>
+          <a:bodyPr wrap="square" lIns="0" rIns="0" tIns="0" bIns="0" anchor="t">
+            <a:spAutoFit/>
+          </a:bodyPr>
+          <a:lstStyle/>
+          <a:p>
+            <a:pPr algn="l"/>
             <a:r>
               <a:rPr sz="1800" b="1">
                 <a:solidFill>
-                  <a:srgbClr val="FFFFFF"/>
-                </a:solidFill>
-                <a:latin typeface="Arial"/>
-                <a:ea typeface="Arial"/>
-                <a:cs typeface="Arial"/>
-              </a:rPr>
-              <a:t>2</a:t>
-            </a:r>
-          </a:p>
-        </p:txBody>
-      </p:sp>
-      <p:sp>
-        <p:nvSpPr>
-          <p:cNvPr id="23" name="TextBox 22"/>
-          <p:cNvSpPr txBox="1"/>
-          <p:nvPr/>
-        </p:nvSpPr>
-        <p:spPr>
-          <a:xfrm>
-            <a:off x="4823460" y="3145536"/>
-            <a:ext cx="2912364" cy="365760"/>
+                  <a:srgbClr val="572D26"/>
+                </a:solidFill>
+                <a:latin typeface="微软雅黑"/>
+                <a:ea typeface="微软雅黑"/>
+                <a:cs typeface="微软雅黑"/>
+              </a:rPr>
+              <a:t>热点线程</a:t>
+            </a:r>
+          </a:p>
+        </p:txBody>
+      </p:sp>
+      <p:sp>
+        <p:nvSpPr>
+          <p:cNvPr id="35" name="TextBox 34"/>
+          <p:cNvSpPr txBox="1"/>
+          <p:nvPr/>
+        </p:nvSpPr>
+        <p:spPr>
+          <a:xfrm>
+            <a:off x="10332720" y="3246120"/>
+            <a:ext cx="4754880" cy="365760"/>
           </a:xfrm>
           <a:prstGeom prst="rect">
             <a:avLst/>
@@ -11105,6 +11570,43 @@
           <a:p>
             <a:pPr algn="l"/>
             <a:r>
+              <a:rPr sz="1400" b="0">
+                <a:solidFill>
+                  <a:srgbClr val="9A8578"/>
+                </a:solidFill>
+                <a:latin typeface="微软雅黑"/>
+                <a:ea typeface="微软雅黑"/>
+                <a:cs typeface="微软雅黑"/>
+              </a:rPr>
+              <a:t>谁的 CPU 时间最多</a:t>
+            </a:r>
+          </a:p>
+        </p:txBody>
+      </p:sp>
+      <p:sp>
+        <p:nvSpPr>
+          <p:cNvPr id="36" name="TextBox 35"/>
+          <p:cNvSpPr txBox="1"/>
+          <p:nvPr/>
+        </p:nvSpPr>
+        <p:spPr>
+          <a:xfrm>
+            <a:off x="10332720" y="4297679"/>
+            <a:ext cx="4754880" cy="365760"/>
+          </a:xfrm>
+          <a:prstGeom prst="rect">
+            <a:avLst/>
+          </a:prstGeom>
+          <a:noFill/>
+        </p:spPr>
+        <p:txBody>
+          <a:bodyPr wrap="square" lIns="0" rIns="0" tIns="0" bIns="0" anchor="t">
+            <a:spAutoFit/>
+          </a:bodyPr>
+          <a:lstStyle/>
+          <a:p>
+            <a:pPr algn="l"/>
+            <a:r>
               <a:rPr sz="1800" b="1">
                 <a:solidFill>
                   <a:srgbClr val="572D26"/>
@@ -11113,21 +11615,21 @@
                 <a:ea typeface="微软雅黑"/>
                 <a:cs typeface="微软雅黑"/>
               </a:rPr>
-              <a:t>目标线程</a:t>
-            </a:r>
-          </a:p>
-        </p:txBody>
-      </p:sp>
-      <p:sp>
-        <p:nvSpPr>
-          <p:cNvPr id="24" name="TextBox 23"/>
-          <p:cNvSpPr txBox="1"/>
-          <p:nvPr/>
-        </p:nvSpPr>
-        <p:spPr>
-          <a:xfrm>
-            <a:off x="4823460" y="3547872"/>
-            <a:ext cx="2912364" cy="502920"/>
+              <a:t>热点函数</a:t>
+            </a:r>
+          </a:p>
+        </p:txBody>
+      </p:sp>
+      <p:sp>
+        <p:nvSpPr>
+          <p:cNvPr id="37" name="TextBox 36"/>
+          <p:cNvSpPr txBox="1"/>
+          <p:nvPr/>
+        </p:nvSpPr>
+        <p:spPr>
+          <a:xfrm>
+            <a:off x="10332720" y="4754879"/>
+            <a:ext cx="4754880" cy="365760"/>
           </a:xfrm>
           <a:prstGeom prst="rect">
             <a:avLst/>
@@ -11142,7 +11644,44 @@
           <a:p>
             <a:pPr algn="l"/>
             <a:r>
-              <a:rPr sz="1200" b="0">
+              <a:rPr sz="1400" b="0">
+                <a:solidFill>
+                  <a:srgbClr val="9A8578"/>
+                </a:solidFill>
+                <a:latin typeface="微软雅黑"/>
+                <a:ea typeface="微软雅黑"/>
+                <a:cs typeface="微软雅黑"/>
+              </a:rPr>
+              <a:t>哪个函数 / 调用路径占比高</a:t>
+            </a:r>
+          </a:p>
+        </p:txBody>
+      </p:sp>
+      <p:sp>
+        <p:nvSpPr>
+          <p:cNvPr id="38" name="TextBox 37"/>
+          <p:cNvSpPr txBox="1"/>
+          <p:nvPr/>
+        </p:nvSpPr>
+        <p:spPr>
+          <a:xfrm>
+            <a:off x="10332720" y="5806440"/>
+            <a:ext cx="4754880" cy="365760"/>
+          </a:xfrm>
+          <a:prstGeom prst="rect">
+            <a:avLst/>
+          </a:prstGeom>
+          <a:noFill/>
+        </p:spPr>
+        <p:txBody>
+          <a:bodyPr wrap="square" lIns="0" rIns="0" tIns="0" bIns="0" anchor="t">
+            <a:spAutoFit/>
+          </a:bodyPr>
+          <a:lstStyle/>
+          <a:p>
+            <a:pPr algn="l"/>
+            <a:r>
+              <a:rPr sz="1800" b="1">
                 <a:solidFill>
                   <a:srgbClr val="572D26"/>
                 </a:solidFill>
@@ -11150,185 +11689,21 @@
                 <a:ea typeface="微软雅黑"/>
                 <a:cs typeface="微软雅黑"/>
               </a:rPr>
-              <a:t>比较各线程 On-CPU 时间</a:t>
-            </a:r>
-          </a:p>
-        </p:txBody>
-      </p:sp>
-      <p:sp>
-        <p:nvSpPr>
-          <p:cNvPr id="25" name="TextBox 24"/>
-          <p:cNvSpPr txBox="1"/>
-          <p:nvPr/>
-        </p:nvSpPr>
-        <p:spPr>
-          <a:xfrm>
-            <a:off x="8010144" y="2926080"/>
-            <a:ext cx="237744" cy="411480"/>
-          </a:xfrm>
-          <a:prstGeom prst="rect">
-            <a:avLst/>
-          </a:prstGeom>
-          <a:noFill/>
-        </p:spPr>
-        <p:txBody>
-          <a:bodyPr wrap="square" lIns="0" rIns="0" tIns="0" bIns="0" anchor="ctr">
-            <a:spAutoFit/>
-          </a:bodyPr>
-          <a:lstStyle/>
-          <a:p>
-            <a:pPr algn="ctr"/>
-            <a:r>
-              <a:rPr sz="1800" b="1">
-                <a:solidFill>
-                  <a:srgbClr val="FF3C00"/>
-                </a:solidFill>
-                <a:latin typeface="Arial"/>
-                <a:ea typeface="Arial"/>
-                <a:cs typeface="Arial"/>
-              </a:rPr>
-              <a:t>→</a:t>
-            </a:r>
-          </a:p>
-        </p:txBody>
-      </p:sp>
-      <p:sp>
-        <p:nvSpPr>
-          <p:cNvPr id="26" name="Rounded Rectangle 25"/>
-          <p:cNvSpPr/>
-          <p:nvPr/>
-        </p:nvSpPr>
-        <p:spPr>
-          <a:xfrm>
-            <a:off x="8266175" y="2240280"/>
-            <a:ext cx="3424428" cy="1874519"/>
-          </a:xfrm>
-          <a:prstGeom prst="roundRect">
-            <a:avLst>
-              <a:gd name="adj" fmla="val 8000"/>
-            </a:avLst>
-          </a:prstGeom>
-          <a:solidFill>
-            <a:srgbClr val="FFF9F3"/>
-          </a:solidFill>
-          <a:ln>
-            <a:noFill/>
-          </a:ln>
-          <a:effectLst/>
-        </p:spPr>
-        <p:style>
-          <a:lnRef idx="1">
-            <a:schemeClr val="accent1"/>
-          </a:lnRef>
-          <a:fillRef idx="3">
-            <a:schemeClr val="accent1"/>
-          </a:fillRef>
-          <a:effectRef idx="2">
-            <a:schemeClr val="accent1"/>
-          </a:effectRef>
-          <a:fontRef idx="minor">
-            <a:schemeClr val="lt1"/>
-          </a:fontRef>
-        </p:style>
-        <p:txBody>
-          <a:bodyPr rtlCol="0" anchor="ctr"/>
-          <a:lstStyle/>
-          <a:p>
-            <a:pPr algn="ctr"/>
-          </a:p>
-        </p:txBody>
-      </p:sp>
-      <p:sp>
-        <p:nvSpPr>
-          <p:cNvPr id="27" name="Oval 26"/>
-          <p:cNvSpPr/>
-          <p:nvPr/>
-        </p:nvSpPr>
-        <p:spPr>
-          <a:xfrm>
-            <a:off x="8522207" y="2450592"/>
-            <a:ext cx="566928" cy="566928"/>
-          </a:xfrm>
-          <a:prstGeom prst="ellipse">
-            <a:avLst/>
-          </a:prstGeom>
-          <a:solidFill>
-            <a:srgbClr val="FF3C00"/>
-          </a:solidFill>
-          <a:ln>
-            <a:noFill/>
-          </a:ln>
-          <a:effectLst/>
-        </p:spPr>
-        <p:style>
-          <a:lnRef idx="1">
-            <a:schemeClr val="accent1"/>
-          </a:lnRef>
-          <a:fillRef idx="3">
-            <a:schemeClr val="accent1"/>
-          </a:fillRef>
-          <a:effectRef idx="2">
-            <a:schemeClr val="accent1"/>
-          </a:effectRef>
-          <a:fontRef idx="minor">
-            <a:schemeClr val="lt1"/>
-          </a:fontRef>
-        </p:style>
-        <p:txBody>
-          <a:bodyPr rtlCol="0" anchor="ctr"/>
-          <a:lstStyle/>
-          <a:p>
-            <a:pPr algn="ctr"/>
-          </a:p>
-        </p:txBody>
-      </p:sp>
-      <p:sp>
-        <p:nvSpPr>
-          <p:cNvPr id="28" name="TextBox 27"/>
-          <p:cNvSpPr txBox="1"/>
-          <p:nvPr/>
-        </p:nvSpPr>
-        <p:spPr>
-          <a:xfrm>
-            <a:off x="8522207" y="2450592"/>
-            <a:ext cx="566928" cy="566928"/>
-          </a:xfrm>
-          <a:prstGeom prst="rect">
-            <a:avLst/>
-          </a:prstGeom>
-          <a:noFill/>
-        </p:spPr>
-        <p:txBody>
-          <a:bodyPr wrap="square" lIns="0" rIns="0" tIns="0" bIns="0" anchor="ctr">
-            <a:spAutoFit/>
-          </a:bodyPr>
-          <a:lstStyle/>
-          <a:p>
-            <a:pPr algn="ctr"/>
-            <a:r>
-              <a:rPr sz="1800" b="1">
-                <a:solidFill>
-                  <a:srgbClr val="FFFFFF"/>
-                </a:solidFill>
-                <a:latin typeface="Arial"/>
-                <a:ea typeface="Arial"/>
-                <a:cs typeface="Arial"/>
-              </a:rPr>
-              <a:t>3</a:t>
-            </a:r>
-          </a:p>
-        </p:txBody>
-      </p:sp>
-      <p:sp>
-        <p:nvSpPr>
-          <p:cNvPr id="29" name="TextBox 28"/>
-          <p:cNvSpPr txBox="1"/>
-          <p:nvPr/>
-        </p:nvSpPr>
-        <p:spPr>
-          <a:xfrm>
-            <a:off x="8522207" y="3145536"/>
-            <a:ext cx="2912364" cy="365760"/>
+              <a:t>异常窗口</a:t>
+            </a:r>
+          </a:p>
+        </p:txBody>
+      </p:sp>
+      <p:sp>
+        <p:nvSpPr>
+          <p:cNvPr id="39" name="TextBox 38"/>
+          <p:cNvSpPr txBox="1"/>
+          <p:nvPr/>
+        </p:nvSpPr>
+        <p:spPr>
+          <a:xfrm>
+            <a:off x="10332720" y="6263640"/>
+            <a:ext cx="4754880" cy="365760"/>
           </a:xfrm>
           <a:prstGeom prst="rect">
             <a:avLst/>
@@ -11343,681 +11718,9 @@
           <a:p>
             <a:pPr algn="l"/>
             <a:r>
-              <a:rPr sz="1800" b="1">
-                <a:solidFill>
-                  <a:srgbClr val="572D26"/>
-                </a:solidFill>
-                <a:latin typeface="微软雅黑"/>
-                <a:ea typeface="微软雅黑"/>
-                <a:cs typeface="微软雅黑"/>
-              </a:rPr>
-              <a:t>调用栈</a:t>
-            </a:r>
-          </a:p>
-        </p:txBody>
-      </p:sp>
-      <p:sp>
-        <p:nvSpPr>
-          <p:cNvPr id="30" name="TextBox 29"/>
-          <p:cNvSpPr txBox="1"/>
-          <p:nvPr/>
-        </p:nvSpPr>
-        <p:spPr>
-          <a:xfrm>
-            <a:off x="8522207" y="3547872"/>
-            <a:ext cx="2912364" cy="502920"/>
-          </a:xfrm>
-          <a:prstGeom prst="rect">
-            <a:avLst/>
-          </a:prstGeom>
-          <a:noFill/>
-        </p:spPr>
-        <p:txBody>
-          <a:bodyPr wrap="square" lIns="0" rIns="0" tIns="0" bIns="0" anchor="t">
-            <a:spAutoFit/>
-          </a:bodyPr>
-          <a:lstStyle/>
-          <a:p>
-            <a:pPr algn="l"/>
-            <a:r>
-              <a:rPr sz="1200" b="0">
-                <a:solidFill>
-                  <a:srgbClr val="572D26"/>
-                </a:solidFill>
-                <a:latin typeface="微软雅黑"/>
-                <a:ea typeface="微软雅黑"/>
-                <a:cs typeface="微软雅黑"/>
-              </a:rPr>
-              <a:t>识别采样热点与函数路径</a:t>
-            </a:r>
-          </a:p>
-        </p:txBody>
-      </p:sp>
-      <p:sp>
-        <p:nvSpPr>
-          <p:cNvPr id="31" name="TextBox 30"/>
-          <p:cNvSpPr txBox="1"/>
-          <p:nvPr/>
-        </p:nvSpPr>
-        <p:spPr>
-          <a:xfrm>
-            <a:off x="11708892" y="2926080"/>
-            <a:ext cx="237744" cy="411480"/>
-          </a:xfrm>
-          <a:prstGeom prst="rect">
-            <a:avLst/>
-          </a:prstGeom>
-          <a:noFill/>
-        </p:spPr>
-        <p:txBody>
-          <a:bodyPr wrap="square" lIns="0" rIns="0" tIns="0" bIns="0" anchor="ctr">
-            <a:spAutoFit/>
-          </a:bodyPr>
-          <a:lstStyle/>
-          <a:p>
-            <a:pPr algn="ctr"/>
-            <a:r>
-              <a:rPr sz="1800" b="1">
-                <a:solidFill>
-                  <a:srgbClr val="FF3C00"/>
-                </a:solidFill>
-                <a:latin typeface="Arial"/>
-                <a:ea typeface="Arial"/>
-                <a:cs typeface="Arial"/>
-              </a:rPr>
-              <a:t>→</a:t>
-            </a:r>
-          </a:p>
-        </p:txBody>
-      </p:sp>
-      <p:sp>
-        <p:nvSpPr>
-          <p:cNvPr id="32" name="Rounded Rectangle 31"/>
-          <p:cNvSpPr/>
-          <p:nvPr/>
-        </p:nvSpPr>
-        <p:spPr>
-          <a:xfrm>
-            <a:off x="11964924" y="2240280"/>
-            <a:ext cx="3424428" cy="1874519"/>
-          </a:xfrm>
-          <a:prstGeom prst="roundRect">
-            <a:avLst>
-              <a:gd name="adj" fmla="val 8000"/>
-            </a:avLst>
-          </a:prstGeom>
-          <a:solidFill>
-            <a:srgbClr val="FFF9F3"/>
-          </a:solidFill>
-          <a:ln>
-            <a:noFill/>
-          </a:ln>
-          <a:effectLst/>
-        </p:spPr>
-        <p:style>
-          <a:lnRef idx="1">
-            <a:schemeClr val="accent1"/>
-          </a:lnRef>
-          <a:fillRef idx="3">
-            <a:schemeClr val="accent1"/>
-          </a:fillRef>
-          <a:effectRef idx="2">
-            <a:schemeClr val="accent1"/>
-          </a:effectRef>
-          <a:fontRef idx="minor">
-            <a:schemeClr val="lt1"/>
-          </a:fontRef>
-        </p:style>
-        <p:txBody>
-          <a:bodyPr rtlCol="0" anchor="ctr"/>
-          <a:lstStyle/>
-          <a:p>
-            <a:pPr algn="ctr"/>
-          </a:p>
-        </p:txBody>
-      </p:sp>
-      <p:sp>
-        <p:nvSpPr>
-          <p:cNvPr id="33" name="Oval 32"/>
-          <p:cNvSpPr/>
-          <p:nvPr/>
-        </p:nvSpPr>
-        <p:spPr>
-          <a:xfrm>
-            <a:off x="12220955" y="2450592"/>
-            <a:ext cx="566928" cy="566928"/>
-          </a:xfrm>
-          <a:prstGeom prst="ellipse">
-            <a:avLst/>
-          </a:prstGeom>
-          <a:solidFill>
-            <a:srgbClr val="FF3C00"/>
-          </a:solidFill>
-          <a:ln>
-            <a:noFill/>
-          </a:ln>
-          <a:effectLst/>
-        </p:spPr>
-        <p:style>
-          <a:lnRef idx="1">
-            <a:schemeClr val="accent1"/>
-          </a:lnRef>
-          <a:fillRef idx="3">
-            <a:schemeClr val="accent1"/>
-          </a:fillRef>
-          <a:effectRef idx="2">
-            <a:schemeClr val="accent1"/>
-          </a:effectRef>
-          <a:fontRef idx="minor">
-            <a:schemeClr val="lt1"/>
-          </a:fontRef>
-        </p:style>
-        <p:txBody>
-          <a:bodyPr rtlCol="0" anchor="ctr"/>
-          <a:lstStyle/>
-          <a:p>
-            <a:pPr algn="ctr"/>
-          </a:p>
-        </p:txBody>
-      </p:sp>
-      <p:sp>
-        <p:nvSpPr>
-          <p:cNvPr id="34" name="TextBox 33"/>
-          <p:cNvSpPr txBox="1"/>
-          <p:nvPr/>
-        </p:nvSpPr>
-        <p:spPr>
-          <a:xfrm>
-            <a:off x="12220955" y="2450592"/>
-            <a:ext cx="566928" cy="566928"/>
-          </a:xfrm>
-          <a:prstGeom prst="rect">
-            <a:avLst/>
-          </a:prstGeom>
-          <a:noFill/>
-        </p:spPr>
-        <p:txBody>
-          <a:bodyPr wrap="square" lIns="0" rIns="0" tIns="0" bIns="0" anchor="ctr">
-            <a:spAutoFit/>
-          </a:bodyPr>
-          <a:lstStyle/>
-          <a:p>
-            <a:pPr algn="ctr"/>
-            <a:r>
-              <a:rPr sz="1800" b="1">
-                <a:solidFill>
-                  <a:srgbClr val="FFFFFF"/>
-                </a:solidFill>
-                <a:latin typeface="Arial"/>
-                <a:ea typeface="Arial"/>
-                <a:cs typeface="Arial"/>
-              </a:rPr>
-              <a:t>4</a:t>
-            </a:r>
-          </a:p>
-        </p:txBody>
-      </p:sp>
-      <p:sp>
-        <p:nvSpPr>
-          <p:cNvPr id="35" name="TextBox 34"/>
-          <p:cNvSpPr txBox="1"/>
-          <p:nvPr/>
-        </p:nvSpPr>
-        <p:spPr>
-          <a:xfrm>
-            <a:off x="12220955" y="3145536"/>
-            <a:ext cx="2912364" cy="365760"/>
-          </a:xfrm>
-          <a:prstGeom prst="rect">
-            <a:avLst/>
-          </a:prstGeom>
-          <a:noFill/>
-        </p:spPr>
-        <p:txBody>
-          <a:bodyPr wrap="square" lIns="0" rIns="0" tIns="0" bIns="0" anchor="t">
-            <a:spAutoFit/>
-          </a:bodyPr>
-          <a:lstStyle/>
-          <a:p>
-            <a:pPr algn="l"/>
-            <a:r>
-              <a:rPr sz="1800" b="1">
-                <a:solidFill>
-                  <a:srgbClr val="572D26"/>
-                </a:solidFill>
-                <a:latin typeface="微软雅黑"/>
-                <a:ea typeface="微软雅黑"/>
-                <a:cs typeface="微软雅黑"/>
-              </a:rPr>
-              <a:t>源码验证</a:t>
-            </a:r>
-          </a:p>
-        </p:txBody>
-      </p:sp>
-      <p:sp>
-        <p:nvSpPr>
-          <p:cNvPr id="36" name="TextBox 35"/>
-          <p:cNvSpPr txBox="1"/>
-          <p:nvPr/>
-        </p:nvSpPr>
-        <p:spPr>
-          <a:xfrm>
-            <a:off x="12220955" y="3547872"/>
-            <a:ext cx="2912364" cy="502920"/>
-          </a:xfrm>
-          <a:prstGeom prst="rect">
-            <a:avLst/>
-          </a:prstGeom>
-          <a:noFill/>
-        </p:spPr>
-        <p:txBody>
-          <a:bodyPr wrap="square" lIns="0" rIns="0" tIns="0" bIns="0" anchor="t">
-            <a:spAutoFit/>
-          </a:bodyPr>
-          <a:lstStyle/>
-          <a:p>
-            <a:pPr algn="l"/>
-            <a:r>
-              <a:rPr sz="1200" b="0">
-                <a:solidFill>
-                  <a:srgbClr val="572D26"/>
-                </a:solidFill>
-                <a:latin typeface="微软雅黑"/>
-                <a:ea typeface="微软雅黑"/>
-                <a:cs typeface="微软雅黑"/>
-              </a:rPr>
-              <a:t>核对与实际调用逻辑一致</a:t>
-            </a:r>
-          </a:p>
-        </p:txBody>
-      </p:sp>
-      <p:sp>
-        <p:nvSpPr>
-          <p:cNvPr id="37" name="TextBox 36"/>
-          <p:cNvSpPr txBox="1"/>
-          <p:nvPr/>
-        </p:nvSpPr>
-        <p:spPr>
-          <a:xfrm>
-            <a:off x="868680" y="4389120"/>
-            <a:ext cx="7315200" cy="320040"/>
-          </a:xfrm>
-          <a:prstGeom prst="rect">
-            <a:avLst/>
-          </a:prstGeom>
-          <a:noFill/>
-        </p:spPr>
-        <p:txBody>
-          <a:bodyPr wrap="square" lIns="0" rIns="0" tIns="0" bIns="0" anchor="t">
-            <a:spAutoFit/>
-          </a:bodyPr>
-          <a:lstStyle/>
-          <a:p>
-            <a:pPr algn="l"/>
-            <a:r>
-              <a:rPr sz="2100" b="1">
-                <a:solidFill>
-                  <a:srgbClr val="572D26"/>
-                </a:solidFill>
-                <a:latin typeface="微软雅黑"/>
-                <a:ea typeface="微软雅黑"/>
-                <a:cs typeface="微软雅黑"/>
-              </a:rPr>
-              <a:t>常见输出</a:t>
-            </a:r>
-          </a:p>
-        </p:txBody>
-      </p:sp>
-      <p:sp>
-        <p:nvSpPr>
-          <p:cNvPr id="38" name="Rounded Rectangle 37"/>
-          <p:cNvSpPr/>
-          <p:nvPr/>
-        </p:nvSpPr>
-        <p:spPr>
-          <a:xfrm>
-            <a:off x="868680" y="4800600"/>
-            <a:ext cx="4657344" cy="1965960"/>
-          </a:xfrm>
-          <a:prstGeom prst="roundRect">
-            <a:avLst>
-              <a:gd name="adj" fmla="val 8000"/>
-            </a:avLst>
-          </a:prstGeom>
-          <a:solidFill>
-            <a:srgbClr val="FFF9F3"/>
-          </a:solidFill>
-          <a:ln>
-            <a:noFill/>
-          </a:ln>
-          <a:effectLst/>
-        </p:spPr>
-        <p:style>
-          <a:lnRef idx="1">
-            <a:schemeClr val="accent1"/>
-          </a:lnRef>
-          <a:fillRef idx="3">
-            <a:schemeClr val="accent1"/>
-          </a:fillRef>
-          <a:effectRef idx="2">
-            <a:schemeClr val="accent1"/>
-          </a:effectRef>
-          <a:fontRef idx="minor">
-            <a:schemeClr val="lt1"/>
-          </a:fontRef>
-        </p:style>
-        <p:txBody>
-          <a:bodyPr rtlCol="0" anchor="ctr"/>
-          <a:lstStyle/>
-          <a:p>
-            <a:pPr algn="ctr"/>
-          </a:p>
-        </p:txBody>
-      </p:sp>
-      <p:sp>
-        <p:nvSpPr>
-          <p:cNvPr id="39" name="TextBox 38"/>
-          <p:cNvSpPr txBox="1"/>
-          <p:nvPr/>
-        </p:nvSpPr>
-        <p:spPr>
-          <a:xfrm>
-            <a:off x="1143000" y="5047488"/>
-            <a:ext cx="4108704" cy="365760"/>
-          </a:xfrm>
-          <a:prstGeom prst="rect">
-            <a:avLst/>
-          </a:prstGeom>
-          <a:noFill/>
-        </p:spPr>
-        <p:txBody>
-          <a:bodyPr wrap="square" lIns="0" rIns="0" tIns="0" bIns="0" anchor="t">
-            <a:spAutoFit/>
-          </a:bodyPr>
-          <a:lstStyle/>
-          <a:p>
-            <a:pPr algn="l"/>
-            <a:r>
-              <a:rPr sz="1800" b="1">
-                <a:solidFill>
-                  <a:srgbClr val="FF3C00"/>
-                </a:solidFill>
-                <a:latin typeface="微软雅黑"/>
-                <a:ea typeface="微软雅黑"/>
-                <a:cs typeface="微软雅黑"/>
-              </a:rPr>
-              <a:t>热点线程</a:t>
-            </a:r>
-          </a:p>
-        </p:txBody>
-      </p:sp>
-      <p:sp>
-        <p:nvSpPr>
-          <p:cNvPr id="40" name="TextBox 39"/>
-          <p:cNvSpPr txBox="1"/>
-          <p:nvPr/>
-        </p:nvSpPr>
-        <p:spPr>
-          <a:xfrm>
-            <a:off x="1143000" y="5504688"/>
-            <a:ext cx="4108704" cy="822960"/>
-          </a:xfrm>
-          <a:prstGeom prst="rect">
-            <a:avLst/>
-          </a:prstGeom>
-          <a:noFill/>
-        </p:spPr>
-        <p:txBody>
-          <a:bodyPr wrap="square" lIns="0" rIns="0" tIns="0" bIns="0" anchor="t">
-            <a:spAutoFit/>
-          </a:bodyPr>
-          <a:lstStyle/>
-          <a:p>
-            <a:pPr algn="l"/>
-            <a:r>
               <a:rPr sz="1400" b="0">
                 <a:solidFill>
-                  <a:srgbClr val="572D26"/>
-                </a:solidFill>
-                <a:latin typeface="微软雅黑"/>
-                <a:ea typeface="微软雅黑"/>
-                <a:cs typeface="微软雅黑"/>
-              </a:rPr>
-              <a:t>谁的 CPU 时间最多</a:t>
-            </a:r>
-          </a:p>
-        </p:txBody>
-      </p:sp>
-      <p:sp>
-        <p:nvSpPr>
-          <p:cNvPr id="41" name="Rounded Rectangle 40"/>
-          <p:cNvSpPr/>
-          <p:nvPr/>
-        </p:nvSpPr>
-        <p:spPr>
-          <a:xfrm>
-            <a:off x="5800344" y="4800600"/>
-            <a:ext cx="4657344" cy="1965960"/>
-          </a:xfrm>
-          <a:prstGeom prst="roundRect">
-            <a:avLst>
-              <a:gd name="adj" fmla="val 8000"/>
-            </a:avLst>
-          </a:prstGeom>
-          <a:solidFill>
-            <a:srgbClr val="FFF9F3"/>
-          </a:solidFill>
-          <a:ln>
-            <a:noFill/>
-          </a:ln>
-          <a:effectLst/>
-        </p:spPr>
-        <p:style>
-          <a:lnRef idx="1">
-            <a:schemeClr val="accent1"/>
-          </a:lnRef>
-          <a:fillRef idx="3">
-            <a:schemeClr val="accent1"/>
-          </a:fillRef>
-          <a:effectRef idx="2">
-            <a:schemeClr val="accent1"/>
-          </a:effectRef>
-          <a:fontRef idx="minor">
-            <a:schemeClr val="lt1"/>
-          </a:fontRef>
-        </p:style>
-        <p:txBody>
-          <a:bodyPr rtlCol="0" anchor="ctr"/>
-          <a:lstStyle/>
-          <a:p>
-            <a:pPr algn="ctr"/>
-          </a:p>
-        </p:txBody>
-      </p:sp>
-      <p:sp>
-        <p:nvSpPr>
-          <p:cNvPr id="42" name="TextBox 41"/>
-          <p:cNvSpPr txBox="1"/>
-          <p:nvPr/>
-        </p:nvSpPr>
-        <p:spPr>
-          <a:xfrm>
-            <a:off x="6074664" y="5047488"/>
-            <a:ext cx="4108704" cy="365760"/>
-          </a:xfrm>
-          <a:prstGeom prst="rect">
-            <a:avLst/>
-          </a:prstGeom>
-          <a:noFill/>
-        </p:spPr>
-        <p:txBody>
-          <a:bodyPr wrap="square" lIns="0" rIns="0" tIns="0" bIns="0" anchor="t">
-            <a:spAutoFit/>
-          </a:bodyPr>
-          <a:lstStyle/>
-          <a:p>
-            <a:pPr algn="l"/>
-            <a:r>
-              <a:rPr sz="1800" b="1">
-                <a:solidFill>
-                  <a:srgbClr val="FF3C00"/>
-                </a:solidFill>
-                <a:latin typeface="微软雅黑"/>
-                <a:ea typeface="微软雅黑"/>
-                <a:cs typeface="微软雅黑"/>
-              </a:rPr>
-              <a:t>热点函数</a:t>
-            </a:r>
-          </a:p>
-        </p:txBody>
-      </p:sp>
-      <p:sp>
-        <p:nvSpPr>
-          <p:cNvPr id="43" name="TextBox 42"/>
-          <p:cNvSpPr txBox="1"/>
-          <p:nvPr/>
-        </p:nvSpPr>
-        <p:spPr>
-          <a:xfrm>
-            <a:off x="6074664" y="5504688"/>
-            <a:ext cx="4108704" cy="822960"/>
-          </a:xfrm>
-          <a:prstGeom prst="rect">
-            <a:avLst/>
-          </a:prstGeom>
-          <a:noFill/>
-        </p:spPr>
-        <p:txBody>
-          <a:bodyPr wrap="square" lIns="0" rIns="0" tIns="0" bIns="0" anchor="t">
-            <a:spAutoFit/>
-          </a:bodyPr>
-          <a:lstStyle/>
-          <a:p>
-            <a:pPr algn="l"/>
-            <a:r>
-              <a:rPr sz="1400" b="0">
-                <a:solidFill>
-                  <a:srgbClr val="572D26"/>
-                </a:solidFill>
-                <a:latin typeface="微软雅黑"/>
-                <a:ea typeface="微软雅黑"/>
-                <a:cs typeface="微软雅黑"/>
-              </a:rPr>
-              <a:t>哪个函数 / 调用路径占比高</a:t>
-            </a:r>
-          </a:p>
-        </p:txBody>
-      </p:sp>
-      <p:sp>
-        <p:nvSpPr>
-          <p:cNvPr id="44" name="Rounded Rectangle 43"/>
-          <p:cNvSpPr/>
-          <p:nvPr/>
-        </p:nvSpPr>
-        <p:spPr>
-          <a:xfrm>
-            <a:off x="10732008" y="4800600"/>
-            <a:ext cx="4657344" cy="1965960"/>
-          </a:xfrm>
-          <a:prstGeom prst="roundRect">
-            <a:avLst>
-              <a:gd name="adj" fmla="val 8000"/>
-            </a:avLst>
-          </a:prstGeom>
-          <a:solidFill>
-            <a:srgbClr val="FFF9F3"/>
-          </a:solidFill>
-          <a:ln>
-            <a:noFill/>
-          </a:ln>
-          <a:effectLst/>
-        </p:spPr>
-        <p:style>
-          <a:lnRef idx="1">
-            <a:schemeClr val="accent1"/>
-          </a:lnRef>
-          <a:fillRef idx="3">
-            <a:schemeClr val="accent1"/>
-          </a:fillRef>
-          <a:effectRef idx="2">
-            <a:schemeClr val="accent1"/>
-          </a:effectRef>
-          <a:fontRef idx="minor">
-            <a:schemeClr val="lt1"/>
-          </a:fontRef>
-        </p:style>
-        <p:txBody>
-          <a:bodyPr rtlCol="0" anchor="ctr"/>
-          <a:lstStyle/>
-          <a:p>
-            <a:pPr algn="ctr"/>
-          </a:p>
-        </p:txBody>
-      </p:sp>
-      <p:sp>
-        <p:nvSpPr>
-          <p:cNvPr id="45" name="TextBox 44"/>
-          <p:cNvSpPr txBox="1"/>
-          <p:nvPr/>
-        </p:nvSpPr>
-        <p:spPr>
-          <a:xfrm>
-            <a:off x="11006328" y="5047488"/>
-            <a:ext cx="4108704" cy="365760"/>
-          </a:xfrm>
-          <a:prstGeom prst="rect">
-            <a:avLst/>
-          </a:prstGeom>
-          <a:noFill/>
-        </p:spPr>
-        <p:txBody>
-          <a:bodyPr wrap="square" lIns="0" rIns="0" tIns="0" bIns="0" anchor="t">
-            <a:spAutoFit/>
-          </a:bodyPr>
-          <a:lstStyle/>
-          <a:p>
-            <a:pPr algn="l"/>
-            <a:r>
-              <a:rPr sz="1800" b="1">
-                <a:solidFill>
-                  <a:srgbClr val="FF3C00"/>
-                </a:solidFill>
-                <a:latin typeface="微软雅黑"/>
-                <a:ea typeface="微软雅黑"/>
-                <a:cs typeface="微软雅黑"/>
-              </a:rPr>
-              <a:t>异常窗口</a:t>
-            </a:r>
-          </a:p>
-        </p:txBody>
-      </p:sp>
-      <p:sp>
-        <p:nvSpPr>
-          <p:cNvPr id="46" name="TextBox 45"/>
-          <p:cNvSpPr txBox="1"/>
-          <p:nvPr/>
-        </p:nvSpPr>
-        <p:spPr>
-          <a:xfrm>
-            <a:off x="11006328" y="5504688"/>
-            <a:ext cx="4108704" cy="822960"/>
-          </a:xfrm>
-          <a:prstGeom prst="rect">
-            <a:avLst/>
-          </a:prstGeom>
-          <a:noFill/>
-        </p:spPr>
-        <p:txBody>
-          <a:bodyPr wrap="square" lIns="0" rIns="0" tIns="0" bIns="0" anchor="t">
-            <a:spAutoFit/>
-          </a:bodyPr>
-          <a:lstStyle/>
-          <a:p>
-            <a:pPr algn="l"/>
-            <a:r>
-              <a:rPr sz="1400" b="0">
-                <a:solidFill>
-                  <a:srgbClr val="572D26"/>
+                  <a:srgbClr val="9A8578"/>
                 </a:solidFill>
                 <a:latin typeface="微软雅黑"/>
                 <a:ea typeface="微软雅黑"/>

</xml_diff>

<commit_message>
Update perfetto_ppt/: realign three pages with source deck layout
Summary:
- Scheduling: boxed question line, one enclosing panel with three
  outlined stage boxes (t-labels outside), compact focus cards and a
  centered bold note, matching the source slide composition.
- Latency: enclosing panel titled "Frame #1024 chain (not measured)"
  with five outlined stage boxes, in-panel bold note and compact
  deliverable cards.
- Collaboration: centered banner / four centered cards with arrows /
  centered conclusion box; question-mark titles restored.
- All 26 pages pass the structural QA (overflow / overlap check).

Signed-off-by: xiaodong03.zhang <xiaodong03.zhang@d-robotics.cc>
</commit_message>
<xml_diff>
--- a/perfetto_ppt/Perfetto_Agent_Skills_地瓜模板_26页.pptx
+++ b/perfetto_ppt/Perfetto_Agent_Skills_地瓜模板_26页.pptx
@@ -11749,46 +11749,9 @@
         <p:nvPr/>
       </p:nvGrpSpPr>
       <p:grpSpPr/>
-      <p:sp>
-        <p:nvSpPr>
-          <p:cNvPr id="2" name="TextBox 1"/>
-          <p:cNvSpPr txBox="1"/>
-          <p:nvPr/>
-        </p:nvSpPr>
-        <p:spPr>
-          <a:xfrm>
-            <a:off x="896112" y="1298448"/>
-            <a:ext cx="13716000" cy="365760"/>
-          </a:xfrm>
-          <a:prstGeom prst="rect">
-            <a:avLst/>
-          </a:prstGeom>
-          <a:noFill/>
-        </p:spPr>
-        <p:txBody>
-          <a:bodyPr wrap="square" lIns="0" rIns="0" tIns="0" bIns="0" anchor="t">
-            <a:spAutoFit/>
-          </a:bodyPr>
-          <a:lstStyle/>
-          <a:p>
-            <a:pPr algn="l"/>
-            <a:r>
-              <a:rPr sz="1400" b="0">
-                <a:solidFill>
-                  <a:srgbClr val="7A6A5E"/>
-                </a:solidFill>
-                <a:latin typeface="微软雅黑"/>
-                <a:ea typeface="微软雅黑"/>
-                <a:cs typeface="微软雅黑"/>
-              </a:rPr>
-              <a:t>典型提问：“程序偶尔卡 20 ms，但 CPU 并不高，为什么线程没及时处理任务？”</a:t>
-            </a:r>
-          </a:p>
-        </p:txBody>
-      </p:sp>
       <p:pic>
         <p:nvPicPr>
-          <p:cNvPr id="3" name="Picture 2" descr="logo.png"/>
+          <p:cNvPr id="2" name="Picture 1" descr="logo.png"/>
           <p:cNvPicPr>
             <a:picLocks noChangeAspect="1"/>
           </p:cNvPicPr>
@@ -11812,90 +11775,7 @@
       </p:pic>
       <p:sp>
         <p:nvSpPr>
-          <p:cNvPr id="4" name="Rounded Rectangle 3"/>
-          <p:cNvSpPr/>
-          <p:nvPr/>
-        </p:nvSpPr>
-        <p:spPr>
-          <a:xfrm>
-            <a:off x="868680" y="7882127"/>
-            <a:ext cx="14520672" cy="502920"/>
-          </a:xfrm>
-          <a:prstGeom prst="roundRect">
-            <a:avLst>
-              <a:gd name="adj" fmla="val 20000"/>
-            </a:avLst>
-          </a:prstGeom>
-          <a:solidFill>
-            <a:srgbClr val="FFEFD9"/>
-          </a:solidFill>
-          <a:ln>
-            <a:noFill/>
-          </a:ln>
-          <a:effectLst/>
-        </p:spPr>
-        <p:style>
-          <a:lnRef idx="1">
-            <a:schemeClr val="accent1"/>
-          </a:lnRef>
-          <a:fillRef idx="3">
-            <a:schemeClr val="accent1"/>
-          </a:fillRef>
-          <a:effectRef idx="2">
-            <a:schemeClr val="accent1"/>
-          </a:effectRef>
-          <a:fontRef idx="minor">
-            <a:schemeClr val="lt1"/>
-          </a:fontRef>
-        </p:style>
-        <p:txBody>
-          <a:bodyPr rtlCol="0" anchor="ctr"/>
-          <a:lstStyle/>
-          <a:p>
-            <a:pPr algn="ctr"/>
-          </a:p>
-        </p:txBody>
-      </p:sp>
-      <p:sp>
-        <p:nvSpPr>
-          <p:cNvPr id="5" name="TextBox 4"/>
-          <p:cNvSpPr txBox="1"/>
-          <p:nvPr/>
-        </p:nvSpPr>
-        <p:spPr>
-          <a:xfrm>
-            <a:off x="1143000" y="7882127"/>
-            <a:ext cx="13972032" cy="502920"/>
-          </a:xfrm>
-          <a:prstGeom prst="rect">
-            <a:avLst/>
-          </a:prstGeom>
-          <a:noFill/>
-        </p:spPr>
-        <p:txBody>
-          <a:bodyPr wrap="square" lIns="0" rIns="0" tIns="0" bIns="0" anchor="ctr">
-            <a:spAutoFit/>
-          </a:bodyPr>
-          <a:lstStyle/>
-          <a:p>
-            <a:pPr algn="l"/>
-            <a:r>
-              <a:rPr sz="1400" b="1">
-                <a:solidFill>
-                  <a:srgbClr val="FF3C00"/>
-                </a:solidFill>
-                <a:latin typeface="微软雅黑"/>
-                <a:ea typeface="微软雅黑"/>
-                <a:cs typeface="微软雅黑"/>
-              </a:rPr>
-              <a:t>注意：唤醒者 ≠ 一定是锁持有者；缺失事件栈或依赖信息时，需要标记 UNKNOWN。</a:t>
-            </a:r>
-          </a:p>
-        </p:txBody>
-      </p:sp>
-      <p:sp>
-        <p:nvSpPr>
-          <p:cNvPr id="6" name="Rounded Rectangle 5"/>
+          <p:cNvPr id="3" name="Rounded Rectangle 2"/>
           <p:cNvSpPr/>
           <p:nvPr/>
         </p:nvSpPr>
@@ -11954,7 +11834,7 @@
       </p:sp>
       <p:sp>
         <p:nvSpPr>
-          <p:cNvPr id="7" name="Rounded Rectangle 6"/>
+          <p:cNvPr id="4" name="Rounded Rectangle 3"/>
           <p:cNvSpPr/>
           <p:nvPr/>
         </p:nvSpPr>
@@ -12013,7 +11893,7 @@
       </p:sp>
       <p:sp>
         <p:nvSpPr>
-          <p:cNvPr id="8" name="Rounded Rectangle 7"/>
+          <p:cNvPr id="5" name="Rounded Rectangle 4"/>
           <p:cNvSpPr/>
           <p:nvPr/>
         </p:nvSpPr>
@@ -12072,7 +11952,7 @@
       </p:sp>
       <p:sp>
         <p:nvSpPr>
-          <p:cNvPr id="9" name="Rounded Rectangle 8"/>
+          <p:cNvPr id="6" name="Rounded Rectangle 5"/>
           <p:cNvSpPr/>
           <p:nvPr/>
         </p:nvSpPr>
@@ -12131,7 +12011,7 @@
       </p:sp>
       <p:sp>
         <p:nvSpPr>
-          <p:cNvPr id="10" name="Rounded Rectangle 9"/>
+          <p:cNvPr id="7" name="Rounded Rectangle 6"/>
           <p:cNvSpPr/>
           <p:nvPr/>
         </p:nvSpPr>
@@ -12190,7 +12070,7 @@
       </p:sp>
       <p:sp>
         <p:nvSpPr>
-          <p:cNvPr id="11" name="TextBox 10"/>
+          <p:cNvPr id="8" name="TextBox 7"/>
           <p:cNvSpPr txBox="1"/>
           <p:nvPr/>
         </p:nvSpPr>
@@ -12227,7 +12107,7 @@
       </p:sp>
       <p:sp>
         <p:nvSpPr>
-          <p:cNvPr id="12" name="TextBox 11"/>
+          <p:cNvPr id="9" name="TextBox 8"/>
           <p:cNvSpPr txBox="1"/>
           <p:nvPr/>
         </p:nvSpPr>
@@ -12257,36 +12137,82 @@
                 <a:ea typeface="优设标题黑"/>
                 <a:cs typeface="优设标题黑"/>
               </a:rPr>
-              <a:t>03.Scheduling：线程没在跑，时间耗在哪里</a:t>
-            </a:r>
-          </a:p>
-        </p:txBody>
-      </p:sp>
-      <p:sp>
-        <p:nvSpPr>
-          <p:cNvPr id="13" name="TextBox 12"/>
-          <p:cNvSpPr txBox="1"/>
-          <p:nvPr/>
-        </p:nvSpPr>
-        <p:spPr>
-          <a:xfrm>
-            <a:off x="868680" y="1828800"/>
-            <a:ext cx="9144000" cy="320040"/>
-          </a:xfrm>
-          <a:prstGeom prst="rect">
-            <a:avLst/>
-          </a:prstGeom>
-          <a:noFill/>
-        </p:spPr>
-        <p:txBody>
-          <a:bodyPr wrap="square" lIns="0" rIns="0" tIns="0" bIns="0" anchor="t">
+              <a:t>03.Scheduling：线程没在跑，时间究竟耗在哪里？</a:t>
+            </a:r>
+          </a:p>
+        </p:txBody>
+      </p:sp>
+      <p:sp>
+        <p:nvSpPr>
+          <p:cNvPr id="10" name="Rounded Rectangle 9"/>
+          <p:cNvSpPr/>
+          <p:nvPr/>
+        </p:nvSpPr>
+        <p:spPr>
+          <a:xfrm>
+            <a:off x="868680" y="1371600"/>
+            <a:ext cx="14520672" cy="566928"/>
+          </a:xfrm>
+          <a:prstGeom prst="roundRect">
+            <a:avLst>
+              <a:gd name="adj" fmla="val 30000"/>
+            </a:avLst>
+          </a:prstGeom>
+          <a:noFill/>
+          <a:ln w="12700">
+            <a:solidFill>
+              <a:srgbClr val="DDDDDD"/>
+            </a:solidFill>
+          </a:ln>
+          <a:effectLst/>
+        </p:spPr>
+        <p:style>
+          <a:lnRef idx="1">
+            <a:schemeClr val="accent1"/>
+          </a:lnRef>
+          <a:fillRef idx="3">
+            <a:schemeClr val="accent1"/>
+          </a:fillRef>
+          <a:effectRef idx="2">
+            <a:schemeClr val="accent1"/>
+          </a:effectRef>
+          <a:fontRef idx="minor">
+            <a:schemeClr val="lt1"/>
+          </a:fontRef>
+        </p:style>
+        <p:txBody>
+          <a:bodyPr rtlCol="0" anchor="ctr"/>
+          <a:lstStyle/>
+          <a:p>
+            <a:pPr algn="ctr"/>
+          </a:p>
+        </p:txBody>
+      </p:sp>
+      <p:sp>
+        <p:nvSpPr>
+          <p:cNvPr id="11" name="TextBox 10"/>
+          <p:cNvSpPr txBox="1"/>
+          <p:nvPr/>
+        </p:nvSpPr>
+        <p:spPr>
+          <a:xfrm>
+            <a:off x="1170432" y="1371600"/>
+            <a:ext cx="13917168" cy="566928"/>
+          </a:xfrm>
+          <a:prstGeom prst="rect">
+            <a:avLst/>
+          </a:prstGeom>
+          <a:noFill/>
+        </p:spPr>
+        <p:txBody>
+          <a:bodyPr wrap="square" lIns="0" rIns="0" tIns="0" bIns="0" anchor="ctr">
             <a:spAutoFit/>
           </a:bodyPr>
           <a:lstStyle/>
           <a:p>
             <a:pPr algn="l"/>
             <a:r>
-              <a:rPr sz="2100" b="1">
+              <a:rPr sz="1400" b="0">
                 <a:solidFill>
                   <a:srgbClr val="572D26"/>
                 </a:solidFill>
@@ -12294,21 +12220,21 @@
                 <a:ea typeface="微软雅黑"/>
                 <a:cs typeface="微软雅黑"/>
               </a:rPr>
-              <a:t>一次等待的三个阶段（教学示意）</a:t>
-            </a:r>
-          </a:p>
-        </p:txBody>
-      </p:sp>
-      <p:sp>
-        <p:nvSpPr>
-          <p:cNvPr id="14" name="Rounded Rectangle 13"/>
+              <a:t>典型提问：“程序偶尔卡 20 ms，但 CPU 并不高，为什么线程没及时处理任务？”</a:t>
+            </a:r>
+          </a:p>
+        </p:txBody>
+      </p:sp>
+      <p:sp>
+        <p:nvSpPr>
+          <p:cNvPr id="12" name="Rounded Rectangle 11"/>
           <p:cNvSpPr/>
           <p:nvPr/>
         </p:nvSpPr>
         <p:spPr>
           <a:xfrm>
-            <a:off x="868680" y="2240280"/>
-            <a:ext cx="4535424" cy="1463040"/>
+            <a:off x="868680" y="2148840"/>
+            <a:ext cx="14520672" cy="2697480"/>
           </a:xfrm>
           <a:prstGeom prst="roundRect">
             <a:avLst>
@@ -12347,27 +12273,110 @@
       </p:sp>
       <p:sp>
         <p:nvSpPr>
+          <p:cNvPr id="13" name="TextBox 12"/>
+          <p:cNvSpPr txBox="1"/>
+          <p:nvPr/>
+        </p:nvSpPr>
+        <p:spPr>
+          <a:xfrm>
+            <a:off x="1188720" y="2377440"/>
+            <a:ext cx="9144000" cy="365760"/>
+          </a:xfrm>
+          <a:prstGeom prst="rect">
+            <a:avLst/>
+          </a:prstGeom>
+          <a:noFill/>
+        </p:spPr>
+        <p:txBody>
+          <a:bodyPr wrap="square" lIns="0" rIns="0" tIns="0" bIns="0" anchor="t">
+            <a:spAutoFit/>
+          </a:bodyPr>
+          <a:lstStyle/>
+          <a:p>
+            <a:pPr algn="l"/>
+            <a:r>
+              <a:rPr sz="2100" b="1">
+                <a:solidFill>
+                  <a:srgbClr val="572D26"/>
+                </a:solidFill>
+                <a:latin typeface="微软雅黑"/>
+                <a:ea typeface="微软雅黑"/>
+                <a:cs typeface="微软雅黑"/>
+              </a:rPr>
+              <a:t>一次等待的三个阶段（教学示意）</a:t>
+            </a:r>
+          </a:p>
+        </p:txBody>
+      </p:sp>
+      <p:sp>
+        <p:nvSpPr>
+          <p:cNvPr id="14" name="Rounded Rectangle 13"/>
+          <p:cNvSpPr/>
+          <p:nvPr/>
+        </p:nvSpPr>
+        <p:spPr>
+          <a:xfrm>
+            <a:off x="1188720" y="2971800"/>
+            <a:ext cx="4413504" cy="777240"/>
+          </a:xfrm>
+          <a:prstGeom prst="roundRect">
+            <a:avLst>
+              <a:gd name="adj" fmla="val 10000"/>
+            </a:avLst>
+          </a:prstGeom>
+          <a:noFill/>
+          <a:ln w="17780">
+            <a:solidFill>
+              <a:srgbClr val="FF3C00"/>
+            </a:solidFill>
+          </a:ln>
+          <a:effectLst/>
+        </p:spPr>
+        <p:style>
+          <a:lnRef idx="1">
+            <a:schemeClr val="accent1"/>
+          </a:lnRef>
+          <a:fillRef idx="3">
+            <a:schemeClr val="accent1"/>
+          </a:fillRef>
+          <a:effectRef idx="2">
+            <a:schemeClr val="accent1"/>
+          </a:effectRef>
+          <a:fontRef idx="minor">
+            <a:schemeClr val="lt1"/>
+          </a:fontRef>
+        </p:style>
+        <p:txBody>
+          <a:bodyPr rtlCol="0" anchor="ctr"/>
+          <a:lstStyle/>
+          <a:p>
+            <a:pPr algn="ctr"/>
+          </a:p>
+        </p:txBody>
+      </p:sp>
+      <p:sp>
+        <p:nvSpPr>
           <p:cNvPr id="15" name="TextBox 14"/>
           <p:cNvSpPr txBox="1"/>
           <p:nvPr/>
         </p:nvSpPr>
         <p:spPr>
           <a:xfrm>
-            <a:off x="1143000" y="2395728"/>
-            <a:ext cx="3986784" cy="365760"/>
-          </a:xfrm>
-          <a:prstGeom prst="rect">
-            <a:avLst/>
-          </a:prstGeom>
-          <a:noFill/>
-        </p:spPr>
-        <p:txBody>
-          <a:bodyPr wrap="square" lIns="0" rIns="0" tIns="0" bIns="0" anchor="t">
-            <a:spAutoFit/>
-          </a:bodyPr>
-          <a:lstStyle/>
-          <a:p>
-            <a:pPr algn="l"/>
+            <a:off x="1188720" y="2971800"/>
+            <a:ext cx="4413504" cy="777240"/>
+          </a:xfrm>
+          <a:prstGeom prst="rect">
+            <a:avLst/>
+          </a:prstGeom>
+          <a:noFill/>
+        </p:spPr>
+        <p:txBody>
+          <a:bodyPr wrap="square" lIns="0" rIns="0" tIns="0" bIns="0" anchor="ctr">
+            <a:spAutoFit/>
+          </a:bodyPr>
+          <a:lstStyle/>
+          <a:p>
+            <a:pPr algn="ctr"/>
             <a:r>
               <a:rPr sz="1800" b="1">
                 <a:solidFill>
@@ -12390,45 +12399,8 @@
         </p:nvSpPr>
         <p:spPr>
           <a:xfrm>
-            <a:off x="1143000" y="2816352"/>
-            <a:ext cx="3986784" cy="411480"/>
-          </a:xfrm>
-          <a:prstGeom prst="rect">
-            <a:avLst/>
-          </a:prstGeom>
-          <a:noFill/>
-        </p:spPr>
-        <p:txBody>
-          <a:bodyPr wrap="square" lIns="0" rIns="0" tIns="0" bIns="0" anchor="t">
-            <a:spAutoFit/>
-          </a:bodyPr>
-          <a:lstStyle/>
-          <a:p>
-            <a:pPr algn="l"/>
-            <a:r>
-              <a:rPr sz="1200" b="0">
-                <a:solidFill>
-                  <a:srgbClr val="572D26"/>
-                </a:solidFill>
-                <a:latin typeface="微软雅黑"/>
-                <a:ea typeface="微软雅黑"/>
-                <a:cs typeface="微软雅黑"/>
-              </a:rPr>
-              <a:t>等待唤醒或事件</a:t>
-            </a:r>
-          </a:p>
-        </p:txBody>
-      </p:sp>
-      <p:sp>
-        <p:nvSpPr>
-          <p:cNvPr id="17" name="TextBox 16"/>
-          <p:cNvSpPr txBox="1"/>
-          <p:nvPr/>
-        </p:nvSpPr>
-        <p:spPr>
-          <a:xfrm>
-            <a:off x="1143000" y="3291840"/>
-            <a:ext cx="3986784" cy="274320"/>
+            <a:off x="1188720" y="3858768"/>
+            <a:ext cx="4413504" cy="256032"/>
           </a:xfrm>
           <a:prstGeom prst="rect">
             <a:avLst/>
@@ -12458,14 +12430,97 @@
       </p:sp>
       <p:sp>
         <p:nvSpPr>
-          <p:cNvPr id="18" name="TextBox 17"/>
-          <p:cNvSpPr txBox="1"/>
-          <p:nvPr/>
-        </p:nvSpPr>
-        <p:spPr>
-          <a:xfrm>
-            <a:off x="5458968" y="2697480"/>
-            <a:ext cx="347472" cy="411480"/>
+          <p:cNvPr id="17" name="TextBox 16"/>
+          <p:cNvSpPr txBox="1"/>
+          <p:nvPr/>
+        </p:nvSpPr>
+        <p:spPr>
+          <a:xfrm>
+            <a:off x="1188720" y="4160520"/>
+            <a:ext cx="4413504" cy="365760"/>
+          </a:xfrm>
+          <a:prstGeom prst="rect">
+            <a:avLst/>
+          </a:prstGeom>
+          <a:noFill/>
+        </p:spPr>
+        <p:txBody>
+          <a:bodyPr wrap="square" lIns="0" rIns="0" tIns="0" bIns="0" anchor="t">
+            <a:spAutoFit/>
+          </a:bodyPr>
+          <a:lstStyle/>
+          <a:p>
+            <a:pPr algn="ctr"/>
+            <a:r>
+              <a:rPr sz="1400" b="0">
+                <a:solidFill>
+                  <a:srgbClr val="572D26"/>
+                </a:solidFill>
+                <a:latin typeface="微软雅黑"/>
+                <a:ea typeface="微软雅黑"/>
+                <a:cs typeface="微软雅黑"/>
+              </a:rPr>
+              <a:t>等待唤醒或事件</a:t>
+            </a:r>
+          </a:p>
+        </p:txBody>
+      </p:sp>
+      <p:sp>
+        <p:nvSpPr>
+          <p:cNvPr id="18" name="Rounded Rectangle 17"/>
+          <p:cNvSpPr/>
+          <p:nvPr/>
+        </p:nvSpPr>
+        <p:spPr>
+          <a:xfrm>
+            <a:off x="5967984" y="2971800"/>
+            <a:ext cx="4413504" cy="777240"/>
+          </a:xfrm>
+          <a:prstGeom prst="roundRect">
+            <a:avLst>
+              <a:gd name="adj" fmla="val 10000"/>
+            </a:avLst>
+          </a:prstGeom>
+          <a:noFill/>
+          <a:ln w="17780">
+            <a:solidFill>
+              <a:srgbClr val="FF3C00"/>
+            </a:solidFill>
+          </a:ln>
+          <a:effectLst/>
+        </p:spPr>
+        <p:style>
+          <a:lnRef idx="1">
+            <a:schemeClr val="accent1"/>
+          </a:lnRef>
+          <a:fillRef idx="3">
+            <a:schemeClr val="accent1"/>
+          </a:fillRef>
+          <a:effectRef idx="2">
+            <a:schemeClr val="accent1"/>
+          </a:effectRef>
+          <a:fontRef idx="minor">
+            <a:schemeClr val="lt1"/>
+          </a:fontRef>
+        </p:style>
+        <p:txBody>
+          <a:bodyPr rtlCol="0" anchor="ctr"/>
+          <a:lstStyle/>
+          <a:p>
+            <a:pPr algn="ctr"/>
+          </a:p>
+        </p:txBody>
+      </p:sp>
+      <p:sp>
+        <p:nvSpPr>
+          <p:cNvPr id="19" name="TextBox 18"/>
+          <p:cNvSpPr txBox="1"/>
+          <p:nvPr/>
+        </p:nvSpPr>
+        <p:spPr>
+          <a:xfrm>
+            <a:off x="5967984" y="2971800"/>
+            <a:ext cx="4413504" cy="777240"/>
           </a:xfrm>
           <a:prstGeom prst="rect">
             <a:avLst/>
@@ -12483,26 +12538,257 @@
               <a:rPr sz="1800" b="1">
                 <a:solidFill>
                   <a:srgbClr val="FF3C00"/>
+                </a:solidFill>
+                <a:latin typeface="微软雅黑"/>
+                <a:ea typeface="微软雅黑"/>
+                <a:cs typeface="微软雅黑"/>
+              </a:rPr>
+              <a:t>Runnable</a:t>
+            </a:r>
+          </a:p>
+        </p:txBody>
+      </p:sp>
+      <p:sp>
+        <p:nvSpPr>
+          <p:cNvPr id="20" name="TextBox 19"/>
+          <p:cNvSpPr txBox="1"/>
+          <p:nvPr/>
+        </p:nvSpPr>
+        <p:spPr>
+          <a:xfrm>
+            <a:off x="5967984" y="3858768"/>
+            <a:ext cx="4413504" cy="256032"/>
+          </a:xfrm>
+          <a:prstGeom prst="rect">
+            <a:avLst/>
+          </a:prstGeom>
+          <a:noFill/>
+        </p:spPr>
+        <p:txBody>
+          <a:bodyPr wrap="square" lIns="0" rIns="0" tIns="0" bIns="0" anchor="t">
+            <a:spAutoFit/>
+          </a:bodyPr>
+          <a:lstStyle/>
+          <a:p>
+            <a:pPr algn="l"/>
+            <a:r>
+              <a:rPr sz="1200" b="0">
+                <a:solidFill>
+                  <a:srgbClr val="9A8578"/>
                 </a:solidFill>
                 <a:latin typeface="Arial"/>
                 <a:ea typeface="Arial"/>
                 <a:cs typeface="Arial"/>
               </a:rPr>
-              <a:t>→</a:t>
-            </a:r>
-          </a:p>
-        </p:txBody>
-      </p:sp>
-      <p:sp>
-        <p:nvSpPr>
-          <p:cNvPr id="19" name="Rounded Rectangle 18"/>
+              <a:t>t1 · 唤醒</a:t>
+            </a:r>
+          </a:p>
+        </p:txBody>
+      </p:sp>
+      <p:sp>
+        <p:nvSpPr>
+          <p:cNvPr id="21" name="TextBox 20"/>
+          <p:cNvSpPr txBox="1"/>
+          <p:nvPr/>
+        </p:nvSpPr>
+        <p:spPr>
+          <a:xfrm>
+            <a:off x="5967984" y="4160520"/>
+            <a:ext cx="4413504" cy="365760"/>
+          </a:xfrm>
+          <a:prstGeom prst="rect">
+            <a:avLst/>
+          </a:prstGeom>
+          <a:noFill/>
+        </p:spPr>
+        <p:txBody>
+          <a:bodyPr wrap="square" lIns="0" rIns="0" tIns="0" bIns="0" anchor="t">
+            <a:spAutoFit/>
+          </a:bodyPr>
+          <a:lstStyle/>
+          <a:p>
+            <a:pPr algn="ctr"/>
+            <a:r>
+              <a:rPr sz="1400" b="0">
+                <a:solidFill>
+                  <a:srgbClr val="572D26"/>
+                </a:solidFill>
+                <a:latin typeface="微软雅黑"/>
+                <a:ea typeface="微软雅黑"/>
+                <a:cs typeface="微软雅黑"/>
+              </a:rPr>
+              <a:t>已可运行，等待获得 CPU</a:t>
+            </a:r>
+          </a:p>
+        </p:txBody>
+      </p:sp>
+      <p:sp>
+        <p:nvSpPr>
+          <p:cNvPr id="22" name="Rounded Rectangle 21"/>
           <p:cNvSpPr/>
           <p:nvPr/>
         </p:nvSpPr>
         <p:spPr>
           <a:xfrm>
-            <a:off x="5861304" y="2240280"/>
-            <a:ext cx="4535424" cy="1463040"/>
+            <a:off x="10747248" y="2971800"/>
+            <a:ext cx="4413504" cy="777240"/>
+          </a:xfrm>
+          <a:prstGeom prst="roundRect">
+            <a:avLst>
+              <a:gd name="adj" fmla="val 10000"/>
+            </a:avLst>
+          </a:prstGeom>
+          <a:noFill/>
+          <a:ln w="17780">
+            <a:solidFill>
+              <a:srgbClr val="FF3C00"/>
+            </a:solidFill>
+          </a:ln>
+          <a:effectLst/>
+        </p:spPr>
+        <p:style>
+          <a:lnRef idx="1">
+            <a:schemeClr val="accent1"/>
+          </a:lnRef>
+          <a:fillRef idx="3">
+            <a:schemeClr val="accent1"/>
+          </a:fillRef>
+          <a:effectRef idx="2">
+            <a:schemeClr val="accent1"/>
+          </a:effectRef>
+          <a:fontRef idx="minor">
+            <a:schemeClr val="lt1"/>
+          </a:fontRef>
+        </p:style>
+        <p:txBody>
+          <a:bodyPr rtlCol="0" anchor="ctr"/>
+          <a:lstStyle/>
+          <a:p>
+            <a:pPr algn="ctr"/>
+          </a:p>
+        </p:txBody>
+      </p:sp>
+      <p:sp>
+        <p:nvSpPr>
+          <p:cNvPr id="23" name="TextBox 22"/>
+          <p:cNvSpPr txBox="1"/>
+          <p:nvPr/>
+        </p:nvSpPr>
+        <p:spPr>
+          <a:xfrm>
+            <a:off x="10747248" y="2971800"/>
+            <a:ext cx="4413504" cy="777240"/>
+          </a:xfrm>
+          <a:prstGeom prst="rect">
+            <a:avLst/>
+          </a:prstGeom>
+          <a:noFill/>
+        </p:spPr>
+        <p:txBody>
+          <a:bodyPr wrap="square" lIns="0" rIns="0" tIns="0" bIns="0" anchor="ctr">
+            <a:spAutoFit/>
+          </a:bodyPr>
+          <a:lstStyle/>
+          <a:p>
+            <a:pPr algn="ctr"/>
+            <a:r>
+              <a:rPr sz="1800" b="1">
+                <a:solidFill>
+                  <a:srgbClr val="FF3C00"/>
+                </a:solidFill>
+                <a:latin typeface="微软雅黑"/>
+                <a:ea typeface="微软雅黑"/>
+                <a:cs typeface="微软雅黑"/>
+              </a:rPr>
+              <a:t>Running</a:t>
+            </a:r>
+          </a:p>
+        </p:txBody>
+      </p:sp>
+      <p:sp>
+        <p:nvSpPr>
+          <p:cNvPr id="24" name="TextBox 23"/>
+          <p:cNvSpPr txBox="1"/>
+          <p:nvPr/>
+        </p:nvSpPr>
+        <p:spPr>
+          <a:xfrm>
+            <a:off x="10747248" y="3858768"/>
+            <a:ext cx="4413504" cy="256032"/>
+          </a:xfrm>
+          <a:prstGeom prst="rect">
+            <a:avLst/>
+          </a:prstGeom>
+          <a:noFill/>
+        </p:spPr>
+        <p:txBody>
+          <a:bodyPr wrap="square" lIns="0" rIns="0" tIns="0" bIns="0" anchor="t">
+            <a:spAutoFit/>
+          </a:bodyPr>
+          <a:lstStyle/>
+          <a:p>
+            <a:pPr algn="l"/>
+            <a:r>
+              <a:rPr sz="1200" b="0">
+                <a:solidFill>
+                  <a:srgbClr val="9A8578"/>
+                </a:solidFill>
+                <a:latin typeface="Arial"/>
+                <a:ea typeface="Arial"/>
+                <a:cs typeface="Arial"/>
+              </a:rPr>
+              <a:t>t2 · 运行</a:t>
+            </a:r>
+          </a:p>
+        </p:txBody>
+      </p:sp>
+      <p:sp>
+        <p:nvSpPr>
+          <p:cNvPr id="25" name="TextBox 24"/>
+          <p:cNvSpPr txBox="1"/>
+          <p:nvPr/>
+        </p:nvSpPr>
+        <p:spPr>
+          <a:xfrm>
+            <a:off x="10747248" y="4160520"/>
+            <a:ext cx="4413504" cy="365760"/>
+          </a:xfrm>
+          <a:prstGeom prst="rect">
+            <a:avLst/>
+          </a:prstGeom>
+          <a:noFill/>
+        </p:spPr>
+        <p:txBody>
+          <a:bodyPr wrap="square" lIns="0" rIns="0" tIns="0" bIns="0" anchor="t">
+            <a:spAutoFit/>
+          </a:bodyPr>
+          <a:lstStyle/>
+          <a:p>
+            <a:pPr algn="ctr"/>
+            <a:r>
+              <a:rPr sz="1400" b="0">
+                <a:solidFill>
+                  <a:srgbClr val="572D26"/>
+                </a:solidFill>
+                <a:latin typeface="微软雅黑"/>
+                <a:ea typeface="微软雅黑"/>
+                <a:cs typeface="微软雅黑"/>
+              </a:rPr>
+              <a:t>真正执行任务</a:t>
+            </a:r>
+          </a:p>
+        </p:txBody>
+      </p:sp>
+      <p:sp>
+        <p:nvSpPr>
+          <p:cNvPr id="26" name="Rounded Rectangle 25"/>
+          <p:cNvSpPr/>
+          <p:nvPr/>
+        </p:nvSpPr>
+        <p:spPr>
+          <a:xfrm>
+            <a:off x="868680" y="5120640"/>
+            <a:ext cx="4657344" cy="1554480"/>
           </a:xfrm>
           <a:prstGeom prst="roundRect">
             <a:avLst>
@@ -12541,125 +12827,97 @@
       </p:sp>
       <p:sp>
         <p:nvSpPr>
-          <p:cNvPr id="20" name="TextBox 19"/>
-          <p:cNvSpPr txBox="1"/>
-          <p:nvPr/>
-        </p:nvSpPr>
-        <p:spPr>
-          <a:xfrm>
-            <a:off x="6135624" y="2395728"/>
-            <a:ext cx="3986784" cy="365760"/>
-          </a:xfrm>
-          <a:prstGeom prst="rect">
-            <a:avLst/>
-          </a:prstGeom>
-          <a:noFill/>
-        </p:spPr>
-        <p:txBody>
-          <a:bodyPr wrap="square" lIns="0" rIns="0" tIns="0" bIns="0" anchor="t">
-            <a:spAutoFit/>
-          </a:bodyPr>
-          <a:lstStyle/>
-          <a:p>
-            <a:pPr algn="l"/>
-            <a:r>
-              <a:rPr sz="1800" b="1">
+          <p:cNvPr id="27" name="Rounded Rectangle 26"/>
+          <p:cNvSpPr/>
+          <p:nvPr/>
+        </p:nvSpPr>
+        <p:spPr>
+          <a:xfrm>
+            <a:off x="1143000" y="5349240"/>
+            <a:ext cx="603504" cy="402336"/>
+          </a:xfrm>
+          <a:prstGeom prst="roundRect">
+            <a:avLst>
+              <a:gd name="adj" fmla="val 35000"/>
+            </a:avLst>
+          </a:prstGeom>
+          <a:noFill/>
+          <a:ln w="15240">
+            <a:solidFill>
+              <a:srgbClr val="FF3C00"/>
+            </a:solidFill>
+          </a:ln>
+          <a:effectLst/>
+        </p:spPr>
+        <p:style>
+          <a:lnRef idx="1">
+            <a:schemeClr val="accent1"/>
+          </a:lnRef>
+          <a:fillRef idx="3">
+            <a:schemeClr val="accent1"/>
+          </a:fillRef>
+          <a:effectRef idx="2">
+            <a:schemeClr val="accent1"/>
+          </a:effectRef>
+          <a:fontRef idx="minor">
+            <a:schemeClr val="lt1"/>
+          </a:fontRef>
+        </p:style>
+        <p:txBody>
+          <a:bodyPr rtlCol="0" anchor="ctr"/>
+          <a:lstStyle/>
+          <a:p>
+            <a:pPr algn="ctr"/>
+          </a:p>
+        </p:txBody>
+      </p:sp>
+      <p:sp>
+        <p:nvSpPr>
+          <p:cNvPr id="28" name="TextBox 27"/>
+          <p:cNvSpPr txBox="1"/>
+          <p:nvPr/>
+        </p:nvSpPr>
+        <p:spPr>
+          <a:xfrm>
+            <a:off x="1143000" y="5349240"/>
+            <a:ext cx="603504" cy="402336"/>
+          </a:xfrm>
+          <a:prstGeom prst="rect">
+            <a:avLst/>
+          </a:prstGeom>
+          <a:noFill/>
+        </p:spPr>
+        <p:txBody>
+          <a:bodyPr wrap="square" lIns="0" rIns="0" tIns="0" bIns="0" anchor="ctr">
+            <a:spAutoFit/>
+          </a:bodyPr>
+          <a:lstStyle/>
+          <a:p>
+            <a:pPr algn="ctr"/>
+            <a:r>
+              <a:rPr sz="1400" b="1">
                 <a:solidFill>
                   <a:srgbClr val="FF3C00"/>
-                </a:solidFill>
-                <a:latin typeface="微软雅黑"/>
-                <a:ea typeface="微软雅黑"/>
-                <a:cs typeface="微软雅黑"/>
-              </a:rPr>
-              <a:t>Runnable</a:t>
-            </a:r>
-          </a:p>
-        </p:txBody>
-      </p:sp>
-      <p:sp>
-        <p:nvSpPr>
-          <p:cNvPr id="21" name="TextBox 20"/>
-          <p:cNvSpPr txBox="1"/>
-          <p:nvPr/>
-        </p:nvSpPr>
-        <p:spPr>
-          <a:xfrm>
-            <a:off x="6135624" y="2816352"/>
-            <a:ext cx="3986784" cy="411480"/>
-          </a:xfrm>
-          <a:prstGeom prst="rect">
-            <a:avLst/>
-          </a:prstGeom>
-          <a:noFill/>
-        </p:spPr>
-        <p:txBody>
-          <a:bodyPr wrap="square" lIns="0" rIns="0" tIns="0" bIns="0" anchor="t">
-            <a:spAutoFit/>
-          </a:bodyPr>
-          <a:lstStyle/>
-          <a:p>
-            <a:pPr algn="l"/>
-            <a:r>
-              <a:rPr sz="1200" b="0">
-                <a:solidFill>
-                  <a:srgbClr val="572D26"/>
-                </a:solidFill>
-                <a:latin typeface="微软雅黑"/>
-                <a:ea typeface="微软雅黑"/>
-                <a:cs typeface="微软雅黑"/>
-              </a:rPr>
-              <a:t>已可运行，等待获得 CPU</a:t>
-            </a:r>
-          </a:p>
-        </p:txBody>
-      </p:sp>
-      <p:sp>
-        <p:nvSpPr>
-          <p:cNvPr id="22" name="TextBox 21"/>
-          <p:cNvSpPr txBox="1"/>
-          <p:nvPr/>
-        </p:nvSpPr>
-        <p:spPr>
-          <a:xfrm>
-            <a:off x="6135624" y="3291840"/>
-            <a:ext cx="3986784" cy="274320"/>
-          </a:xfrm>
-          <a:prstGeom prst="rect">
-            <a:avLst/>
-          </a:prstGeom>
-          <a:noFill/>
-        </p:spPr>
-        <p:txBody>
-          <a:bodyPr wrap="square" lIns="0" rIns="0" tIns="0" bIns="0" anchor="t">
-            <a:spAutoFit/>
-          </a:bodyPr>
-          <a:lstStyle/>
-          <a:p>
-            <a:pPr algn="l"/>
-            <a:r>
-              <a:rPr sz="1200" b="0">
-                <a:solidFill>
-                  <a:srgbClr val="9A8578"/>
                 </a:solidFill>
                 <a:latin typeface="Arial"/>
                 <a:ea typeface="Arial"/>
                 <a:cs typeface="Arial"/>
               </a:rPr>
-              <a:t>t1 · 唤醒</a:t>
-            </a:r>
-          </a:p>
-        </p:txBody>
-      </p:sp>
-      <p:sp>
-        <p:nvSpPr>
-          <p:cNvPr id="23" name="TextBox 22"/>
-          <p:cNvSpPr txBox="1"/>
-          <p:nvPr/>
-        </p:nvSpPr>
-        <p:spPr>
-          <a:xfrm>
-            <a:off x="10451592" y="2697480"/>
-            <a:ext cx="347472" cy="411480"/>
+              <a:t>01</a:t>
+            </a:r>
+          </a:p>
+        </p:txBody>
+      </p:sp>
+      <p:sp>
+        <p:nvSpPr>
+          <p:cNvPr id="29" name="TextBox 28"/>
+          <p:cNvSpPr txBox="1"/>
+          <p:nvPr/>
+        </p:nvSpPr>
+        <p:spPr>
+          <a:xfrm>
+            <a:off x="1892808" y="5349240"/>
+            <a:ext cx="3358896" cy="402336"/>
           </a:xfrm>
           <a:prstGeom prst="rect">
             <a:avLst/>
@@ -12672,31 +12930,68 @@
           </a:bodyPr>
           <a:lstStyle/>
           <a:p>
-            <a:pPr algn="ctr"/>
-            <a:r>
-              <a:rPr sz="1800" b="1">
-                <a:solidFill>
-                  <a:srgbClr val="FF3C00"/>
-                </a:solidFill>
-                <a:latin typeface="Arial"/>
-                <a:ea typeface="Arial"/>
-                <a:cs typeface="Arial"/>
-              </a:rPr>
-              <a:t>→</a:t>
-            </a:r>
-          </a:p>
-        </p:txBody>
-      </p:sp>
-      <p:sp>
-        <p:nvSpPr>
-          <p:cNvPr id="24" name="Rounded Rectangle 23"/>
+            <a:pPr algn="l"/>
+            <a:r>
+              <a:rPr sz="2100" b="1">
+                <a:solidFill>
+                  <a:srgbClr val="572D26"/>
+                </a:solidFill>
+                <a:latin typeface="微软雅黑"/>
+                <a:ea typeface="微软雅黑"/>
+                <a:cs typeface="微软雅黑"/>
+              </a:rPr>
+              <a:t>阻塞端调用栈</a:t>
+            </a:r>
+          </a:p>
+        </p:txBody>
+      </p:sp>
+      <p:sp>
+        <p:nvSpPr>
+          <p:cNvPr id="30" name="TextBox 29"/>
+          <p:cNvSpPr txBox="1"/>
+          <p:nvPr/>
+        </p:nvSpPr>
+        <p:spPr>
+          <a:xfrm>
+            <a:off x="1143000" y="5925312"/>
+            <a:ext cx="4108704" cy="457200"/>
+          </a:xfrm>
+          <a:prstGeom prst="rect">
+            <a:avLst/>
+          </a:prstGeom>
+          <a:noFill/>
+        </p:spPr>
+        <p:txBody>
+          <a:bodyPr wrap="square" lIns="0" rIns="0" tIns="0" bIns="0" anchor="t">
+            <a:spAutoFit/>
+          </a:bodyPr>
+          <a:lstStyle/>
+          <a:p>
+            <a:pPr algn="ctr"/>
+            <a:r>
+              <a:rPr sz="1400" b="0">
+                <a:solidFill>
+                  <a:srgbClr val="572D26"/>
+                </a:solidFill>
+                <a:latin typeface="微软雅黑"/>
+                <a:ea typeface="微软雅黑"/>
+                <a:cs typeface="微软雅黑"/>
+              </a:rPr>
+              <a:t>在哪一条代码路径停止推进？</a:t>
+            </a:r>
+          </a:p>
+        </p:txBody>
+      </p:sp>
+      <p:sp>
+        <p:nvSpPr>
+          <p:cNvPr id="31" name="Rounded Rectangle 30"/>
           <p:cNvSpPr/>
           <p:nvPr/>
         </p:nvSpPr>
         <p:spPr>
           <a:xfrm>
-            <a:off x="10853928" y="2240280"/>
-            <a:ext cx="4535424" cy="1463040"/>
+            <a:off x="5800344" y="5120640"/>
+            <a:ext cx="4657344" cy="1554480"/>
           </a:xfrm>
           <a:prstGeom prst="roundRect">
             <a:avLst>
@@ -12735,125 +13030,171 @@
       </p:sp>
       <p:sp>
         <p:nvSpPr>
-          <p:cNvPr id="25" name="TextBox 24"/>
-          <p:cNvSpPr txBox="1"/>
-          <p:nvPr/>
-        </p:nvSpPr>
-        <p:spPr>
-          <a:xfrm>
-            <a:off x="11128248" y="2395728"/>
-            <a:ext cx="3986784" cy="365760"/>
-          </a:xfrm>
-          <a:prstGeom prst="rect">
-            <a:avLst/>
-          </a:prstGeom>
-          <a:noFill/>
-        </p:spPr>
-        <p:txBody>
-          <a:bodyPr wrap="square" lIns="0" rIns="0" tIns="0" bIns="0" anchor="t">
-            <a:spAutoFit/>
-          </a:bodyPr>
-          <a:lstStyle/>
-          <a:p>
-            <a:pPr algn="l"/>
-            <a:r>
-              <a:rPr sz="1800" b="1">
+          <p:cNvPr id="32" name="Rounded Rectangle 31"/>
+          <p:cNvSpPr/>
+          <p:nvPr/>
+        </p:nvSpPr>
+        <p:spPr>
+          <a:xfrm>
+            <a:off x="6074664" y="5349240"/>
+            <a:ext cx="603504" cy="402336"/>
+          </a:xfrm>
+          <a:prstGeom prst="roundRect">
+            <a:avLst>
+              <a:gd name="adj" fmla="val 35000"/>
+            </a:avLst>
+          </a:prstGeom>
+          <a:noFill/>
+          <a:ln w="15240">
+            <a:solidFill>
+              <a:srgbClr val="FF3C00"/>
+            </a:solidFill>
+          </a:ln>
+          <a:effectLst/>
+        </p:spPr>
+        <p:style>
+          <a:lnRef idx="1">
+            <a:schemeClr val="accent1"/>
+          </a:lnRef>
+          <a:fillRef idx="3">
+            <a:schemeClr val="accent1"/>
+          </a:fillRef>
+          <a:effectRef idx="2">
+            <a:schemeClr val="accent1"/>
+          </a:effectRef>
+          <a:fontRef idx="minor">
+            <a:schemeClr val="lt1"/>
+          </a:fontRef>
+        </p:style>
+        <p:txBody>
+          <a:bodyPr rtlCol="0" anchor="ctr"/>
+          <a:lstStyle/>
+          <a:p>
+            <a:pPr algn="ctr"/>
+          </a:p>
+        </p:txBody>
+      </p:sp>
+      <p:sp>
+        <p:nvSpPr>
+          <p:cNvPr id="33" name="TextBox 32"/>
+          <p:cNvSpPr txBox="1"/>
+          <p:nvPr/>
+        </p:nvSpPr>
+        <p:spPr>
+          <a:xfrm>
+            <a:off x="6074664" y="5349240"/>
+            <a:ext cx="603504" cy="402336"/>
+          </a:xfrm>
+          <a:prstGeom prst="rect">
+            <a:avLst/>
+          </a:prstGeom>
+          <a:noFill/>
+        </p:spPr>
+        <p:txBody>
+          <a:bodyPr wrap="square" lIns="0" rIns="0" tIns="0" bIns="0" anchor="ctr">
+            <a:spAutoFit/>
+          </a:bodyPr>
+          <a:lstStyle/>
+          <a:p>
+            <a:pPr algn="ctr"/>
+            <a:r>
+              <a:rPr sz="1400" b="1">
                 <a:solidFill>
                   <a:srgbClr val="FF3C00"/>
-                </a:solidFill>
-                <a:latin typeface="微软雅黑"/>
-                <a:ea typeface="微软雅黑"/>
-                <a:cs typeface="微软雅黑"/>
-              </a:rPr>
-              <a:t>Running</a:t>
-            </a:r>
-          </a:p>
-        </p:txBody>
-      </p:sp>
-      <p:sp>
-        <p:nvSpPr>
-          <p:cNvPr id="26" name="TextBox 25"/>
-          <p:cNvSpPr txBox="1"/>
-          <p:nvPr/>
-        </p:nvSpPr>
-        <p:spPr>
-          <a:xfrm>
-            <a:off x="11128248" y="2816352"/>
-            <a:ext cx="3986784" cy="411480"/>
-          </a:xfrm>
-          <a:prstGeom prst="rect">
-            <a:avLst/>
-          </a:prstGeom>
-          <a:noFill/>
-        </p:spPr>
-        <p:txBody>
-          <a:bodyPr wrap="square" lIns="0" rIns="0" tIns="0" bIns="0" anchor="t">
-            <a:spAutoFit/>
-          </a:bodyPr>
-          <a:lstStyle/>
-          <a:p>
-            <a:pPr algn="l"/>
-            <a:r>
-              <a:rPr sz="1200" b="0">
-                <a:solidFill>
-                  <a:srgbClr val="572D26"/>
-                </a:solidFill>
-                <a:latin typeface="微软雅黑"/>
-                <a:ea typeface="微软雅黑"/>
-                <a:cs typeface="微软雅黑"/>
-              </a:rPr>
-              <a:t>真正执行任务</a:t>
-            </a:r>
-          </a:p>
-        </p:txBody>
-      </p:sp>
-      <p:sp>
-        <p:nvSpPr>
-          <p:cNvPr id="27" name="TextBox 26"/>
-          <p:cNvSpPr txBox="1"/>
-          <p:nvPr/>
-        </p:nvSpPr>
-        <p:spPr>
-          <a:xfrm>
-            <a:off x="11128248" y="3291840"/>
-            <a:ext cx="3986784" cy="274320"/>
-          </a:xfrm>
-          <a:prstGeom prst="rect">
-            <a:avLst/>
-          </a:prstGeom>
-          <a:noFill/>
-        </p:spPr>
-        <p:txBody>
-          <a:bodyPr wrap="square" lIns="0" rIns="0" tIns="0" bIns="0" anchor="t">
-            <a:spAutoFit/>
-          </a:bodyPr>
-          <a:lstStyle/>
-          <a:p>
-            <a:pPr algn="l"/>
-            <a:r>
-              <a:rPr sz="1200" b="0">
-                <a:solidFill>
-                  <a:srgbClr val="9A8578"/>
                 </a:solidFill>
                 <a:latin typeface="Arial"/>
                 <a:ea typeface="Arial"/>
                 <a:cs typeface="Arial"/>
               </a:rPr>
-              <a:t>t2 · 运行</a:t>
-            </a:r>
-          </a:p>
-        </p:txBody>
-      </p:sp>
-      <p:sp>
-        <p:nvSpPr>
-          <p:cNvPr id="28" name="Rounded Rectangle 27"/>
+              <a:t>02</a:t>
+            </a:r>
+          </a:p>
+        </p:txBody>
+      </p:sp>
+      <p:sp>
+        <p:nvSpPr>
+          <p:cNvPr id="34" name="TextBox 33"/>
+          <p:cNvSpPr txBox="1"/>
+          <p:nvPr/>
+        </p:nvSpPr>
+        <p:spPr>
+          <a:xfrm>
+            <a:off x="6824472" y="5349240"/>
+            <a:ext cx="3358896" cy="402336"/>
+          </a:xfrm>
+          <a:prstGeom prst="rect">
+            <a:avLst/>
+          </a:prstGeom>
+          <a:noFill/>
+        </p:spPr>
+        <p:txBody>
+          <a:bodyPr wrap="square" lIns="0" rIns="0" tIns="0" bIns="0" anchor="ctr">
+            <a:spAutoFit/>
+          </a:bodyPr>
+          <a:lstStyle/>
+          <a:p>
+            <a:pPr algn="l"/>
+            <a:r>
+              <a:rPr sz="2100" b="1">
+                <a:solidFill>
+                  <a:srgbClr val="572D26"/>
+                </a:solidFill>
+                <a:latin typeface="微软雅黑"/>
+                <a:ea typeface="微软雅黑"/>
+                <a:cs typeface="微软雅黑"/>
+              </a:rPr>
+              <a:t>唤醒端调用栈</a:t>
+            </a:r>
+          </a:p>
+        </p:txBody>
+      </p:sp>
+      <p:sp>
+        <p:nvSpPr>
+          <p:cNvPr id="35" name="TextBox 34"/>
+          <p:cNvSpPr txBox="1"/>
+          <p:nvPr/>
+        </p:nvSpPr>
+        <p:spPr>
+          <a:xfrm>
+            <a:off x="6074664" y="5925312"/>
+            <a:ext cx="4108704" cy="457200"/>
+          </a:xfrm>
+          <a:prstGeom prst="rect">
+            <a:avLst/>
+          </a:prstGeom>
+          <a:noFill/>
+        </p:spPr>
+        <p:txBody>
+          <a:bodyPr wrap="square" lIns="0" rIns="0" tIns="0" bIns="0" anchor="t">
+            <a:spAutoFit/>
+          </a:bodyPr>
+          <a:lstStyle/>
+          <a:p>
+            <a:pPr algn="ctr"/>
+            <a:r>
+              <a:rPr sz="1400" b="0">
+                <a:solidFill>
+                  <a:srgbClr val="572D26"/>
+                </a:solidFill>
+                <a:latin typeface="微软雅黑"/>
+                <a:ea typeface="微软雅黑"/>
+                <a:cs typeface="微软雅黑"/>
+              </a:rPr>
+              <a:t>谁从什么路径唤醒目标？</a:t>
+            </a:r>
+          </a:p>
+        </p:txBody>
+      </p:sp>
+      <p:sp>
+        <p:nvSpPr>
+          <p:cNvPr id="36" name="Rounded Rectangle 35"/>
           <p:cNvSpPr/>
           <p:nvPr/>
         </p:nvSpPr>
         <p:spPr>
           <a:xfrm>
-            <a:off x="868680" y="4023360"/>
-            <a:ext cx="4657344" cy="2560320"/>
+            <a:off x="10732008" y="5120640"/>
+            <a:ext cx="4657344" cy="1554480"/>
           </a:xfrm>
           <a:prstGeom prst="roundRect">
             <a:avLst>
@@ -12892,13 +13233,13 @@
       </p:sp>
       <p:sp>
         <p:nvSpPr>
-          <p:cNvPr id="29" name="Rounded Rectangle 28"/>
+          <p:cNvPr id="37" name="Rounded Rectangle 36"/>
           <p:cNvSpPr/>
           <p:nvPr/>
         </p:nvSpPr>
         <p:spPr>
           <a:xfrm>
-            <a:off x="1143000" y="4297680"/>
+            <a:off x="11006328" y="5349240"/>
             <a:ext cx="603504" cy="402336"/>
           </a:xfrm>
           <a:prstGeom prst="roundRect">
@@ -12938,13 +13279,13 @@
       </p:sp>
       <p:sp>
         <p:nvSpPr>
-          <p:cNvPr id="30" name="TextBox 29"/>
-          <p:cNvSpPr txBox="1"/>
-          <p:nvPr/>
-        </p:nvSpPr>
-        <p:spPr>
-          <a:xfrm>
-            <a:off x="1143000" y="4297680"/>
+          <p:cNvPr id="38" name="TextBox 37"/>
+          <p:cNvSpPr txBox="1"/>
+          <p:nvPr/>
+        </p:nvSpPr>
+        <p:spPr>
+          <a:xfrm>
+            <a:off x="11006328" y="5349240"/>
             <a:ext cx="603504" cy="402336"/>
           </a:xfrm>
           <a:prstGeom prst="rect">
@@ -12968,20 +13309,20 @@
                 <a:ea typeface="Arial"/>
                 <a:cs typeface="Arial"/>
               </a:rPr>
-              <a:t>01</a:t>
-            </a:r>
-          </a:p>
-        </p:txBody>
-      </p:sp>
-      <p:sp>
-        <p:nvSpPr>
-          <p:cNvPr id="31" name="TextBox 30"/>
-          <p:cNvSpPr txBox="1"/>
-          <p:nvPr/>
-        </p:nvSpPr>
-        <p:spPr>
-          <a:xfrm>
-            <a:off x="1892808" y="4297680"/>
+              <a:t>03</a:t>
+            </a:r>
+          </a:p>
+        </p:txBody>
+      </p:sp>
+      <p:sp>
+        <p:nvSpPr>
+          <p:cNvPr id="39" name="TextBox 38"/>
+          <p:cNvSpPr txBox="1"/>
+          <p:nvPr/>
+        </p:nvSpPr>
+        <p:spPr>
+          <a:xfrm>
+            <a:off x="11756135" y="5349240"/>
             <a:ext cx="3358896" cy="402336"/>
           </a:xfrm>
           <a:prstGeom prst="rect">
@@ -13005,21 +13346,21 @@
                 <a:ea typeface="微软雅黑"/>
                 <a:cs typeface="微软雅黑"/>
               </a:rPr>
-              <a:t>阻塞端调用栈</a:t>
-            </a:r>
-          </a:p>
-        </p:txBody>
-      </p:sp>
-      <p:sp>
-        <p:nvSpPr>
-          <p:cNvPr id="32" name="TextBox 31"/>
-          <p:cNvSpPr txBox="1"/>
-          <p:nvPr/>
-        </p:nvSpPr>
-        <p:spPr>
-          <a:xfrm>
-            <a:off x="1143000" y="4956048"/>
-            <a:ext cx="4108704" cy="1371600"/>
+              <a:t>相关等待链</a:t>
+            </a:r>
+          </a:p>
+        </p:txBody>
+      </p:sp>
+      <p:sp>
+        <p:nvSpPr>
+          <p:cNvPr id="40" name="TextBox 39"/>
+          <p:cNvSpPr txBox="1"/>
+          <p:nvPr/>
+        </p:nvSpPr>
+        <p:spPr>
+          <a:xfrm>
+            <a:off x="11006328" y="5925312"/>
+            <a:ext cx="4108704" cy="457200"/>
           </a:xfrm>
           <a:prstGeom prst="rect">
             <a:avLst/>
@@ -13032,11 +13373,7 @@
           </a:bodyPr>
           <a:lstStyle/>
           <a:p>
-            <a:pPr algn="l">
-              <a:lnSpc>
-                <a:spcPct val="130000"/>
-              </a:lnSpc>
-            </a:pPr>
+            <a:pPr algn="ctr"/>
             <a:r>
               <a:rPr sz="1400" b="0">
                 <a:solidFill>
@@ -13046,165 +13383,36 @@
                 <a:ea typeface="微软雅黑"/>
                 <a:cs typeface="微软雅黑"/>
               </a:rPr>
-              <a:t>在哪一条代码路径停止推进？</a:t>
-            </a:r>
-          </a:p>
-        </p:txBody>
-      </p:sp>
-      <p:sp>
-        <p:nvSpPr>
-          <p:cNvPr id="33" name="Rounded Rectangle 32"/>
-          <p:cNvSpPr/>
-          <p:nvPr/>
-        </p:nvSpPr>
-        <p:spPr>
-          <a:xfrm>
-            <a:off x="5800344" y="4023360"/>
-            <a:ext cx="4657344" cy="2560320"/>
-          </a:xfrm>
-          <a:prstGeom prst="roundRect">
-            <a:avLst>
-              <a:gd name="adj" fmla="val 8000"/>
-            </a:avLst>
-          </a:prstGeom>
-          <a:solidFill>
-            <a:srgbClr val="FFF9F3"/>
-          </a:solidFill>
-          <a:ln>
-            <a:noFill/>
-          </a:ln>
-          <a:effectLst/>
-        </p:spPr>
-        <p:style>
-          <a:lnRef idx="1">
-            <a:schemeClr val="accent1"/>
-          </a:lnRef>
-          <a:fillRef idx="3">
-            <a:schemeClr val="accent1"/>
-          </a:fillRef>
-          <a:effectRef idx="2">
-            <a:schemeClr val="accent1"/>
-          </a:effectRef>
-          <a:fontRef idx="minor">
-            <a:schemeClr val="lt1"/>
-          </a:fontRef>
-        </p:style>
-        <p:txBody>
-          <a:bodyPr rtlCol="0" anchor="ctr"/>
-          <a:lstStyle/>
-          <a:p>
-            <a:pPr algn="ctr"/>
-          </a:p>
-        </p:txBody>
-      </p:sp>
-      <p:sp>
-        <p:nvSpPr>
-          <p:cNvPr id="34" name="Rounded Rectangle 33"/>
-          <p:cNvSpPr/>
-          <p:nvPr/>
-        </p:nvSpPr>
-        <p:spPr>
-          <a:xfrm>
-            <a:off x="6074664" y="4297680"/>
-            <a:ext cx="603504" cy="402336"/>
-          </a:xfrm>
-          <a:prstGeom prst="roundRect">
-            <a:avLst>
-              <a:gd name="adj" fmla="val 35000"/>
-            </a:avLst>
-          </a:prstGeom>
-          <a:noFill/>
-          <a:ln w="15240">
-            <a:solidFill>
-              <a:srgbClr val="FF3C00"/>
-            </a:solidFill>
-          </a:ln>
-          <a:effectLst/>
-        </p:spPr>
-        <p:style>
-          <a:lnRef idx="1">
-            <a:schemeClr val="accent1"/>
-          </a:lnRef>
-          <a:fillRef idx="3">
-            <a:schemeClr val="accent1"/>
-          </a:fillRef>
-          <a:effectRef idx="2">
-            <a:schemeClr val="accent1"/>
-          </a:effectRef>
-          <a:fontRef idx="minor">
-            <a:schemeClr val="lt1"/>
-          </a:fontRef>
-        </p:style>
-        <p:txBody>
-          <a:bodyPr rtlCol="0" anchor="ctr"/>
-          <a:lstStyle/>
-          <a:p>
-            <a:pPr algn="ctr"/>
-          </a:p>
-        </p:txBody>
-      </p:sp>
-      <p:sp>
-        <p:nvSpPr>
-          <p:cNvPr id="35" name="TextBox 34"/>
-          <p:cNvSpPr txBox="1"/>
-          <p:nvPr/>
-        </p:nvSpPr>
-        <p:spPr>
-          <a:xfrm>
-            <a:off x="6074664" y="4297680"/>
-            <a:ext cx="603504" cy="402336"/>
-          </a:xfrm>
-          <a:prstGeom prst="rect">
-            <a:avLst/>
-          </a:prstGeom>
-          <a:noFill/>
-        </p:spPr>
-        <p:txBody>
-          <a:bodyPr wrap="square" lIns="0" rIns="0" tIns="0" bIns="0" anchor="ctr">
-            <a:spAutoFit/>
-          </a:bodyPr>
-          <a:lstStyle/>
-          <a:p>
-            <a:pPr algn="ctr"/>
-            <a:r>
-              <a:rPr sz="1400" b="1">
-                <a:solidFill>
-                  <a:srgbClr val="FF3C00"/>
-                </a:solidFill>
-                <a:latin typeface="Arial"/>
-                <a:ea typeface="Arial"/>
-                <a:cs typeface="Arial"/>
-              </a:rPr>
-              <a:t>02</a:t>
-            </a:r>
-          </a:p>
-        </p:txBody>
-      </p:sp>
-      <p:sp>
-        <p:nvSpPr>
-          <p:cNvPr id="36" name="TextBox 35"/>
-          <p:cNvSpPr txBox="1"/>
-          <p:nvPr/>
-        </p:nvSpPr>
-        <p:spPr>
-          <a:xfrm>
-            <a:off x="6824472" y="4297680"/>
-            <a:ext cx="3358896" cy="402336"/>
-          </a:xfrm>
-          <a:prstGeom prst="rect">
-            <a:avLst/>
-          </a:prstGeom>
-          <a:noFill/>
-        </p:spPr>
-        <p:txBody>
-          <a:bodyPr wrap="square" lIns="0" rIns="0" tIns="0" bIns="0" anchor="ctr">
-            <a:spAutoFit/>
-          </a:bodyPr>
-          <a:lstStyle/>
-          <a:p>
-            <a:pPr algn="l"/>
-            <a:r>
-              <a:rPr sz="2100" b="1">
+              <a:t>唤醒后又受哪些线程影响？</a:t>
+            </a:r>
+          </a:p>
+        </p:txBody>
+      </p:sp>
+      <p:sp>
+        <p:nvSpPr>
+          <p:cNvPr id="41" name="TextBox 40"/>
+          <p:cNvSpPr txBox="1"/>
+          <p:nvPr/>
+        </p:nvSpPr>
+        <p:spPr>
+          <a:xfrm>
+            <a:off x="868680" y="7086600"/>
+            <a:ext cx="14520672" cy="411480"/>
+          </a:xfrm>
+          <a:prstGeom prst="rect">
+            <a:avLst/>
+          </a:prstGeom>
+          <a:noFill/>
+        </p:spPr>
+        <p:txBody>
+          <a:bodyPr wrap="square" lIns="0" rIns="0" tIns="0" bIns="0" anchor="t">
+            <a:spAutoFit/>
+          </a:bodyPr>
+          <a:lstStyle/>
+          <a:p>
+            <a:pPr algn="ctr"/>
+            <a:r>
+              <a:rPr sz="1800" b="1">
                 <a:solidFill>
                   <a:srgbClr val="572D26"/>
                 </a:solidFill>
@@ -13212,255 +13420,7 @@
                 <a:ea typeface="微软雅黑"/>
                 <a:cs typeface="微软雅黑"/>
               </a:rPr>
-              <a:t>唤醒端调用栈</a:t>
-            </a:r>
-          </a:p>
-        </p:txBody>
-      </p:sp>
-      <p:sp>
-        <p:nvSpPr>
-          <p:cNvPr id="37" name="TextBox 36"/>
-          <p:cNvSpPr txBox="1"/>
-          <p:nvPr/>
-        </p:nvSpPr>
-        <p:spPr>
-          <a:xfrm>
-            <a:off x="6074664" y="4956048"/>
-            <a:ext cx="4108704" cy="1371600"/>
-          </a:xfrm>
-          <a:prstGeom prst="rect">
-            <a:avLst/>
-          </a:prstGeom>
-          <a:noFill/>
-        </p:spPr>
-        <p:txBody>
-          <a:bodyPr wrap="square" lIns="0" rIns="0" tIns="0" bIns="0" anchor="t">
-            <a:spAutoFit/>
-          </a:bodyPr>
-          <a:lstStyle/>
-          <a:p>
-            <a:pPr algn="l">
-              <a:lnSpc>
-                <a:spcPct val="130000"/>
-              </a:lnSpc>
-            </a:pPr>
-            <a:r>
-              <a:rPr sz="1400" b="0">
-                <a:solidFill>
-                  <a:srgbClr val="572D26"/>
-                </a:solidFill>
-                <a:latin typeface="微软雅黑"/>
-                <a:ea typeface="微软雅黑"/>
-                <a:cs typeface="微软雅黑"/>
-              </a:rPr>
-              <a:t>谁从什么路径唤醒目标？</a:t>
-            </a:r>
-          </a:p>
-        </p:txBody>
-      </p:sp>
-      <p:sp>
-        <p:nvSpPr>
-          <p:cNvPr id="38" name="Rounded Rectangle 37"/>
-          <p:cNvSpPr/>
-          <p:nvPr/>
-        </p:nvSpPr>
-        <p:spPr>
-          <a:xfrm>
-            <a:off x="10732008" y="4023360"/>
-            <a:ext cx="4657344" cy="2560320"/>
-          </a:xfrm>
-          <a:prstGeom prst="roundRect">
-            <a:avLst>
-              <a:gd name="adj" fmla="val 8000"/>
-            </a:avLst>
-          </a:prstGeom>
-          <a:solidFill>
-            <a:srgbClr val="FFF9F3"/>
-          </a:solidFill>
-          <a:ln>
-            <a:noFill/>
-          </a:ln>
-          <a:effectLst/>
-        </p:spPr>
-        <p:style>
-          <a:lnRef idx="1">
-            <a:schemeClr val="accent1"/>
-          </a:lnRef>
-          <a:fillRef idx="3">
-            <a:schemeClr val="accent1"/>
-          </a:fillRef>
-          <a:effectRef idx="2">
-            <a:schemeClr val="accent1"/>
-          </a:effectRef>
-          <a:fontRef idx="minor">
-            <a:schemeClr val="lt1"/>
-          </a:fontRef>
-        </p:style>
-        <p:txBody>
-          <a:bodyPr rtlCol="0" anchor="ctr"/>
-          <a:lstStyle/>
-          <a:p>
-            <a:pPr algn="ctr"/>
-          </a:p>
-        </p:txBody>
-      </p:sp>
-      <p:sp>
-        <p:nvSpPr>
-          <p:cNvPr id="39" name="Rounded Rectangle 38"/>
-          <p:cNvSpPr/>
-          <p:nvPr/>
-        </p:nvSpPr>
-        <p:spPr>
-          <a:xfrm>
-            <a:off x="11006328" y="4297680"/>
-            <a:ext cx="603504" cy="402336"/>
-          </a:xfrm>
-          <a:prstGeom prst="roundRect">
-            <a:avLst>
-              <a:gd name="adj" fmla="val 35000"/>
-            </a:avLst>
-          </a:prstGeom>
-          <a:noFill/>
-          <a:ln w="15240">
-            <a:solidFill>
-              <a:srgbClr val="FF3C00"/>
-            </a:solidFill>
-          </a:ln>
-          <a:effectLst/>
-        </p:spPr>
-        <p:style>
-          <a:lnRef idx="1">
-            <a:schemeClr val="accent1"/>
-          </a:lnRef>
-          <a:fillRef idx="3">
-            <a:schemeClr val="accent1"/>
-          </a:fillRef>
-          <a:effectRef idx="2">
-            <a:schemeClr val="accent1"/>
-          </a:effectRef>
-          <a:fontRef idx="minor">
-            <a:schemeClr val="lt1"/>
-          </a:fontRef>
-        </p:style>
-        <p:txBody>
-          <a:bodyPr rtlCol="0" anchor="ctr"/>
-          <a:lstStyle/>
-          <a:p>
-            <a:pPr algn="ctr"/>
-          </a:p>
-        </p:txBody>
-      </p:sp>
-      <p:sp>
-        <p:nvSpPr>
-          <p:cNvPr id="40" name="TextBox 39"/>
-          <p:cNvSpPr txBox="1"/>
-          <p:nvPr/>
-        </p:nvSpPr>
-        <p:spPr>
-          <a:xfrm>
-            <a:off x="11006328" y="4297680"/>
-            <a:ext cx="603504" cy="402336"/>
-          </a:xfrm>
-          <a:prstGeom prst="rect">
-            <a:avLst/>
-          </a:prstGeom>
-          <a:noFill/>
-        </p:spPr>
-        <p:txBody>
-          <a:bodyPr wrap="square" lIns="0" rIns="0" tIns="0" bIns="0" anchor="ctr">
-            <a:spAutoFit/>
-          </a:bodyPr>
-          <a:lstStyle/>
-          <a:p>
-            <a:pPr algn="ctr"/>
-            <a:r>
-              <a:rPr sz="1400" b="1">
-                <a:solidFill>
-                  <a:srgbClr val="FF3C00"/>
-                </a:solidFill>
-                <a:latin typeface="Arial"/>
-                <a:ea typeface="Arial"/>
-                <a:cs typeface="Arial"/>
-              </a:rPr>
-              <a:t>03</a:t>
-            </a:r>
-          </a:p>
-        </p:txBody>
-      </p:sp>
-      <p:sp>
-        <p:nvSpPr>
-          <p:cNvPr id="41" name="TextBox 40"/>
-          <p:cNvSpPr txBox="1"/>
-          <p:nvPr/>
-        </p:nvSpPr>
-        <p:spPr>
-          <a:xfrm>
-            <a:off x="11756135" y="4297680"/>
-            <a:ext cx="3358896" cy="402336"/>
-          </a:xfrm>
-          <a:prstGeom prst="rect">
-            <a:avLst/>
-          </a:prstGeom>
-          <a:noFill/>
-        </p:spPr>
-        <p:txBody>
-          <a:bodyPr wrap="square" lIns="0" rIns="0" tIns="0" bIns="0" anchor="ctr">
-            <a:spAutoFit/>
-          </a:bodyPr>
-          <a:lstStyle/>
-          <a:p>
-            <a:pPr algn="l"/>
-            <a:r>
-              <a:rPr sz="2100" b="1">
-                <a:solidFill>
-                  <a:srgbClr val="572D26"/>
-                </a:solidFill>
-                <a:latin typeface="微软雅黑"/>
-                <a:ea typeface="微软雅黑"/>
-                <a:cs typeface="微软雅黑"/>
-              </a:rPr>
-              <a:t>相关等待链</a:t>
-            </a:r>
-          </a:p>
-        </p:txBody>
-      </p:sp>
-      <p:sp>
-        <p:nvSpPr>
-          <p:cNvPr id="42" name="TextBox 41"/>
-          <p:cNvSpPr txBox="1"/>
-          <p:nvPr/>
-        </p:nvSpPr>
-        <p:spPr>
-          <a:xfrm>
-            <a:off x="11006328" y="4956048"/>
-            <a:ext cx="4108704" cy="1371600"/>
-          </a:xfrm>
-          <a:prstGeom prst="rect">
-            <a:avLst/>
-          </a:prstGeom>
-          <a:noFill/>
-        </p:spPr>
-        <p:txBody>
-          <a:bodyPr wrap="square" lIns="0" rIns="0" tIns="0" bIns="0" anchor="t">
-            <a:spAutoFit/>
-          </a:bodyPr>
-          <a:lstStyle/>
-          <a:p>
-            <a:pPr algn="l">
-              <a:lnSpc>
-                <a:spcPct val="130000"/>
-              </a:lnSpc>
-            </a:pPr>
-            <a:r>
-              <a:rPr sz="1400" b="0">
-                <a:solidFill>
-                  <a:srgbClr val="572D26"/>
-                </a:solidFill>
-                <a:latin typeface="微软雅黑"/>
-                <a:ea typeface="微软雅黑"/>
-                <a:cs typeface="微软雅黑"/>
-              </a:rPr>
-              <a:t>唤醒后又受哪些线程影响？</a:t>
+              <a:t>注意：唤醒者 ≠ 一定是锁持有者；缺失事件栈或依赖信息时，需要标记 UNKNOWN。</a:t>
             </a:r>
           </a:p>
         </p:txBody>
@@ -13991,7 +13951,7 @@
                 <a:ea typeface="优设标题黑"/>
                 <a:cs typeface="优设标题黑"/>
               </a:rPr>
-              <a:t>03.Latency：一次请求或一帧数据，慢在哪一步</a:t>
+              <a:t>03.Latency：一次请求或一帧数据，慢在哪一步？</a:t>
             </a:r>
           </a:p>
         </p:txBody>
@@ -14004,793 +13964,8 @@
         </p:nvSpPr>
         <p:spPr>
           <a:xfrm>
-            <a:off x="868680" y="1874519"/>
-            <a:ext cx="2648102" cy="960120"/>
-          </a:xfrm>
-          <a:prstGeom prst="roundRect">
-            <a:avLst>
-              <a:gd name="adj" fmla="val 8000"/>
-            </a:avLst>
-          </a:prstGeom>
-          <a:solidFill>
-            <a:srgbClr val="FFEFD9"/>
-          </a:solidFill>
-          <a:ln>
-            <a:noFill/>
-          </a:ln>
-          <a:effectLst/>
-        </p:spPr>
-        <p:style>
-          <a:lnRef idx="1">
-            <a:schemeClr val="accent1"/>
-          </a:lnRef>
-          <a:fillRef idx="3">
-            <a:schemeClr val="accent1"/>
-          </a:fillRef>
-          <a:effectRef idx="2">
-            <a:schemeClr val="accent1"/>
-          </a:effectRef>
-          <a:fontRef idx="minor">
-            <a:schemeClr val="lt1"/>
-          </a:fontRef>
-        </p:style>
-        <p:txBody>
-          <a:bodyPr rtlCol="0" anchor="ctr"/>
-          <a:lstStyle/>
-          <a:p>
-            <a:pPr algn="ctr"/>
-          </a:p>
-        </p:txBody>
-      </p:sp>
-      <p:sp>
-        <p:nvSpPr>
-          <p:cNvPr id="14" name="TextBox 13"/>
-          <p:cNvSpPr txBox="1"/>
-          <p:nvPr/>
-        </p:nvSpPr>
-        <p:spPr>
-          <a:xfrm>
-            <a:off x="941832" y="2011680"/>
-            <a:ext cx="2501798" cy="320040"/>
-          </a:xfrm>
-          <a:prstGeom prst="rect">
-            <a:avLst/>
-          </a:prstGeom>
-          <a:noFill/>
-        </p:spPr>
-        <p:txBody>
-          <a:bodyPr wrap="square" lIns="0" rIns="0" tIns="0" bIns="0" anchor="t">
-            <a:spAutoFit/>
-          </a:bodyPr>
-          <a:lstStyle/>
-          <a:p>
-            <a:pPr algn="ctr"/>
-            <a:r>
-              <a:rPr sz="1400" b="1">
-                <a:solidFill>
-                  <a:srgbClr val="572D26"/>
-                </a:solidFill>
-                <a:latin typeface="微软雅黑"/>
-                <a:ea typeface="微软雅黑"/>
-                <a:cs typeface="微软雅黑"/>
-              </a:rPr>
-              <a:t>Camera</a:t>
-            </a:r>
-          </a:p>
-        </p:txBody>
-      </p:sp>
-      <p:sp>
-        <p:nvSpPr>
-          <p:cNvPr id="15" name="TextBox 14"/>
-          <p:cNvSpPr txBox="1"/>
-          <p:nvPr/>
-        </p:nvSpPr>
-        <p:spPr>
-          <a:xfrm>
-            <a:off x="941832" y="2359152"/>
-            <a:ext cx="2501798" cy="274320"/>
-          </a:xfrm>
-          <a:prstGeom prst="rect">
-            <a:avLst/>
-          </a:prstGeom>
-          <a:noFill/>
-        </p:spPr>
-        <p:txBody>
-          <a:bodyPr wrap="square" lIns="0" rIns="0" tIns="0" bIns="0" anchor="t">
-            <a:spAutoFit/>
-          </a:bodyPr>
-          <a:lstStyle/>
-          <a:p>
-            <a:pPr algn="ctr"/>
-            <a:r>
-              <a:rPr sz="1200" b="0">
-                <a:solidFill>
-                  <a:srgbClr val="9A8578"/>
-                </a:solidFill>
-                <a:latin typeface="微软雅黑"/>
-                <a:ea typeface="微软雅黑"/>
-                <a:cs typeface="微软雅黑"/>
-              </a:rPr>
-              <a:t>输入帧</a:t>
-            </a:r>
-          </a:p>
-        </p:txBody>
-      </p:sp>
-      <p:sp>
-        <p:nvSpPr>
-          <p:cNvPr id="16" name="TextBox 15"/>
-          <p:cNvSpPr txBox="1"/>
-          <p:nvPr/>
-        </p:nvSpPr>
-        <p:spPr>
-          <a:xfrm>
-            <a:off x="3544214" y="2103120"/>
-            <a:ext cx="265176" cy="411480"/>
-          </a:xfrm>
-          <a:prstGeom prst="rect">
-            <a:avLst/>
-          </a:prstGeom>
-          <a:noFill/>
-        </p:spPr>
-        <p:txBody>
-          <a:bodyPr wrap="square" lIns="0" rIns="0" tIns="0" bIns="0" anchor="ctr">
-            <a:spAutoFit/>
-          </a:bodyPr>
-          <a:lstStyle/>
-          <a:p>
-            <a:pPr algn="ctr"/>
-            <a:r>
-              <a:rPr sz="1800" b="1">
-                <a:solidFill>
-                  <a:srgbClr val="FF3C00"/>
-                </a:solidFill>
-                <a:latin typeface="Arial"/>
-                <a:ea typeface="Arial"/>
-                <a:cs typeface="Arial"/>
-              </a:rPr>
-              <a:t>→</a:t>
-            </a:r>
-          </a:p>
-        </p:txBody>
-      </p:sp>
-      <p:sp>
-        <p:nvSpPr>
-          <p:cNvPr id="17" name="Rounded Rectangle 16"/>
-          <p:cNvSpPr/>
-          <p:nvPr/>
-        </p:nvSpPr>
-        <p:spPr>
-          <a:xfrm>
-            <a:off x="3836822" y="1874519"/>
-            <a:ext cx="2648102" cy="960120"/>
-          </a:xfrm>
-          <a:prstGeom prst="roundRect">
-            <a:avLst>
-              <a:gd name="adj" fmla="val 8000"/>
-            </a:avLst>
-          </a:prstGeom>
-          <a:solidFill>
-            <a:srgbClr val="FFEFD9"/>
-          </a:solidFill>
-          <a:ln>
-            <a:noFill/>
-          </a:ln>
-          <a:effectLst/>
-        </p:spPr>
-        <p:style>
-          <a:lnRef idx="1">
-            <a:schemeClr val="accent1"/>
-          </a:lnRef>
-          <a:fillRef idx="3">
-            <a:schemeClr val="accent1"/>
-          </a:fillRef>
-          <a:effectRef idx="2">
-            <a:schemeClr val="accent1"/>
-          </a:effectRef>
-          <a:fontRef idx="minor">
-            <a:schemeClr val="lt1"/>
-          </a:fontRef>
-        </p:style>
-        <p:txBody>
-          <a:bodyPr rtlCol="0" anchor="ctr"/>
-          <a:lstStyle/>
-          <a:p>
-            <a:pPr algn="ctr"/>
-          </a:p>
-        </p:txBody>
-      </p:sp>
-      <p:sp>
-        <p:nvSpPr>
-          <p:cNvPr id="18" name="TextBox 17"/>
-          <p:cNvSpPr txBox="1"/>
-          <p:nvPr/>
-        </p:nvSpPr>
-        <p:spPr>
-          <a:xfrm>
-            <a:off x="3909974" y="2011680"/>
-            <a:ext cx="2501798" cy="320040"/>
-          </a:xfrm>
-          <a:prstGeom prst="rect">
-            <a:avLst/>
-          </a:prstGeom>
-          <a:noFill/>
-        </p:spPr>
-        <p:txBody>
-          <a:bodyPr wrap="square" lIns="0" rIns="0" tIns="0" bIns="0" anchor="t">
-            <a:spAutoFit/>
-          </a:bodyPr>
-          <a:lstStyle/>
-          <a:p>
-            <a:pPr algn="ctr"/>
-            <a:r>
-              <a:rPr sz="1400" b="1">
-                <a:solidFill>
-                  <a:srgbClr val="572D26"/>
-                </a:solidFill>
-                <a:latin typeface="微软雅黑"/>
-                <a:ea typeface="微软雅黑"/>
-                <a:cs typeface="微软雅黑"/>
-              </a:rPr>
-              <a:t>Queue</a:t>
-            </a:r>
-          </a:p>
-        </p:txBody>
-      </p:sp>
-      <p:sp>
-        <p:nvSpPr>
-          <p:cNvPr id="19" name="TextBox 18"/>
-          <p:cNvSpPr txBox="1"/>
-          <p:nvPr/>
-        </p:nvSpPr>
-        <p:spPr>
-          <a:xfrm>
-            <a:off x="3909974" y="2359152"/>
-            <a:ext cx="2501798" cy="274320"/>
-          </a:xfrm>
-          <a:prstGeom prst="rect">
-            <a:avLst/>
-          </a:prstGeom>
-          <a:noFill/>
-        </p:spPr>
-        <p:txBody>
-          <a:bodyPr wrap="square" lIns="0" rIns="0" tIns="0" bIns="0" anchor="t">
-            <a:spAutoFit/>
-          </a:bodyPr>
-          <a:lstStyle/>
-          <a:p>
-            <a:pPr algn="ctr"/>
-            <a:r>
-              <a:rPr sz="1200" b="0">
-                <a:solidFill>
-                  <a:srgbClr val="9A8578"/>
-                </a:solidFill>
-                <a:latin typeface="微软雅黑"/>
-                <a:ea typeface="微软雅黑"/>
-                <a:cs typeface="微软雅黑"/>
-              </a:rPr>
-              <a:t>排队</a:t>
-            </a:r>
-          </a:p>
-        </p:txBody>
-      </p:sp>
-      <p:sp>
-        <p:nvSpPr>
-          <p:cNvPr id="20" name="TextBox 19"/>
-          <p:cNvSpPr txBox="1"/>
-          <p:nvPr/>
-        </p:nvSpPr>
-        <p:spPr>
-          <a:xfrm>
-            <a:off x="6512356" y="2103120"/>
-            <a:ext cx="265176" cy="411480"/>
-          </a:xfrm>
-          <a:prstGeom prst="rect">
-            <a:avLst/>
-          </a:prstGeom>
-          <a:noFill/>
-        </p:spPr>
-        <p:txBody>
-          <a:bodyPr wrap="square" lIns="0" rIns="0" tIns="0" bIns="0" anchor="ctr">
-            <a:spAutoFit/>
-          </a:bodyPr>
-          <a:lstStyle/>
-          <a:p>
-            <a:pPr algn="ctr"/>
-            <a:r>
-              <a:rPr sz="1800" b="1">
-                <a:solidFill>
-                  <a:srgbClr val="FF3C00"/>
-                </a:solidFill>
-                <a:latin typeface="Arial"/>
-                <a:ea typeface="Arial"/>
-                <a:cs typeface="Arial"/>
-              </a:rPr>
-              <a:t>→</a:t>
-            </a:r>
-          </a:p>
-        </p:txBody>
-      </p:sp>
-      <p:sp>
-        <p:nvSpPr>
-          <p:cNvPr id="21" name="Rounded Rectangle 20"/>
-          <p:cNvSpPr/>
-          <p:nvPr/>
-        </p:nvSpPr>
-        <p:spPr>
-          <a:xfrm>
-            <a:off x="6804964" y="1874519"/>
-            <a:ext cx="2648102" cy="960120"/>
-          </a:xfrm>
-          <a:prstGeom prst="roundRect">
-            <a:avLst>
-              <a:gd name="adj" fmla="val 8000"/>
-            </a:avLst>
-          </a:prstGeom>
-          <a:solidFill>
-            <a:srgbClr val="FFEFD9"/>
-          </a:solidFill>
-          <a:ln>
-            <a:noFill/>
-          </a:ln>
-          <a:effectLst/>
-        </p:spPr>
-        <p:style>
-          <a:lnRef idx="1">
-            <a:schemeClr val="accent1"/>
-          </a:lnRef>
-          <a:fillRef idx="3">
-            <a:schemeClr val="accent1"/>
-          </a:fillRef>
-          <a:effectRef idx="2">
-            <a:schemeClr val="accent1"/>
-          </a:effectRef>
-          <a:fontRef idx="minor">
-            <a:schemeClr val="lt1"/>
-          </a:fontRef>
-        </p:style>
-        <p:txBody>
-          <a:bodyPr rtlCol="0" anchor="ctr"/>
-          <a:lstStyle/>
-          <a:p>
-            <a:pPr algn="ctr"/>
-          </a:p>
-        </p:txBody>
-      </p:sp>
-      <p:sp>
-        <p:nvSpPr>
-          <p:cNvPr id="22" name="TextBox 21"/>
-          <p:cNvSpPr txBox="1"/>
-          <p:nvPr/>
-        </p:nvSpPr>
-        <p:spPr>
-          <a:xfrm>
-            <a:off x="6878116" y="2011680"/>
-            <a:ext cx="2501798" cy="320040"/>
-          </a:xfrm>
-          <a:prstGeom prst="rect">
-            <a:avLst/>
-          </a:prstGeom>
-          <a:noFill/>
-        </p:spPr>
-        <p:txBody>
-          <a:bodyPr wrap="square" lIns="0" rIns="0" tIns="0" bIns="0" anchor="t">
-            <a:spAutoFit/>
-          </a:bodyPr>
-          <a:lstStyle/>
-          <a:p>
-            <a:pPr algn="ctr"/>
-            <a:r>
-              <a:rPr sz="1400" b="1">
-                <a:solidFill>
-                  <a:srgbClr val="572D26"/>
-                </a:solidFill>
-                <a:latin typeface="微软雅黑"/>
-                <a:ea typeface="微软雅黑"/>
-                <a:cs typeface="微软雅黑"/>
-              </a:rPr>
-              <a:t>CPU Pre</a:t>
-            </a:r>
-          </a:p>
-        </p:txBody>
-      </p:sp>
-      <p:sp>
-        <p:nvSpPr>
-          <p:cNvPr id="23" name="TextBox 22"/>
-          <p:cNvSpPr txBox="1"/>
-          <p:nvPr/>
-        </p:nvSpPr>
-        <p:spPr>
-          <a:xfrm>
-            <a:off x="6878116" y="2359152"/>
-            <a:ext cx="2501798" cy="274320"/>
-          </a:xfrm>
-          <a:prstGeom prst="rect">
-            <a:avLst/>
-          </a:prstGeom>
-          <a:noFill/>
-        </p:spPr>
-        <p:txBody>
-          <a:bodyPr wrap="square" lIns="0" rIns="0" tIns="0" bIns="0" anchor="t">
-            <a:spAutoFit/>
-          </a:bodyPr>
-          <a:lstStyle/>
-          <a:p>
-            <a:pPr algn="ctr"/>
-            <a:r>
-              <a:rPr sz="1200" b="0">
-                <a:solidFill>
-                  <a:srgbClr val="9A8578"/>
-                </a:solidFill>
-                <a:latin typeface="微软雅黑"/>
-                <a:ea typeface="微软雅黑"/>
-                <a:cs typeface="微软雅黑"/>
-              </a:rPr>
-              <a:t>预处理</a:t>
-            </a:r>
-          </a:p>
-        </p:txBody>
-      </p:sp>
-      <p:sp>
-        <p:nvSpPr>
-          <p:cNvPr id="24" name="TextBox 23"/>
-          <p:cNvSpPr txBox="1"/>
-          <p:nvPr/>
-        </p:nvSpPr>
-        <p:spPr>
-          <a:xfrm>
-            <a:off x="9480499" y="2103120"/>
-            <a:ext cx="265176" cy="411480"/>
-          </a:xfrm>
-          <a:prstGeom prst="rect">
-            <a:avLst/>
-          </a:prstGeom>
-          <a:noFill/>
-        </p:spPr>
-        <p:txBody>
-          <a:bodyPr wrap="square" lIns="0" rIns="0" tIns="0" bIns="0" anchor="ctr">
-            <a:spAutoFit/>
-          </a:bodyPr>
-          <a:lstStyle/>
-          <a:p>
-            <a:pPr algn="ctr"/>
-            <a:r>
-              <a:rPr sz="1800" b="1">
-                <a:solidFill>
-                  <a:srgbClr val="FF3C00"/>
-                </a:solidFill>
-                <a:latin typeface="Arial"/>
-                <a:ea typeface="Arial"/>
-                <a:cs typeface="Arial"/>
-              </a:rPr>
-              <a:t>→</a:t>
-            </a:r>
-          </a:p>
-        </p:txBody>
-      </p:sp>
-      <p:sp>
-        <p:nvSpPr>
-          <p:cNvPr id="25" name="Rounded Rectangle 24"/>
-          <p:cNvSpPr/>
-          <p:nvPr/>
-        </p:nvSpPr>
-        <p:spPr>
-          <a:xfrm>
-            <a:off x="9773107" y="1874519"/>
-            <a:ext cx="2648102" cy="960120"/>
-          </a:xfrm>
-          <a:prstGeom prst="roundRect">
-            <a:avLst>
-              <a:gd name="adj" fmla="val 8000"/>
-            </a:avLst>
-          </a:prstGeom>
-          <a:solidFill>
-            <a:srgbClr val="FFEFD9"/>
-          </a:solidFill>
-          <a:ln>
-            <a:noFill/>
-          </a:ln>
-          <a:effectLst/>
-        </p:spPr>
-        <p:style>
-          <a:lnRef idx="1">
-            <a:schemeClr val="accent1"/>
-          </a:lnRef>
-          <a:fillRef idx="3">
-            <a:schemeClr val="accent1"/>
-          </a:fillRef>
-          <a:effectRef idx="2">
-            <a:schemeClr val="accent1"/>
-          </a:effectRef>
-          <a:fontRef idx="minor">
-            <a:schemeClr val="lt1"/>
-          </a:fontRef>
-        </p:style>
-        <p:txBody>
-          <a:bodyPr rtlCol="0" anchor="ctr"/>
-          <a:lstStyle/>
-          <a:p>
-            <a:pPr algn="ctr"/>
-          </a:p>
-        </p:txBody>
-      </p:sp>
-      <p:sp>
-        <p:nvSpPr>
-          <p:cNvPr id="26" name="TextBox 25"/>
-          <p:cNvSpPr txBox="1"/>
-          <p:nvPr/>
-        </p:nvSpPr>
-        <p:spPr>
-          <a:xfrm>
-            <a:off x="9846259" y="2011680"/>
-            <a:ext cx="2501798" cy="320040"/>
-          </a:xfrm>
-          <a:prstGeom prst="rect">
-            <a:avLst/>
-          </a:prstGeom>
-          <a:noFill/>
-        </p:spPr>
-        <p:txBody>
-          <a:bodyPr wrap="square" lIns="0" rIns="0" tIns="0" bIns="0" anchor="t">
-            <a:spAutoFit/>
-          </a:bodyPr>
-          <a:lstStyle/>
-          <a:p>
-            <a:pPr algn="ctr"/>
-            <a:r>
-              <a:rPr sz="1400" b="1">
-                <a:solidFill>
-                  <a:srgbClr val="572D26"/>
-                </a:solidFill>
-                <a:latin typeface="微软雅黑"/>
-                <a:ea typeface="微软雅黑"/>
-                <a:cs typeface="微软雅黑"/>
-              </a:rPr>
-              <a:t>BPU Wait</a:t>
-            </a:r>
-          </a:p>
-        </p:txBody>
-      </p:sp>
-      <p:sp>
-        <p:nvSpPr>
-          <p:cNvPr id="27" name="TextBox 26"/>
-          <p:cNvSpPr txBox="1"/>
-          <p:nvPr/>
-        </p:nvSpPr>
-        <p:spPr>
-          <a:xfrm>
-            <a:off x="9846259" y="2359152"/>
-            <a:ext cx="2501798" cy="274320"/>
-          </a:xfrm>
-          <a:prstGeom prst="rect">
-            <a:avLst/>
-          </a:prstGeom>
-          <a:noFill/>
-        </p:spPr>
-        <p:txBody>
-          <a:bodyPr wrap="square" lIns="0" rIns="0" tIns="0" bIns="0" anchor="t">
-            <a:spAutoFit/>
-          </a:bodyPr>
-          <a:lstStyle/>
-          <a:p>
-            <a:pPr algn="ctr"/>
-            <a:r>
-              <a:rPr sz="1200" b="0">
-                <a:solidFill>
-                  <a:srgbClr val="9A8578"/>
-                </a:solidFill>
-                <a:latin typeface="微软雅黑"/>
-                <a:ea typeface="微软雅黑"/>
-                <a:cs typeface="微软雅黑"/>
-              </a:rPr>
-              <a:t>提交→完成</a:t>
-            </a:r>
-          </a:p>
-        </p:txBody>
-      </p:sp>
-      <p:sp>
-        <p:nvSpPr>
-          <p:cNvPr id="28" name="TextBox 27"/>
-          <p:cNvSpPr txBox="1"/>
-          <p:nvPr/>
-        </p:nvSpPr>
-        <p:spPr>
-          <a:xfrm>
-            <a:off x="12448641" y="2103120"/>
-            <a:ext cx="265176" cy="411480"/>
-          </a:xfrm>
-          <a:prstGeom prst="rect">
-            <a:avLst/>
-          </a:prstGeom>
-          <a:noFill/>
-        </p:spPr>
-        <p:txBody>
-          <a:bodyPr wrap="square" lIns="0" rIns="0" tIns="0" bIns="0" anchor="ctr">
-            <a:spAutoFit/>
-          </a:bodyPr>
-          <a:lstStyle/>
-          <a:p>
-            <a:pPr algn="ctr"/>
-            <a:r>
-              <a:rPr sz="1800" b="1">
-                <a:solidFill>
-                  <a:srgbClr val="FF3C00"/>
-                </a:solidFill>
-                <a:latin typeface="Arial"/>
-                <a:ea typeface="Arial"/>
-                <a:cs typeface="Arial"/>
-              </a:rPr>
-              <a:t>→</a:t>
-            </a:r>
-          </a:p>
-        </p:txBody>
-      </p:sp>
-      <p:sp>
-        <p:nvSpPr>
-          <p:cNvPr id="29" name="Rounded Rectangle 28"/>
-          <p:cNvSpPr/>
-          <p:nvPr/>
-        </p:nvSpPr>
-        <p:spPr>
-          <a:xfrm>
-            <a:off x="12741249" y="1874519"/>
-            <a:ext cx="2648102" cy="960120"/>
-          </a:xfrm>
-          <a:prstGeom prst="roundRect">
-            <a:avLst>
-              <a:gd name="adj" fmla="val 8000"/>
-            </a:avLst>
-          </a:prstGeom>
-          <a:solidFill>
-            <a:srgbClr val="FFEFD9"/>
-          </a:solidFill>
-          <a:ln>
-            <a:noFill/>
-          </a:ln>
-          <a:effectLst/>
-        </p:spPr>
-        <p:style>
-          <a:lnRef idx="1">
-            <a:schemeClr val="accent1"/>
-          </a:lnRef>
-          <a:fillRef idx="3">
-            <a:schemeClr val="accent1"/>
-          </a:fillRef>
-          <a:effectRef idx="2">
-            <a:schemeClr val="accent1"/>
-          </a:effectRef>
-          <a:fontRef idx="minor">
-            <a:schemeClr val="lt1"/>
-          </a:fontRef>
-        </p:style>
-        <p:txBody>
-          <a:bodyPr rtlCol="0" anchor="ctr"/>
-          <a:lstStyle/>
-          <a:p>
-            <a:pPr algn="ctr"/>
-          </a:p>
-        </p:txBody>
-      </p:sp>
-      <p:sp>
-        <p:nvSpPr>
-          <p:cNvPr id="30" name="TextBox 29"/>
-          <p:cNvSpPr txBox="1"/>
-          <p:nvPr/>
-        </p:nvSpPr>
-        <p:spPr>
-          <a:xfrm>
-            <a:off x="12814401" y="2011680"/>
-            <a:ext cx="2501798" cy="320040"/>
-          </a:xfrm>
-          <a:prstGeom prst="rect">
-            <a:avLst/>
-          </a:prstGeom>
-          <a:noFill/>
-        </p:spPr>
-        <p:txBody>
-          <a:bodyPr wrap="square" lIns="0" rIns="0" tIns="0" bIns="0" anchor="t">
-            <a:spAutoFit/>
-          </a:bodyPr>
-          <a:lstStyle/>
-          <a:p>
-            <a:pPr algn="ctr"/>
-            <a:r>
-              <a:rPr sz="1400" b="1">
-                <a:solidFill>
-                  <a:srgbClr val="572D26"/>
-                </a:solidFill>
-                <a:latin typeface="微软雅黑"/>
-                <a:ea typeface="微软雅黑"/>
-                <a:cs typeface="微软雅黑"/>
-              </a:rPr>
-              <a:t>Output</a:t>
-            </a:r>
-          </a:p>
-        </p:txBody>
-      </p:sp>
-      <p:sp>
-        <p:nvSpPr>
-          <p:cNvPr id="31" name="TextBox 30"/>
-          <p:cNvSpPr txBox="1"/>
-          <p:nvPr/>
-        </p:nvSpPr>
-        <p:spPr>
-          <a:xfrm>
-            <a:off x="12814401" y="2359152"/>
-            <a:ext cx="2501798" cy="274320"/>
-          </a:xfrm>
-          <a:prstGeom prst="rect">
-            <a:avLst/>
-          </a:prstGeom>
-          <a:noFill/>
-        </p:spPr>
-        <p:txBody>
-          <a:bodyPr wrap="square" lIns="0" rIns="0" tIns="0" bIns="0" anchor="t">
-            <a:spAutoFit/>
-          </a:bodyPr>
-          <a:lstStyle/>
-          <a:p>
-            <a:pPr algn="ctr"/>
-            <a:r>
-              <a:rPr sz="1200" b="0">
-                <a:solidFill>
-                  <a:srgbClr val="9A8578"/>
-                </a:solidFill>
-                <a:latin typeface="微软雅黑"/>
-                <a:ea typeface="微软雅黑"/>
-                <a:cs typeface="微软雅黑"/>
-              </a:rPr>
-              <a:t>后处理</a:t>
-            </a:r>
-          </a:p>
-        </p:txBody>
-      </p:sp>
-      <p:sp>
-        <p:nvSpPr>
-          <p:cNvPr id="32" name="TextBox 31"/>
-          <p:cNvSpPr txBox="1"/>
-          <p:nvPr/>
-        </p:nvSpPr>
-        <p:spPr>
-          <a:xfrm>
-            <a:off x="868680" y="3063240"/>
-            <a:ext cx="14520672" cy="365760"/>
-          </a:xfrm>
-          <a:prstGeom prst="rect">
-            <a:avLst/>
-          </a:prstGeom>
-          <a:noFill/>
-        </p:spPr>
-        <p:txBody>
-          <a:bodyPr wrap="square" lIns="0" rIns="0" tIns="0" bIns="0" anchor="t">
-            <a:spAutoFit/>
-          </a:bodyPr>
-          <a:lstStyle/>
-          <a:p>
-            <a:pPr algn="l"/>
-            <a:r>
-              <a:rPr sz="1400" b="0">
-                <a:solidFill>
-                  <a:srgbClr val="572D26"/>
-                </a:solidFill>
-                <a:latin typeface="微软雅黑"/>
-                <a:ea typeface="微软雅黑"/>
-                <a:cs typeface="微软雅黑"/>
-              </a:rPr>
-              <a:t>每个阶段可以跨线程、异步、并行；Frame ID / Request ID 才能关联同一个业务对象。（教学示意，非设备测量）</a:t>
-            </a:r>
-          </a:p>
-        </p:txBody>
-      </p:sp>
-      <p:sp>
-        <p:nvSpPr>
-          <p:cNvPr id="33" name="Rounded Rectangle 32"/>
-          <p:cNvSpPr/>
-          <p:nvPr/>
-        </p:nvSpPr>
-        <p:spPr>
-          <a:xfrm>
-            <a:off x="868680" y="3611880"/>
-            <a:ext cx="4657344" cy="3291840"/>
+            <a:off x="868680" y="1783080"/>
+            <a:ext cx="14520672" cy="3246120"/>
           </a:xfrm>
           <a:prstGeom prst="roundRect">
             <a:avLst>
@@ -14829,14 +14004,809 @@
       </p:sp>
       <p:sp>
         <p:nvSpPr>
+          <p:cNvPr id="14" name="TextBox 13"/>
+          <p:cNvSpPr txBox="1"/>
+          <p:nvPr/>
+        </p:nvSpPr>
+        <p:spPr>
+          <a:xfrm>
+            <a:off x="1188720" y="2011680"/>
+            <a:ext cx="10972800" cy="365760"/>
+          </a:xfrm>
+          <a:prstGeom prst="rect">
+            <a:avLst/>
+          </a:prstGeom>
+          <a:noFill/>
+        </p:spPr>
+        <p:txBody>
+          <a:bodyPr wrap="square" lIns="0" rIns="0" tIns="0" bIns="0" anchor="t">
+            <a:spAutoFit/>
+          </a:bodyPr>
+          <a:lstStyle/>
+          <a:p>
+            <a:pPr algn="l"/>
+            <a:r>
+              <a:rPr sz="2100" b="1">
+                <a:solidFill>
+                  <a:srgbClr val="572D26"/>
+                </a:solidFill>
+                <a:latin typeface="微软雅黑"/>
+                <a:ea typeface="微软雅黑"/>
+                <a:cs typeface="微软雅黑"/>
+              </a:rPr>
+              <a:t>示例：Frame #1024 的业务处理链路（非实测）</a:t>
+            </a:r>
+          </a:p>
+        </p:txBody>
+      </p:sp>
+      <p:sp>
+        <p:nvSpPr>
+          <p:cNvPr id="15" name="Rounded Rectangle 14"/>
+          <p:cNvSpPr/>
+          <p:nvPr/>
+        </p:nvSpPr>
+        <p:spPr>
+          <a:xfrm>
+            <a:off x="1188720" y="2651760"/>
+            <a:ext cx="2538374" cy="1097280"/>
+          </a:xfrm>
+          <a:prstGeom prst="roundRect">
+            <a:avLst>
+              <a:gd name="adj" fmla="val 10000"/>
+            </a:avLst>
+          </a:prstGeom>
+          <a:solidFill>
+            <a:srgbClr val="FFFFFF"/>
+          </a:solidFill>
+          <a:ln w="17780">
+            <a:solidFill>
+              <a:srgbClr val="FF3C00"/>
+            </a:solidFill>
+          </a:ln>
+          <a:effectLst/>
+        </p:spPr>
+        <p:style>
+          <a:lnRef idx="1">
+            <a:schemeClr val="accent1"/>
+          </a:lnRef>
+          <a:fillRef idx="3">
+            <a:schemeClr val="accent1"/>
+          </a:fillRef>
+          <a:effectRef idx="2">
+            <a:schemeClr val="accent1"/>
+          </a:effectRef>
+          <a:fontRef idx="minor">
+            <a:schemeClr val="lt1"/>
+          </a:fontRef>
+        </p:style>
+        <p:txBody>
+          <a:bodyPr rtlCol="0" anchor="ctr"/>
+          <a:lstStyle/>
+          <a:p>
+            <a:pPr algn="ctr"/>
+          </a:p>
+        </p:txBody>
+      </p:sp>
+      <p:sp>
+        <p:nvSpPr>
+          <p:cNvPr id="16" name="TextBox 15"/>
+          <p:cNvSpPr txBox="1"/>
+          <p:nvPr/>
+        </p:nvSpPr>
+        <p:spPr>
+          <a:xfrm>
+            <a:off x="1188720" y="2816352"/>
+            <a:ext cx="2538374" cy="365760"/>
+          </a:xfrm>
+          <a:prstGeom prst="rect">
+            <a:avLst/>
+          </a:prstGeom>
+          <a:noFill/>
+        </p:spPr>
+        <p:txBody>
+          <a:bodyPr wrap="square" lIns="0" rIns="0" tIns="0" bIns="0" anchor="t">
+            <a:spAutoFit/>
+          </a:bodyPr>
+          <a:lstStyle/>
+          <a:p>
+            <a:pPr algn="ctr"/>
+            <a:r>
+              <a:rPr sz="1800" b="1">
+                <a:solidFill>
+                  <a:srgbClr val="FF3C00"/>
+                </a:solidFill>
+                <a:latin typeface="微软雅黑"/>
+                <a:ea typeface="微软雅黑"/>
+                <a:cs typeface="微软雅黑"/>
+              </a:rPr>
+              <a:t>Camera</a:t>
+            </a:r>
+          </a:p>
+        </p:txBody>
+      </p:sp>
+      <p:sp>
+        <p:nvSpPr>
+          <p:cNvPr id="17" name="TextBox 16"/>
+          <p:cNvSpPr txBox="1"/>
+          <p:nvPr/>
+        </p:nvSpPr>
+        <p:spPr>
+          <a:xfrm>
+            <a:off x="1188720" y="3246120"/>
+            <a:ext cx="2538374" cy="320040"/>
+          </a:xfrm>
+          <a:prstGeom prst="rect">
+            <a:avLst/>
+          </a:prstGeom>
+          <a:noFill/>
+        </p:spPr>
+        <p:txBody>
+          <a:bodyPr wrap="square" lIns="0" rIns="0" tIns="0" bIns="0" anchor="t">
+            <a:spAutoFit/>
+          </a:bodyPr>
+          <a:lstStyle/>
+          <a:p>
+            <a:pPr algn="ctr"/>
+            <a:r>
+              <a:rPr sz="1200" b="0">
+                <a:solidFill>
+                  <a:srgbClr val="9A8578"/>
+                </a:solidFill>
+                <a:latin typeface="微软雅黑"/>
+                <a:ea typeface="微软雅黑"/>
+                <a:cs typeface="微软雅黑"/>
+              </a:rPr>
+              <a:t>输入帧</a:t>
+            </a:r>
+          </a:p>
+        </p:txBody>
+      </p:sp>
+      <p:sp>
+        <p:nvSpPr>
+          <p:cNvPr id="18" name="TextBox 17"/>
+          <p:cNvSpPr txBox="1"/>
+          <p:nvPr/>
+        </p:nvSpPr>
+        <p:spPr>
+          <a:xfrm>
+            <a:off x="3763670" y="2971800"/>
+            <a:ext cx="246888" cy="411480"/>
+          </a:xfrm>
+          <a:prstGeom prst="rect">
+            <a:avLst/>
+          </a:prstGeom>
+          <a:noFill/>
+        </p:spPr>
+        <p:txBody>
+          <a:bodyPr wrap="square" lIns="0" rIns="0" tIns="0" bIns="0" anchor="ctr">
+            <a:spAutoFit/>
+          </a:bodyPr>
+          <a:lstStyle/>
+          <a:p>
+            <a:pPr algn="ctr"/>
+            <a:r>
+              <a:rPr sz="1800" b="1">
+                <a:solidFill>
+                  <a:srgbClr val="FF3C00"/>
+                </a:solidFill>
+                <a:latin typeface="Arial"/>
+                <a:ea typeface="Arial"/>
+                <a:cs typeface="Arial"/>
+              </a:rPr>
+              <a:t>→</a:t>
+            </a:r>
+          </a:p>
+        </p:txBody>
+      </p:sp>
+      <p:sp>
+        <p:nvSpPr>
+          <p:cNvPr id="19" name="Rounded Rectangle 18"/>
+          <p:cNvSpPr/>
+          <p:nvPr/>
+        </p:nvSpPr>
+        <p:spPr>
+          <a:xfrm>
+            <a:off x="4047134" y="2651760"/>
+            <a:ext cx="2538374" cy="1097280"/>
+          </a:xfrm>
+          <a:prstGeom prst="roundRect">
+            <a:avLst>
+              <a:gd name="adj" fmla="val 10000"/>
+            </a:avLst>
+          </a:prstGeom>
+          <a:solidFill>
+            <a:srgbClr val="FFFFFF"/>
+          </a:solidFill>
+          <a:ln w="17780">
+            <a:solidFill>
+              <a:srgbClr val="FF3C00"/>
+            </a:solidFill>
+          </a:ln>
+          <a:effectLst/>
+        </p:spPr>
+        <p:style>
+          <a:lnRef idx="1">
+            <a:schemeClr val="accent1"/>
+          </a:lnRef>
+          <a:fillRef idx="3">
+            <a:schemeClr val="accent1"/>
+          </a:fillRef>
+          <a:effectRef idx="2">
+            <a:schemeClr val="accent1"/>
+          </a:effectRef>
+          <a:fontRef idx="minor">
+            <a:schemeClr val="lt1"/>
+          </a:fontRef>
+        </p:style>
+        <p:txBody>
+          <a:bodyPr rtlCol="0" anchor="ctr"/>
+          <a:lstStyle/>
+          <a:p>
+            <a:pPr algn="ctr"/>
+          </a:p>
+        </p:txBody>
+      </p:sp>
+      <p:sp>
+        <p:nvSpPr>
+          <p:cNvPr id="20" name="TextBox 19"/>
+          <p:cNvSpPr txBox="1"/>
+          <p:nvPr/>
+        </p:nvSpPr>
+        <p:spPr>
+          <a:xfrm>
+            <a:off x="4047134" y="2816352"/>
+            <a:ext cx="2538374" cy="365760"/>
+          </a:xfrm>
+          <a:prstGeom prst="rect">
+            <a:avLst/>
+          </a:prstGeom>
+          <a:noFill/>
+        </p:spPr>
+        <p:txBody>
+          <a:bodyPr wrap="square" lIns="0" rIns="0" tIns="0" bIns="0" anchor="t">
+            <a:spAutoFit/>
+          </a:bodyPr>
+          <a:lstStyle/>
+          <a:p>
+            <a:pPr algn="ctr"/>
+            <a:r>
+              <a:rPr sz="1800" b="1">
+                <a:solidFill>
+                  <a:srgbClr val="FF3C00"/>
+                </a:solidFill>
+                <a:latin typeface="微软雅黑"/>
+                <a:ea typeface="微软雅黑"/>
+                <a:cs typeface="微软雅黑"/>
+              </a:rPr>
+              <a:t>Queue</a:t>
+            </a:r>
+          </a:p>
+        </p:txBody>
+      </p:sp>
+      <p:sp>
+        <p:nvSpPr>
+          <p:cNvPr id="21" name="TextBox 20"/>
+          <p:cNvSpPr txBox="1"/>
+          <p:nvPr/>
+        </p:nvSpPr>
+        <p:spPr>
+          <a:xfrm>
+            <a:off x="4047134" y="3246120"/>
+            <a:ext cx="2538374" cy="320040"/>
+          </a:xfrm>
+          <a:prstGeom prst="rect">
+            <a:avLst/>
+          </a:prstGeom>
+          <a:noFill/>
+        </p:spPr>
+        <p:txBody>
+          <a:bodyPr wrap="square" lIns="0" rIns="0" tIns="0" bIns="0" anchor="t">
+            <a:spAutoFit/>
+          </a:bodyPr>
+          <a:lstStyle/>
+          <a:p>
+            <a:pPr algn="ctr"/>
+            <a:r>
+              <a:rPr sz="1200" b="0">
+                <a:solidFill>
+                  <a:srgbClr val="9A8578"/>
+                </a:solidFill>
+                <a:latin typeface="微软雅黑"/>
+                <a:ea typeface="微软雅黑"/>
+                <a:cs typeface="微软雅黑"/>
+              </a:rPr>
+              <a:t>排队</a:t>
+            </a:r>
+          </a:p>
+        </p:txBody>
+      </p:sp>
+      <p:sp>
+        <p:nvSpPr>
+          <p:cNvPr id="22" name="TextBox 21"/>
+          <p:cNvSpPr txBox="1"/>
+          <p:nvPr/>
+        </p:nvSpPr>
+        <p:spPr>
+          <a:xfrm>
+            <a:off x="6622084" y="2971800"/>
+            <a:ext cx="246888" cy="411480"/>
+          </a:xfrm>
+          <a:prstGeom prst="rect">
+            <a:avLst/>
+          </a:prstGeom>
+          <a:noFill/>
+        </p:spPr>
+        <p:txBody>
+          <a:bodyPr wrap="square" lIns="0" rIns="0" tIns="0" bIns="0" anchor="ctr">
+            <a:spAutoFit/>
+          </a:bodyPr>
+          <a:lstStyle/>
+          <a:p>
+            <a:pPr algn="ctr"/>
+            <a:r>
+              <a:rPr sz="1800" b="1">
+                <a:solidFill>
+                  <a:srgbClr val="FF3C00"/>
+                </a:solidFill>
+                <a:latin typeface="Arial"/>
+                <a:ea typeface="Arial"/>
+                <a:cs typeface="Arial"/>
+              </a:rPr>
+              <a:t>→</a:t>
+            </a:r>
+          </a:p>
+        </p:txBody>
+      </p:sp>
+      <p:sp>
+        <p:nvSpPr>
+          <p:cNvPr id="23" name="Rounded Rectangle 22"/>
+          <p:cNvSpPr/>
+          <p:nvPr/>
+        </p:nvSpPr>
+        <p:spPr>
+          <a:xfrm>
+            <a:off x="6905548" y="2651760"/>
+            <a:ext cx="2538374" cy="1097280"/>
+          </a:xfrm>
+          <a:prstGeom prst="roundRect">
+            <a:avLst>
+              <a:gd name="adj" fmla="val 10000"/>
+            </a:avLst>
+          </a:prstGeom>
+          <a:solidFill>
+            <a:srgbClr val="FFFFFF"/>
+          </a:solidFill>
+          <a:ln w="17780">
+            <a:solidFill>
+              <a:srgbClr val="FF3C00"/>
+            </a:solidFill>
+          </a:ln>
+          <a:effectLst/>
+        </p:spPr>
+        <p:style>
+          <a:lnRef idx="1">
+            <a:schemeClr val="accent1"/>
+          </a:lnRef>
+          <a:fillRef idx="3">
+            <a:schemeClr val="accent1"/>
+          </a:fillRef>
+          <a:effectRef idx="2">
+            <a:schemeClr val="accent1"/>
+          </a:effectRef>
+          <a:fontRef idx="minor">
+            <a:schemeClr val="lt1"/>
+          </a:fontRef>
+        </p:style>
+        <p:txBody>
+          <a:bodyPr rtlCol="0" anchor="ctr"/>
+          <a:lstStyle/>
+          <a:p>
+            <a:pPr algn="ctr"/>
+          </a:p>
+        </p:txBody>
+      </p:sp>
+      <p:sp>
+        <p:nvSpPr>
+          <p:cNvPr id="24" name="TextBox 23"/>
+          <p:cNvSpPr txBox="1"/>
+          <p:nvPr/>
+        </p:nvSpPr>
+        <p:spPr>
+          <a:xfrm>
+            <a:off x="6905548" y="2816352"/>
+            <a:ext cx="2538374" cy="365760"/>
+          </a:xfrm>
+          <a:prstGeom prst="rect">
+            <a:avLst/>
+          </a:prstGeom>
+          <a:noFill/>
+        </p:spPr>
+        <p:txBody>
+          <a:bodyPr wrap="square" lIns="0" rIns="0" tIns="0" bIns="0" anchor="t">
+            <a:spAutoFit/>
+          </a:bodyPr>
+          <a:lstStyle/>
+          <a:p>
+            <a:pPr algn="ctr"/>
+            <a:r>
+              <a:rPr sz="1800" b="1">
+                <a:solidFill>
+                  <a:srgbClr val="FF3C00"/>
+                </a:solidFill>
+                <a:latin typeface="微软雅黑"/>
+                <a:ea typeface="微软雅黑"/>
+                <a:cs typeface="微软雅黑"/>
+              </a:rPr>
+              <a:t>CPU Pre</a:t>
+            </a:r>
+          </a:p>
+        </p:txBody>
+      </p:sp>
+      <p:sp>
+        <p:nvSpPr>
+          <p:cNvPr id="25" name="TextBox 24"/>
+          <p:cNvSpPr txBox="1"/>
+          <p:nvPr/>
+        </p:nvSpPr>
+        <p:spPr>
+          <a:xfrm>
+            <a:off x="6905548" y="3246120"/>
+            <a:ext cx="2538374" cy="320040"/>
+          </a:xfrm>
+          <a:prstGeom prst="rect">
+            <a:avLst/>
+          </a:prstGeom>
+          <a:noFill/>
+        </p:spPr>
+        <p:txBody>
+          <a:bodyPr wrap="square" lIns="0" rIns="0" tIns="0" bIns="0" anchor="t">
+            <a:spAutoFit/>
+          </a:bodyPr>
+          <a:lstStyle/>
+          <a:p>
+            <a:pPr algn="ctr"/>
+            <a:r>
+              <a:rPr sz="1200" b="0">
+                <a:solidFill>
+                  <a:srgbClr val="9A8578"/>
+                </a:solidFill>
+                <a:latin typeface="微软雅黑"/>
+                <a:ea typeface="微软雅黑"/>
+                <a:cs typeface="微软雅黑"/>
+              </a:rPr>
+              <a:t>预处理</a:t>
+            </a:r>
+          </a:p>
+        </p:txBody>
+      </p:sp>
+      <p:sp>
+        <p:nvSpPr>
+          <p:cNvPr id="26" name="TextBox 25"/>
+          <p:cNvSpPr txBox="1"/>
+          <p:nvPr/>
+        </p:nvSpPr>
+        <p:spPr>
+          <a:xfrm>
+            <a:off x="9480499" y="2971800"/>
+            <a:ext cx="246888" cy="411480"/>
+          </a:xfrm>
+          <a:prstGeom prst="rect">
+            <a:avLst/>
+          </a:prstGeom>
+          <a:noFill/>
+        </p:spPr>
+        <p:txBody>
+          <a:bodyPr wrap="square" lIns="0" rIns="0" tIns="0" bIns="0" anchor="ctr">
+            <a:spAutoFit/>
+          </a:bodyPr>
+          <a:lstStyle/>
+          <a:p>
+            <a:pPr algn="ctr"/>
+            <a:r>
+              <a:rPr sz="1800" b="1">
+                <a:solidFill>
+                  <a:srgbClr val="FF3C00"/>
+                </a:solidFill>
+                <a:latin typeface="Arial"/>
+                <a:ea typeface="Arial"/>
+                <a:cs typeface="Arial"/>
+              </a:rPr>
+              <a:t>→</a:t>
+            </a:r>
+          </a:p>
+        </p:txBody>
+      </p:sp>
+      <p:sp>
+        <p:nvSpPr>
+          <p:cNvPr id="27" name="Rounded Rectangle 26"/>
+          <p:cNvSpPr/>
+          <p:nvPr/>
+        </p:nvSpPr>
+        <p:spPr>
+          <a:xfrm>
+            <a:off x="9763963" y="2651760"/>
+            <a:ext cx="2538374" cy="1097280"/>
+          </a:xfrm>
+          <a:prstGeom prst="roundRect">
+            <a:avLst>
+              <a:gd name="adj" fmla="val 10000"/>
+            </a:avLst>
+          </a:prstGeom>
+          <a:solidFill>
+            <a:srgbClr val="FFFFFF"/>
+          </a:solidFill>
+          <a:ln w="17780">
+            <a:solidFill>
+              <a:srgbClr val="FF3C00"/>
+            </a:solidFill>
+          </a:ln>
+          <a:effectLst/>
+        </p:spPr>
+        <p:style>
+          <a:lnRef idx="1">
+            <a:schemeClr val="accent1"/>
+          </a:lnRef>
+          <a:fillRef idx="3">
+            <a:schemeClr val="accent1"/>
+          </a:fillRef>
+          <a:effectRef idx="2">
+            <a:schemeClr val="accent1"/>
+          </a:effectRef>
+          <a:fontRef idx="minor">
+            <a:schemeClr val="lt1"/>
+          </a:fontRef>
+        </p:style>
+        <p:txBody>
+          <a:bodyPr rtlCol="0" anchor="ctr"/>
+          <a:lstStyle/>
+          <a:p>
+            <a:pPr algn="ctr"/>
+          </a:p>
+        </p:txBody>
+      </p:sp>
+      <p:sp>
+        <p:nvSpPr>
+          <p:cNvPr id="28" name="TextBox 27"/>
+          <p:cNvSpPr txBox="1"/>
+          <p:nvPr/>
+        </p:nvSpPr>
+        <p:spPr>
+          <a:xfrm>
+            <a:off x="9763963" y="2816352"/>
+            <a:ext cx="2538374" cy="365760"/>
+          </a:xfrm>
+          <a:prstGeom prst="rect">
+            <a:avLst/>
+          </a:prstGeom>
+          <a:noFill/>
+        </p:spPr>
+        <p:txBody>
+          <a:bodyPr wrap="square" lIns="0" rIns="0" tIns="0" bIns="0" anchor="t">
+            <a:spAutoFit/>
+          </a:bodyPr>
+          <a:lstStyle/>
+          <a:p>
+            <a:pPr algn="ctr"/>
+            <a:r>
+              <a:rPr sz="1800" b="1">
+                <a:solidFill>
+                  <a:srgbClr val="FF3C00"/>
+                </a:solidFill>
+                <a:latin typeface="微软雅黑"/>
+                <a:ea typeface="微软雅黑"/>
+                <a:cs typeface="微软雅黑"/>
+              </a:rPr>
+              <a:t>BPU Wait</a:t>
+            </a:r>
+          </a:p>
+        </p:txBody>
+      </p:sp>
+      <p:sp>
+        <p:nvSpPr>
+          <p:cNvPr id="29" name="TextBox 28"/>
+          <p:cNvSpPr txBox="1"/>
+          <p:nvPr/>
+        </p:nvSpPr>
+        <p:spPr>
+          <a:xfrm>
+            <a:off x="9763963" y="3246120"/>
+            <a:ext cx="2538374" cy="320040"/>
+          </a:xfrm>
+          <a:prstGeom prst="rect">
+            <a:avLst/>
+          </a:prstGeom>
+          <a:noFill/>
+        </p:spPr>
+        <p:txBody>
+          <a:bodyPr wrap="square" lIns="0" rIns="0" tIns="0" bIns="0" anchor="t">
+            <a:spAutoFit/>
+          </a:bodyPr>
+          <a:lstStyle/>
+          <a:p>
+            <a:pPr algn="ctr"/>
+            <a:r>
+              <a:rPr sz="1200" b="0">
+                <a:solidFill>
+                  <a:srgbClr val="9A8578"/>
+                </a:solidFill>
+                <a:latin typeface="微软雅黑"/>
+                <a:ea typeface="微软雅黑"/>
+                <a:cs typeface="微软雅黑"/>
+              </a:rPr>
+              <a:t>提交→完成</a:t>
+            </a:r>
+          </a:p>
+        </p:txBody>
+      </p:sp>
+      <p:sp>
+        <p:nvSpPr>
+          <p:cNvPr id="30" name="TextBox 29"/>
+          <p:cNvSpPr txBox="1"/>
+          <p:nvPr/>
+        </p:nvSpPr>
+        <p:spPr>
+          <a:xfrm>
+            <a:off x="12338913" y="2971800"/>
+            <a:ext cx="246888" cy="411480"/>
+          </a:xfrm>
+          <a:prstGeom prst="rect">
+            <a:avLst/>
+          </a:prstGeom>
+          <a:noFill/>
+        </p:spPr>
+        <p:txBody>
+          <a:bodyPr wrap="square" lIns="0" rIns="0" tIns="0" bIns="0" anchor="ctr">
+            <a:spAutoFit/>
+          </a:bodyPr>
+          <a:lstStyle/>
+          <a:p>
+            <a:pPr algn="ctr"/>
+            <a:r>
+              <a:rPr sz="1800" b="1">
+                <a:solidFill>
+                  <a:srgbClr val="FF3C00"/>
+                </a:solidFill>
+                <a:latin typeface="Arial"/>
+                <a:ea typeface="Arial"/>
+                <a:cs typeface="Arial"/>
+              </a:rPr>
+              <a:t>→</a:t>
+            </a:r>
+          </a:p>
+        </p:txBody>
+      </p:sp>
+      <p:sp>
+        <p:nvSpPr>
+          <p:cNvPr id="31" name="Rounded Rectangle 30"/>
+          <p:cNvSpPr/>
+          <p:nvPr/>
+        </p:nvSpPr>
+        <p:spPr>
+          <a:xfrm>
+            <a:off x="12622377" y="2651760"/>
+            <a:ext cx="2538374" cy="1097280"/>
+          </a:xfrm>
+          <a:prstGeom prst="roundRect">
+            <a:avLst>
+              <a:gd name="adj" fmla="val 10000"/>
+            </a:avLst>
+          </a:prstGeom>
+          <a:solidFill>
+            <a:srgbClr val="FFFFFF"/>
+          </a:solidFill>
+          <a:ln w="17780">
+            <a:solidFill>
+              <a:srgbClr val="FF3C00"/>
+            </a:solidFill>
+          </a:ln>
+          <a:effectLst/>
+        </p:spPr>
+        <p:style>
+          <a:lnRef idx="1">
+            <a:schemeClr val="accent1"/>
+          </a:lnRef>
+          <a:fillRef idx="3">
+            <a:schemeClr val="accent1"/>
+          </a:fillRef>
+          <a:effectRef idx="2">
+            <a:schemeClr val="accent1"/>
+          </a:effectRef>
+          <a:fontRef idx="minor">
+            <a:schemeClr val="lt1"/>
+          </a:fontRef>
+        </p:style>
+        <p:txBody>
+          <a:bodyPr rtlCol="0" anchor="ctr"/>
+          <a:lstStyle/>
+          <a:p>
+            <a:pPr algn="ctr"/>
+          </a:p>
+        </p:txBody>
+      </p:sp>
+      <p:sp>
+        <p:nvSpPr>
+          <p:cNvPr id="32" name="TextBox 31"/>
+          <p:cNvSpPr txBox="1"/>
+          <p:nvPr/>
+        </p:nvSpPr>
+        <p:spPr>
+          <a:xfrm>
+            <a:off x="12622377" y="2816352"/>
+            <a:ext cx="2538374" cy="365760"/>
+          </a:xfrm>
+          <a:prstGeom prst="rect">
+            <a:avLst/>
+          </a:prstGeom>
+          <a:noFill/>
+        </p:spPr>
+        <p:txBody>
+          <a:bodyPr wrap="square" lIns="0" rIns="0" tIns="0" bIns="0" anchor="t">
+            <a:spAutoFit/>
+          </a:bodyPr>
+          <a:lstStyle/>
+          <a:p>
+            <a:pPr algn="ctr"/>
+            <a:r>
+              <a:rPr sz="1800" b="1">
+                <a:solidFill>
+                  <a:srgbClr val="FF3C00"/>
+                </a:solidFill>
+                <a:latin typeface="微软雅黑"/>
+                <a:ea typeface="微软雅黑"/>
+                <a:cs typeface="微软雅黑"/>
+              </a:rPr>
+              <a:t>Output</a:t>
+            </a:r>
+          </a:p>
+        </p:txBody>
+      </p:sp>
+      <p:sp>
+        <p:nvSpPr>
+          <p:cNvPr id="33" name="TextBox 32"/>
+          <p:cNvSpPr txBox="1"/>
+          <p:nvPr/>
+        </p:nvSpPr>
+        <p:spPr>
+          <a:xfrm>
+            <a:off x="12622377" y="3246120"/>
+            <a:ext cx="2538374" cy="320040"/>
+          </a:xfrm>
+          <a:prstGeom prst="rect">
+            <a:avLst/>
+          </a:prstGeom>
+          <a:noFill/>
+        </p:spPr>
+        <p:txBody>
+          <a:bodyPr wrap="square" lIns="0" rIns="0" tIns="0" bIns="0" anchor="t">
+            <a:spAutoFit/>
+          </a:bodyPr>
+          <a:lstStyle/>
+          <a:p>
+            <a:pPr algn="ctr"/>
+            <a:r>
+              <a:rPr sz="1200" b="0">
+                <a:solidFill>
+                  <a:srgbClr val="9A8578"/>
+                </a:solidFill>
+                <a:latin typeface="微软雅黑"/>
+                <a:ea typeface="微软雅黑"/>
+                <a:cs typeface="微软雅黑"/>
+              </a:rPr>
+              <a:t>后处理</a:t>
+            </a:r>
+          </a:p>
+        </p:txBody>
+      </p:sp>
+      <p:sp>
+        <p:nvSpPr>
           <p:cNvPr id="34" name="TextBox 33"/>
           <p:cNvSpPr txBox="1"/>
           <p:nvPr/>
         </p:nvSpPr>
         <p:spPr>
           <a:xfrm>
-            <a:off x="1143000" y="3886200"/>
-            <a:ext cx="4108704" cy="365760"/>
+            <a:off x="1188720" y="4069080"/>
+            <a:ext cx="13880592" cy="411480"/>
           </a:xfrm>
           <a:prstGeom prst="rect">
             <a:avLst/>
@@ -14849,50 +14819,9 @@
           </a:bodyPr>
           <a:lstStyle/>
           <a:p>
-            <a:pPr algn="l"/>
-            <a:r>
-              <a:rPr sz="1800" b="1">
-                <a:solidFill>
-                  <a:srgbClr val="FF3C00"/>
-                </a:solidFill>
-                <a:latin typeface="微软雅黑"/>
-                <a:ea typeface="微软雅黑"/>
-                <a:cs typeface="微软雅黑"/>
-              </a:rPr>
-              <a:t>端到端时延</a:t>
-            </a:r>
-          </a:p>
-        </p:txBody>
-      </p:sp>
-      <p:sp>
-        <p:nvSpPr>
-          <p:cNvPr id="35" name="TextBox 34"/>
-          <p:cNvSpPr txBox="1"/>
-          <p:nvPr/>
-        </p:nvSpPr>
-        <p:spPr>
-          <a:xfrm>
-            <a:off x="1143000" y="4389120"/>
-            <a:ext cx="4108704" cy="1463040"/>
-          </a:xfrm>
-          <a:prstGeom prst="rect">
-            <a:avLst/>
-          </a:prstGeom>
-          <a:noFill/>
-        </p:spPr>
-        <p:txBody>
-          <a:bodyPr wrap="square" lIns="0" rIns="0" tIns="0" bIns="0" anchor="t">
-            <a:spAutoFit/>
-          </a:bodyPr>
-          <a:lstStyle/>
-          <a:p>
-            <a:pPr algn="l">
-              <a:lnSpc>
-                <a:spcPct val="130000"/>
-              </a:lnSpc>
-            </a:pPr>
-            <a:r>
-              <a:rPr sz="1400" b="0">
+            <a:pPr algn="ctr"/>
+            <a:r>
+              <a:rPr sz="1400" b="1">
                 <a:solidFill>
                   <a:srgbClr val="572D26"/>
                 </a:solidFill>
@@ -14900,21 +14829,21 @@
                 <a:ea typeface="微软雅黑"/>
                 <a:cs typeface="微软雅黑"/>
               </a:rPr>
-              <a:t>输入 → 输出经历多长时间</a:t>
-            </a:r>
-          </a:p>
-        </p:txBody>
-      </p:sp>
-      <p:sp>
-        <p:nvSpPr>
-          <p:cNvPr id="36" name="Rounded Rectangle 35"/>
+              <a:t>每个阶段可以跨线程、异步、并行；Frame ID / Request ID 才能关联同一个业务对象。</a:t>
+            </a:r>
+          </a:p>
+        </p:txBody>
+      </p:sp>
+      <p:sp>
+        <p:nvSpPr>
+          <p:cNvPr id="35" name="Rounded Rectangle 34"/>
           <p:cNvSpPr/>
           <p:nvPr/>
         </p:nvSpPr>
         <p:spPr>
           <a:xfrm>
-            <a:off x="5800344" y="3611880"/>
-            <a:ext cx="4657344" cy="3291840"/>
+            <a:off x="868680" y="5303520"/>
+            <a:ext cx="4657344" cy="1554480"/>
           </a:xfrm>
           <a:prstGeom prst="roundRect">
             <a:avLst>
@@ -14953,14 +14882,51 @@
       </p:sp>
       <p:sp>
         <p:nvSpPr>
+          <p:cNvPr id="36" name="TextBox 35"/>
+          <p:cNvSpPr txBox="1"/>
+          <p:nvPr/>
+        </p:nvSpPr>
+        <p:spPr>
+          <a:xfrm>
+            <a:off x="868680" y="5532120"/>
+            <a:ext cx="4657344" cy="365760"/>
+          </a:xfrm>
+          <a:prstGeom prst="rect">
+            <a:avLst/>
+          </a:prstGeom>
+          <a:noFill/>
+        </p:spPr>
+        <p:txBody>
+          <a:bodyPr wrap="square" lIns="0" rIns="0" tIns="0" bIns="0" anchor="t">
+            <a:spAutoFit/>
+          </a:bodyPr>
+          <a:lstStyle/>
+          <a:p>
+            <a:pPr algn="ctr"/>
+            <a:r>
+              <a:rPr sz="1800" b="1">
+                <a:solidFill>
+                  <a:srgbClr val="FF3C00"/>
+                </a:solidFill>
+                <a:latin typeface="微软雅黑"/>
+                <a:ea typeface="微软雅黑"/>
+                <a:cs typeface="微软雅黑"/>
+              </a:rPr>
+              <a:t>端到端时延</a:t>
+            </a:r>
+          </a:p>
+        </p:txBody>
+      </p:sp>
+      <p:sp>
+        <p:nvSpPr>
           <p:cNvPr id="37" name="TextBox 36"/>
           <p:cNvSpPr txBox="1"/>
           <p:nvPr/>
         </p:nvSpPr>
         <p:spPr>
           <a:xfrm>
-            <a:off x="6074664" y="3886200"/>
-            <a:ext cx="4108704" cy="365760"/>
+            <a:off x="1051560" y="5989320"/>
+            <a:ext cx="4291584" cy="411480"/>
           </a:xfrm>
           <a:prstGeom prst="rect">
             <a:avLst/>
@@ -14973,48 +14939,7 @@
           </a:bodyPr>
           <a:lstStyle/>
           <a:p>
-            <a:pPr algn="l"/>
-            <a:r>
-              <a:rPr sz="1800" b="1">
-                <a:solidFill>
-                  <a:srgbClr val="FF3C00"/>
-                </a:solidFill>
-                <a:latin typeface="微软雅黑"/>
-                <a:ea typeface="微软雅黑"/>
-                <a:cs typeface="微软雅黑"/>
-              </a:rPr>
-              <a:t>阶段与队列</a:t>
-            </a:r>
-          </a:p>
-        </p:txBody>
-      </p:sp>
-      <p:sp>
-        <p:nvSpPr>
-          <p:cNvPr id="38" name="TextBox 37"/>
-          <p:cNvSpPr txBox="1"/>
-          <p:nvPr/>
-        </p:nvSpPr>
-        <p:spPr>
-          <a:xfrm>
-            <a:off x="6074664" y="4389120"/>
-            <a:ext cx="4108704" cy="1463040"/>
-          </a:xfrm>
-          <a:prstGeom prst="rect">
-            <a:avLst/>
-          </a:prstGeom>
-          <a:noFill/>
-        </p:spPr>
-        <p:txBody>
-          <a:bodyPr wrap="square" lIns="0" rIns="0" tIns="0" bIns="0" anchor="t">
-            <a:spAutoFit/>
-          </a:bodyPr>
-          <a:lstStyle/>
-          <a:p>
-            <a:pPr algn="l">
-              <a:lnSpc>
-                <a:spcPct val="130000"/>
-              </a:lnSpc>
-            </a:pPr>
+            <a:pPr algn="ctr"/>
             <a:r>
               <a:rPr sz="1400" b="0">
                 <a:solidFill>
@@ -15024,21 +14949,21 @@
                 <a:ea typeface="微软雅黑"/>
                 <a:cs typeface="微软雅黑"/>
               </a:rPr>
-              <a:t>时间主要消耗在哪一段</a:t>
-            </a:r>
-          </a:p>
-        </p:txBody>
-      </p:sp>
-      <p:sp>
-        <p:nvSpPr>
-          <p:cNvPr id="39" name="Rounded Rectangle 38"/>
+              <a:t>输入 → 输出经历多长时间</a:t>
+            </a:r>
+          </a:p>
+        </p:txBody>
+      </p:sp>
+      <p:sp>
+        <p:nvSpPr>
+          <p:cNvPr id="38" name="Rounded Rectangle 37"/>
           <p:cNvSpPr/>
           <p:nvPr/>
         </p:nvSpPr>
         <p:spPr>
           <a:xfrm>
-            <a:off x="10732008" y="3611880"/>
-            <a:ext cx="4657344" cy="3291840"/>
+            <a:off x="5800344" y="5303520"/>
+            <a:ext cx="4657344" cy="1554480"/>
           </a:xfrm>
           <a:prstGeom prst="roundRect">
             <a:avLst>
@@ -15077,14 +15002,51 @@
       </p:sp>
       <p:sp>
         <p:nvSpPr>
+          <p:cNvPr id="39" name="TextBox 38"/>
+          <p:cNvSpPr txBox="1"/>
+          <p:nvPr/>
+        </p:nvSpPr>
+        <p:spPr>
+          <a:xfrm>
+            <a:off x="5800344" y="5532120"/>
+            <a:ext cx="4657344" cy="365760"/>
+          </a:xfrm>
+          <a:prstGeom prst="rect">
+            <a:avLst/>
+          </a:prstGeom>
+          <a:noFill/>
+        </p:spPr>
+        <p:txBody>
+          <a:bodyPr wrap="square" lIns="0" rIns="0" tIns="0" bIns="0" anchor="t">
+            <a:spAutoFit/>
+          </a:bodyPr>
+          <a:lstStyle/>
+          <a:p>
+            <a:pPr algn="ctr"/>
+            <a:r>
+              <a:rPr sz="1800" b="1">
+                <a:solidFill>
+                  <a:srgbClr val="FF3C00"/>
+                </a:solidFill>
+                <a:latin typeface="微软雅黑"/>
+                <a:ea typeface="微软雅黑"/>
+                <a:cs typeface="微软雅黑"/>
+              </a:rPr>
+              <a:t>阶段与队列</a:t>
+            </a:r>
+          </a:p>
+        </p:txBody>
+      </p:sp>
+      <p:sp>
+        <p:nvSpPr>
           <p:cNvPr id="40" name="TextBox 39"/>
           <p:cNvSpPr txBox="1"/>
           <p:nvPr/>
         </p:nvSpPr>
         <p:spPr>
           <a:xfrm>
-            <a:off x="11006328" y="3886200"/>
-            <a:ext cx="4108704" cy="365760"/>
+            <a:off x="5983224" y="5989320"/>
+            <a:ext cx="4291584" cy="411480"/>
           </a:xfrm>
           <a:prstGeom prst="rect">
             <a:avLst/>
@@ -15097,7 +15059,90 @@
           </a:bodyPr>
           <a:lstStyle/>
           <a:p>
-            <a:pPr algn="l"/>
+            <a:pPr algn="ctr"/>
+            <a:r>
+              <a:rPr sz="1400" b="0">
+                <a:solidFill>
+                  <a:srgbClr val="572D26"/>
+                </a:solidFill>
+                <a:latin typeface="微软雅黑"/>
+                <a:ea typeface="微软雅黑"/>
+                <a:cs typeface="微软雅黑"/>
+              </a:rPr>
+              <a:t>时间主要消耗在哪一段</a:t>
+            </a:r>
+          </a:p>
+        </p:txBody>
+      </p:sp>
+      <p:sp>
+        <p:nvSpPr>
+          <p:cNvPr id="41" name="Rounded Rectangle 40"/>
+          <p:cNvSpPr/>
+          <p:nvPr/>
+        </p:nvSpPr>
+        <p:spPr>
+          <a:xfrm>
+            <a:off x="10732008" y="5303520"/>
+            <a:ext cx="4657344" cy="1554480"/>
+          </a:xfrm>
+          <a:prstGeom prst="roundRect">
+            <a:avLst>
+              <a:gd name="adj" fmla="val 8000"/>
+            </a:avLst>
+          </a:prstGeom>
+          <a:solidFill>
+            <a:srgbClr val="FFF9F3"/>
+          </a:solidFill>
+          <a:ln>
+            <a:noFill/>
+          </a:ln>
+          <a:effectLst/>
+        </p:spPr>
+        <p:style>
+          <a:lnRef idx="1">
+            <a:schemeClr val="accent1"/>
+          </a:lnRef>
+          <a:fillRef idx="3">
+            <a:schemeClr val="accent1"/>
+          </a:fillRef>
+          <a:effectRef idx="2">
+            <a:schemeClr val="accent1"/>
+          </a:effectRef>
+          <a:fontRef idx="minor">
+            <a:schemeClr val="lt1"/>
+          </a:fontRef>
+        </p:style>
+        <p:txBody>
+          <a:bodyPr rtlCol="0" anchor="ctr"/>
+          <a:lstStyle/>
+          <a:p>
+            <a:pPr algn="ctr"/>
+          </a:p>
+        </p:txBody>
+      </p:sp>
+      <p:sp>
+        <p:nvSpPr>
+          <p:cNvPr id="42" name="TextBox 41"/>
+          <p:cNvSpPr txBox="1"/>
+          <p:nvPr/>
+        </p:nvSpPr>
+        <p:spPr>
+          <a:xfrm>
+            <a:off x="10732008" y="5532120"/>
+            <a:ext cx="4657344" cy="365760"/>
+          </a:xfrm>
+          <a:prstGeom prst="rect">
+            <a:avLst/>
+          </a:prstGeom>
+          <a:noFill/>
+        </p:spPr>
+        <p:txBody>
+          <a:bodyPr wrap="square" lIns="0" rIns="0" tIns="0" bIns="0" anchor="t">
+            <a:spAutoFit/>
+          </a:bodyPr>
+          <a:lstStyle/>
+          <a:p>
+            <a:pPr algn="ctr"/>
             <a:r>
               <a:rPr sz="1800" b="1">
                 <a:solidFill>
@@ -15114,14 +15159,14 @@
       </p:sp>
       <p:sp>
         <p:nvSpPr>
-          <p:cNvPr id="41" name="TextBox 40"/>
-          <p:cNvSpPr txBox="1"/>
-          <p:nvPr/>
-        </p:nvSpPr>
-        <p:spPr>
-          <a:xfrm>
-            <a:off x="11006328" y="4389120"/>
-            <a:ext cx="4108704" cy="1463040"/>
+          <p:cNvPr id="43" name="TextBox 42"/>
+          <p:cNvSpPr txBox="1"/>
+          <p:nvPr/>
+        </p:nvSpPr>
+        <p:spPr>
+          <a:xfrm>
+            <a:off x="10914888" y="5989320"/>
+            <a:ext cx="4291584" cy="411480"/>
           </a:xfrm>
           <a:prstGeom prst="rect">
             <a:avLst/>
@@ -15134,11 +15179,7 @@
           </a:bodyPr>
           <a:lstStyle/>
           <a:p>
-            <a:pPr algn="l">
-              <a:lnSpc>
-                <a:spcPct val="130000"/>
-              </a:lnSpc>
-            </a:pPr>
+            <a:pPr algn="ctr"/>
             <a:r>
               <a:rPr sz="1400" b="0">
                 <a:solidFill>
@@ -16082,7 +16123,7 @@
                 <a:ea typeface="优设标题黑"/>
                 <a:cs typeface="优设标题黑"/>
               </a:rPr>
-              <a:t>04.一个常见卡顿问题，四个 Skill 怎么配合</a:t>
+              <a:t>04.一个常见卡顿问题，四个 Skill 怎么配合？</a:t>
             </a:r>
           </a:p>
         </p:txBody>
@@ -16095,8 +16136,8 @@
         </p:nvSpPr>
         <p:spPr>
           <a:xfrm>
-            <a:off x="868680" y="1828800"/>
-            <a:ext cx="14520672" cy="566928"/>
+            <a:off x="868680" y="1783080"/>
+            <a:ext cx="14520672" cy="603504"/>
           </a:xfrm>
           <a:prstGeom prst="roundRect">
             <a:avLst>
@@ -16141,8 +16182,8 @@
         </p:nvSpPr>
         <p:spPr>
           <a:xfrm>
-            <a:off x="1170432" y="1828800"/>
-            <a:ext cx="13898880" cy="566928"/>
+            <a:off x="1188720" y="1783080"/>
+            <a:ext cx="13880592" cy="603504"/>
           </a:xfrm>
           <a:prstGeom prst="rect">
             <a:avLst/>
@@ -16155,7 +16196,7 @@
           </a:bodyPr>
           <a:lstStyle/>
           <a:p>
-            <a:pPr algn="l"/>
+            <a:pPr algn="ctr"/>
             <a:r>
               <a:rPr sz="1800" b="1">
                 <a:solidFill>
@@ -16178,8 +16219,8 @@
         </p:nvSpPr>
         <p:spPr>
           <a:xfrm>
-            <a:off x="868680" y="2670048"/>
-            <a:ext cx="3321558" cy="2697480"/>
+            <a:off x="868680" y="2651760"/>
+            <a:ext cx="3321558" cy="3017520"/>
           </a:xfrm>
           <a:prstGeom prst="roundRect">
             <a:avLst>
@@ -16224,8 +16265,8 @@
         </p:nvSpPr>
         <p:spPr>
           <a:xfrm>
-            <a:off x="1124712" y="2880360"/>
-            <a:ext cx="2809494" cy="365760"/>
+            <a:off x="868680" y="2926080"/>
+            <a:ext cx="3321558" cy="320040"/>
           </a:xfrm>
           <a:prstGeom prst="rect">
             <a:avLst/>
@@ -16238,9 +16279,9 @@
           </a:bodyPr>
           <a:lstStyle/>
           <a:p>
-            <a:pPr algn="l"/>
-            <a:r>
-              <a:rPr sz="1800" b="1">
+            <a:pPr algn="ctr"/>
+            <a:r>
+              <a:rPr sz="1800" b="1" spc="150">
                 <a:solidFill>
                   <a:srgbClr val="FF3C00"/>
                 </a:solidFill>
@@ -16261,8 +16302,8 @@
         </p:nvSpPr>
         <p:spPr>
           <a:xfrm>
-            <a:off x="1124712" y="3364992"/>
-            <a:ext cx="2809494" cy="1737360"/>
+            <a:off x="1069848" y="3520440"/>
+            <a:ext cx="2919222" cy="822960"/>
           </a:xfrm>
           <a:prstGeom prst="rect">
             <a:avLst/>
@@ -16275,13 +16316,13 @@
           </a:bodyPr>
           <a:lstStyle/>
           <a:p>
-            <a:pPr algn="l">
+            <a:pPr algn="ctr">
               <a:lnSpc>
-                <a:spcPct val="130000"/>
+                <a:spcPct val="125000"/>
               </a:lnSpc>
             </a:pPr>
             <a:r>
-              <a:rPr sz="1400" b="0">
+              <a:rPr sz="1800" b="1">
                 <a:solidFill>
                   <a:srgbClr val="572D26"/>
                 </a:solidFill>
@@ -16289,8 +16330,7 @@
                 <a:ea typeface="微软雅黑"/>
                 <a:cs typeface="微软雅黑"/>
               </a:rPr>
-              <a:t>异常窗口谁在运行？
-调用栈热点</a:t>
+              <a:t>异常窗口谁在运行？</a:t>
             </a:r>
           </a:p>
         </p:txBody>
@@ -16303,7 +16343,44 @@
         </p:nvSpPr>
         <p:spPr>
           <a:xfrm>
-            <a:off x="4226814" y="3749039"/>
+            <a:off x="1069848" y="4892040"/>
+            <a:ext cx="2919222" cy="365760"/>
+          </a:xfrm>
+          <a:prstGeom prst="rect">
+            <a:avLst/>
+          </a:prstGeom>
+          <a:noFill/>
+        </p:spPr>
+        <p:txBody>
+          <a:bodyPr wrap="square" lIns="0" rIns="0" tIns="0" bIns="0" anchor="t">
+            <a:spAutoFit/>
+          </a:bodyPr>
+          <a:lstStyle/>
+          <a:p>
+            <a:pPr algn="ctr"/>
+            <a:r>
+              <a:rPr sz="1200" b="0">
+                <a:solidFill>
+                  <a:srgbClr val="9A8578"/>
+                </a:solidFill>
+                <a:latin typeface="微软雅黑"/>
+                <a:ea typeface="微软雅黑"/>
+                <a:cs typeface="微软雅黑"/>
+              </a:rPr>
+              <a:t>调用栈热点</a:t>
+            </a:r>
+          </a:p>
+        </p:txBody>
+      </p:sp>
+      <p:sp>
+        <p:nvSpPr>
+          <p:cNvPr id="17" name="TextBox 16"/>
+          <p:cNvSpPr txBox="1"/>
+          <p:nvPr/>
+        </p:nvSpPr>
+        <p:spPr>
+          <a:xfrm>
+            <a:off x="4226814" y="3840480"/>
             <a:ext cx="338328" cy="457200"/>
           </a:xfrm>
           <a:prstGeom prst="rect">
@@ -16334,14 +16411,14 @@
       </p:sp>
       <p:sp>
         <p:nvSpPr>
-          <p:cNvPr id="17" name="Rounded Rectangle 16"/>
+          <p:cNvPr id="18" name="Rounded Rectangle 17"/>
           <p:cNvSpPr/>
           <p:nvPr/>
         </p:nvSpPr>
         <p:spPr>
           <a:xfrm>
-            <a:off x="4601718" y="2670048"/>
-            <a:ext cx="3321558" cy="2697480"/>
+            <a:off x="4601718" y="2651760"/>
+            <a:ext cx="3321558" cy="3017520"/>
           </a:xfrm>
           <a:prstGeom prst="roundRect">
             <a:avLst>
@@ -16380,14 +16457,14 @@
       </p:sp>
       <p:sp>
         <p:nvSpPr>
-          <p:cNvPr id="18" name="TextBox 17"/>
-          <p:cNvSpPr txBox="1"/>
-          <p:nvPr/>
-        </p:nvSpPr>
-        <p:spPr>
-          <a:xfrm>
-            <a:off x="4857750" y="2880360"/>
-            <a:ext cx="2809494" cy="365760"/>
+          <p:cNvPr id="19" name="TextBox 18"/>
+          <p:cNvSpPr txBox="1"/>
+          <p:nvPr/>
+        </p:nvSpPr>
+        <p:spPr>
+          <a:xfrm>
+            <a:off x="4601718" y="2926080"/>
+            <a:ext cx="3321558" cy="320040"/>
           </a:xfrm>
           <a:prstGeom prst="rect">
             <a:avLst/>
@@ -16400,9 +16477,9 @@
           </a:bodyPr>
           <a:lstStyle/>
           <a:p>
-            <a:pPr algn="l"/>
-            <a:r>
-              <a:rPr sz="1800" b="1">
+            <a:pPr algn="ctr"/>
+            <a:r>
+              <a:rPr sz="1800" b="1" spc="150">
                 <a:solidFill>
                   <a:srgbClr val="FF3C00"/>
                 </a:solidFill>
@@ -16417,14 +16494,14 @@
       </p:sp>
       <p:sp>
         <p:nvSpPr>
-          <p:cNvPr id="19" name="TextBox 18"/>
-          <p:cNvSpPr txBox="1"/>
-          <p:nvPr/>
-        </p:nvSpPr>
-        <p:spPr>
-          <a:xfrm>
-            <a:off x="4857750" y="3364992"/>
-            <a:ext cx="2809494" cy="1737360"/>
+          <p:cNvPr id="20" name="TextBox 19"/>
+          <p:cNvSpPr txBox="1"/>
+          <p:nvPr/>
+        </p:nvSpPr>
+        <p:spPr>
+          <a:xfrm>
+            <a:off x="4802886" y="3520440"/>
+            <a:ext cx="2919222" cy="822960"/>
           </a:xfrm>
           <a:prstGeom prst="rect">
             <a:avLst/>
@@ -16437,13 +16514,13 @@
           </a:bodyPr>
           <a:lstStyle/>
           <a:p>
-            <a:pPr algn="l">
+            <a:pPr algn="ctr">
               <a:lnSpc>
-                <a:spcPct val="130000"/>
+                <a:spcPct val="125000"/>
               </a:lnSpc>
             </a:pPr>
             <a:r>
-              <a:rPr sz="1400" b="0">
+              <a:rPr sz="1800" b="1">
                 <a:solidFill>
                   <a:srgbClr val="572D26"/>
                 </a:solidFill>
@@ -16451,21 +16528,57 @@
                 <a:ea typeface="微软雅黑"/>
                 <a:cs typeface="微软雅黑"/>
               </a:rPr>
-              <a:t>是不是高频分配？
-Total / Churn</a:t>
-            </a:r>
-          </a:p>
-        </p:txBody>
-      </p:sp>
-      <p:sp>
-        <p:nvSpPr>
-          <p:cNvPr id="20" name="TextBox 19"/>
-          <p:cNvSpPr txBox="1"/>
-          <p:nvPr/>
-        </p:nvSpPr>
-        <p:spPr>
-          <a:xfrm>
-            <a:off x="7959852" y="3749039"/>
+              <a:t>是不是高频分配？</a:t>
+            </a:r>
+          </a:p>
+        </p:txBody>
+      </p:sp>
+      <p:sp>
+        <p:nvSpPr>
+          <p:cNvPr id="21" name="TextBox 20"/>
+          <p:cNvSpPr txBox="1"/>
+          <p:nvPr/>
+        </p:nvSpPr>
+        <p:spPr>
+          <a:xfrm>
+            <a:off x="4802886" y="4892040"/>
+            <a:ext cx="2919222" cy="365760"/>
+          </a:xfrm>
+          <a:prstGeom prst="rect">
+            <a:avLst/>
+          </a:prstGeom>
+          <a:noFill/>
+        </p:spPr>
+        <p:txBody>
+          <a:bodyPr wrap="square" lIns="0" rIns="0" tIns="0" bIns="0" anchor="t">
+            <a:spAutoFit/>
+          </a:bodyPr>
+          <a:lstStyle/>
+          <a:p>
+            <a:pPr algn="ctr"/>
+            <a:r>
+              <a:rPr sz="1200" b="0">
+                <a:solidFill>
+                  <a:srgbClr val="9A8578"/>
+                </a:solidFill>
+                <a:latin typeface="微软雅黑"/>
+                <a:ea typeface="微软雅黑"/>
+                <a:cs typeface="微软雅黑"/>
+              </a:rPr>
+              <a:t>Total / Churn</a:t>
+            </a:r>
+          </a:p>
+        </p:txBody>
+      </p:sp>
+      <p:sp>
+        <p:nvSpPr>
+          <p:cNvPr id="22" name="TextBox 21"/>
+          <p:cNvSpPr txBox="1"/>
+          <p:nvPr/>
+        </p:nvSpPr>
+        <p:spPr>
+          <a:xfrm>
+            <a:off x="7959852" y="3840480"/>
             <a:ext cx="338328" cy="457200"/>
           </a:xfrm>
           <a:prstGeom prst="rect">
@@ -16496,14 +16609,14 @@
       </p:sp>
       <p:sp>
         <p:nvSpPr>
-          <p:cNvPr id="21" name="Rounded Rectangle 20"/>
+          <p:cNvPr id="23" name="Rounded Rectangle 22"/>
           <p:cNvSpPr/>
           <p:nvPr/>
         </p:nvSpPr>
         <p:spPr>
           <a:xfrm>
-            <a:off x="8334756" y="2670048"/>
-            <a:ext cx="3321558" cy="2697480"/>
+            <a:off x="8334756" y="2651760"/>
+            <a:ext cx="3321558" cy="3017520"/>
           </a:xfrm>
           <a:prstGeom prst="roundRect">
             <a:avLst>
@@ -16542,14 +16655,14 @@
       </p:sp>
       <p:sp>
         <p:nvSpPr>
-          <p:cNvPr id="22" name="TextBox 21"/>
-          <p:cNvSpPr txBox="1"/>
-          <p:nvPr/>
-        </p:nvSpPr>
-        <p:spPr>
-          <a:xfrm>
-            <a:off x="8590788" y="2880360"/>
-            <a:ext cx="2809494" cy="365760"/>
+          <p:cNvPr id="24" name="TextBox 23"/>
+          <p:cNvSpPr txBox="1"/>
+          <p:nvPr/>
+        </p:nvSpPr>
+        <p:spPr>
+          <a:xfrm>
+            <a:off x="8334756" y="2926080"/>
+            <a:ext cx="3321558" cy="320040"/>
           </a:xfrm>
           <a:prstGeom prst="rect">
             <a:avLst/>
@@ -16562,9 +16675,9 @@
           </a:bodyPr>
           <a:lstStyle/>
           <a:p>
-            <a:pPr algn="l"/>
-            <a:r>
-              <a:rPr sz="1800" b="1">
+            <a:pPr algn="ctr"/>
+            <a:r>
+              <a:rPr sz="1800" b="1" spc="150">
                 <a:solidFill>
                   <a:srgbClr val="FF3C00"/>
                 </a:solidFill>
@@ -16579,14 +16692,14 @@
       </p:sp>
       <p:sp>
         <p:nvSpPr>
-          <p:cNvPr id="23" name="TextBox 22"/>
-          <p:cNvSpPr txBox="1"/>
-          <p:nvPr/>
-        </p:nvSpPr>
-        <p:spPr>
-          <a:xfrm>
-            <a:off x="8590788" y="3364992"/>
-            <a:ext cx="2809494" cy="1737360"/>
+          <p:cNvPr id="25" name="TextBox 24"/>
+          <p:cNvSpPr txBox="1"/>
+          <p:nvPr/>
+        </p:nvSpPr>
+        <p:spPr>
+          <a:xfrm>
+            <a:off x="8535924" y="3520440"/>
+            <a:ext cx="2919222" cy="822960"/>
           </a:xfrm>
           <a:prstGeom prst="rect">
             <a:avLst/>
@@ -16599,13 +16712,13 @@
           </a:bodyPr>
           <a:lstStyle/>
           <a:p>
-            <a:pPr algn="l">
+            <a:pPr algn="ctr">
               <a:lnSpc>
-                <a:spcPct val="130000"/>
+                <a:spcPct val="125000"/>
               </a:lnSpc>
             </a:pPr>
             <a:r>
-              <a:rPr sz="1400" b="0">
+              <a:rPr sz="1800" b="1">
                 <a:solidFill>
                   <a:srgbClr val="572D26"/>
                 </a:solidFill>
@@ -16613,21 +16726,57 @@
                 <a:ea typeface="微软雅黑"/>
                 <a:cs typeface="微软雅黑"/>
               </a:rPr>
-              <a:t>有没有唤醒 / 等待？
-线程状态</a:t>
-            </a:r>
-          </a:p>
-        </p:txBody>
-      </p:sp>
-      <p:sp>
-        <p:nvSpPr>
-          <p:cNvPr id="24" name="TextBox 23"/>
-          <p:cNvSpPr txBox="1"/>
-          <p:nvPr/>
-        </p:nvSpPr>
-        <p:spPr>
-          <a:xfrm>
-            <a:off x="11692890" y="3749039"/>
+              <a:t>有没有唤醒 / 等待？</a:t>
+            </a:r>
+          </a:p>
+        </p:txBody>
+      </p:sp>
+      <p:sp>
+        <p:nvSpPr>
+          <p:cNvPr id="26" name="TextBox 25"/>
+          <p:cNvSpPr txBox="1"/>
+          <p:nvPr/>
+        </p:nvSpPr>
+        <p:spPr>
+          <a:xfrm>
+            <a:off x="8535924" y="4892040"/>
+            <a:ext cx="2919222" cy="365760"/>
+          </a:xfrm>
+          <a:prstGeom prst="rect">
+            <a:avLst/>
+          </a:prstGeom>
+          <a:noFill/>
+        </p:spPr>
+        <p:txBody>
+          <a:bodyPr wrap="square" lIns="0" rIns="0" tIns="0" bIns="0" anchor="t">
+            <a:spAutoFit/>
+          </a:bodyPr>
+          <a:lstStyle/>
+          <a:p>
+            <a:pPr algn="ctr"/>
+            <a:r>
+              <a:rPr sz="1200" b="0">
+                <a:solidFill>
+                  <a:srgbClr val="9A8578"/>
+                </a:solidFill>
+                <a:latin typeface="微软雅黑"/>
+                <a:ea typeface="微软雅黑"/>
+                <a:cs typeface="微软雅黑"/>
+              </a:rPr>
+              <a:t>线程状态</a:t>
+            </a:r>
+          </a:p>
+        </p:txBody>
+      </p:sp>
+      <p:sp>
+        <p:nvSpPr>
+          <p:cNvPr id="27" name="TextBox 26"/>
+          <p:cNvSpPr txBox="1"/>
+          <p:nvPr/>
+        </p:nvSpPr>
+        <p:spPr>
+          <a:xfrm>
+            <a:off x="11692890" y="3840480"/>
             <a:ext cx="338328" cy="457200"/>
           </a:xfrm>
           <a:prstGeom prst="rect">
@@ -16658,14 +16807,14 @@
       </p:sp>
       <p:sp>
         <p:nvSpPr>
-          <p:cNvPr id="25" name="Rounded Rectangle 24"/>
+          <p:cNvPr id="28" name="Rounded Rectangle 27"/>
           <p:cNvSpPr/>
           <p:nvPr/>
         </p:nvSpPr>
         <p:spPr>
           <a:xfrm>
-            <a:off x="12067794" y="2670048"/>
-            <a:ext cx="3321558" cy="2697480"/>
+            <a:off x="12067794" y="2651760"/>
+            <a:ext cx="3321558" cy="3017520"/>
           </a:xfrm>
           <a:prstGeom prst="roundRect">
             <a:avLst>
@@ -16704,14 +16853,14 @@
       </p:sp>
       <p:sp>
         <p:nvSpPr>
-          <p:cNvPr id="26" name="TextBox 25"/>
-          <p:cNvSpPr txBox="1"/>
-          <p:nvPr/>
-        </p:nvSpPr>
-        <p:spPr>
-          <a:xfrm>
-            <a:off x="12323826" y="2880360"/>
-            <a:ext cx="2809494" cy="365760"/>
+          <p:cNvPr id="29" name="TextBox 28"/>
+          <p:cNvSpPr txBox="1"/>
+          <p:nvPr/>
+        </p:nvSpPr>
+        <p:spPr>
+          <a:xfrm>
+            <a:off x="12067794" y="2926080"/>
+            <a:ext cx="3321558" cy="320040"/>
           </a:xfrm>
           <a:prstGeom prst="rect">
             <a:avLst/>
@@ -16724,9 +16873,9 @@
           </a:bodyPr>
           <a:lstStyle/>
           <a:p>
-            <a:pPr algn="l"/>
-            <a:r>
-              <a:rPr sz="1800" b="1">
+            <a:pPr algn="ctr"/>
+            <a:r>
+              <a:rPr sz="1800" b="1" spc="150">
                 <a:solidFill>
                   <a:srgbClr val="FF3C00"/>
                 </a:solidFill>
@@ -16741,14 +16890,14 @@
       </p:sp>
       <p:sp>
         <p:nvSpPr>
-          <p:cNvPr id="27" name="TextBox 26"/>
-          <p:cNvSpPr txBox="1"/>
-          <p:nvPr/>
-        </p:nvSpPr>
-        <p:spPr>
-          <a:xfrm>
-            <a:off x="12323826" y="3364992"/>
-            <a:ext cx="2809494" cy="1737360"/>
+          <p:cNvPr id="30" name="TextBox 29"/>
+          <p:cNvSpPr txBox="1"/>
+          <p:nvPr/>
+        </p:nvSpPr>
+        <p:spPr>
+          <a:xfrm>
+            <a:off x="12268962" y="3520440"/>
+            <a:ext cx="2919222" cy="822960"/>
           </a:xfrm>
           <a:prstGeom prst="rect">
             <a:avLst/>
@@ -16761,133 +16910,178 @@
           </a:bodyPr>
           <a:lstStyle/>
           <a:p>
-            <a:pPr algn="l">
+            <a:pPr algn="ctr">
               <a:lnSpc>
-                <a:spcPct val="130000"/>
+                <a:spcPct val="125000"/>
               </a:lnSpc>
             </a:pPr>
             <a:r>
+              <a:rPr sz="1800" b="1">
+                <a:solidFill>
+                  <a:srgbClr val="572D26"/>
+                </a:solidFill>
+                <a:latin typeface="微软雅黑"/>
+                <a:ea typeface="微软雅黑"/>
+                <a:cs typeface="微软雅黑"/>
+              </a:rPr>
+              <a:t>卡顿发生在哪段业务？</a:t>
+            </a:r>
+          </a:p>
+        </p:txBody>
+      </p:sp>
+      <p:sp>
+        <p:nvSpPr>
+          <p:cNvPr id="31" name="TextBox 30"/>
+          <p:cNvSpPr txBox="1"/>
+          <p:nvPr/>
+        </p:nvSpPr>
+        <p:spPr>
+          <a:xfrm>
+            <a:off x="12268962" y="4892040"/>
+            <a:ext cx="2919222" cy="365760"/>
+          </a:xfrm>
+          <a:prstGeom prst="rect">
+            <a:avLst/>
+          </a:prstGeom>
+          <a:noFill/>
+        </p:spPr>
+        <p:txBody>
+          <a:bodyPr wrap="square" lIns="0" rIns="0" tIns="0" bIns="0" anchor="t">
+            <a:spAutoFit/>
+          </a:bodyPr>
+          <a:lstStyle/>
+          <a:p>
+            <a:pPr algn="ctr"/>
+            <a:r>
+              <a:rPr sz="1200" b="0">
+                <a:solidFill>
+                  <a:srgbClr val="9A8578"/>
+                </a:solidFill>
+                <a:latin typeface="微软雅黑"/>
+                <a:ea typeface="微软雅黑"/>
+                <a:cs typeface="微软雅黑"/>
+              </a:rPr>
+              <a:t>Frame / Queue</a:t>
+            </a:r>
+          </a:p>
+        </p:txBody>
+      </p:sp>
+      <p:sp>
+        <p:nvSpPr>
+          <p:cNvPr id="32" name="Rounded Rectangle 31"/>
+          <p:cNvSpPr/>
+          <p:nvPr/>
+        </p:nvSpPr>
+        <p:spPr>
+          <a:xfrm>
+            <a:off x="868680" y="5943600"/>
+            <a:ext cx="14520672" cy="777240"/>
+          </a:xfrm>
+          <a:prstGeom prst="roundRect">
+            <a:avLst>
+              <a:gd name="adj" fmla="val 8000"/>
+            </a:avLst>
+          </a:prstGeom>
+          <a:solidFill>
+            <a:srgbClr val="FFEFD9"/>
+          </a:solidFill>
+          <a:ln>
+            <a:noFill/>
+          </a:ln>
+          <a:effectLst/>
+        </p:spPr>
+        <p:style>
+          <a:lnRef idx="1">
+            <a:schemeClr val="accent1"/>
+          </a:lnRef>
+          <a:fillRef idx="3">
+            <a:schemeClr val="accent1"/>
+          </a:fillRef>
+          <a:effectRef idx="2">
+            <a:schemeClr val="accent1"/>
+          </a:effectRef>
+          <a:fontRef idx="minor">
+            <a:schemeClr val="lt1"/>
+          </a:fontRef>
+        </p:style>
+        <p:txBody>
+          <a:bodyPr rtlCol="0" anchor="ctr"/>
+          <a:lstStyle/>
+          <a:p>
+            <a:pPr algn="ctr"/>
+          </a:p>
+        </p:txBody>
+      </p:sp>
+      <p:sp>
+        <p:nvSpPr>
+          <p:cNvPr id="33" name="TextBox 32"/>
+          <p:cNvSpPr txBox="1"/>
+          <p:nvPr/>
+        </p:nvSpPr>
+        <p:spPr>
+          <a:xfrm>
+            <a:off x="1188720" y="5943600"/>
+            <a:ext cx="13880592" cy="777240"/>
+          </a:xfrm>
+          <a:prstGeom prst="rect">
+            <a:avLst/>
+          </a:prstGeom>
+          <a:noFill/>
+        </p:spPr>
+        <p:txBody>
+          <a:bodyPr wrap="square" lIns="0" rIns="0" tIns="0" bIns="0" anchor="ctr">
+            <a:spAutoFit/>
+          </a:bodyPr>
+          <a:lstStyle/>
+          <a:p>
+            <a:pPr algn="ctr"/>
+            <a:r>
+              <a:rPr sz="1800" b="1">
+                <a:solidFill>
+                  <a:srgbClr val="572D26"/>
+                </a:solidFill>
+                <a:latin typeface="微软雅黑"/>
+                <a:ea typeface="微软雅黑"/>
+                <a:cs typeface="微软雅黑"/>
+              </a:rPr>
+              <a:t>形成可信结论，需要同一异常时间窗的证据、相关调用路径和必要的对照验证。</a:t>
+            </a:r>
+          </a:p>
+        </p:txBody>
+      </p:sp>
+      <p:sp>
+        <p:nvSpPr>
+          <p:cNvPr id="34" name="TextBox 33"/>
+          <p:cNvSpPr txBox="1"/>
+          <p:nvPr/>
+        </p:nvSpPr>
+        <p:spPr>
+          <a:xfrm>
+            <a:off x="868680" y="6967728"/>
+            <a:ext cx="14520672" cy="320040"/>
+          </a:xfrm>
+          <a:prstGeom prst="rect">
+            <a:avLst/>
+          </a:prstGeom>
+          <a:noFill/>
+        </p:spPr>
+        <p:txBody>
+          <a:bodyPr wrap="square" lIns="0" rIns="0" tIns="0" bIns="0" anchor="t">
+            <a:spAutoFit/>
+          </a:bodyPr>
+          <a:lstStyle/>
+          <a:p>
+            <a:pPr algn="ctr"/>
+            <a:r>
               <a:rPr sz="1400" b="0">
                 <a:solidFill>
-                  <a:srgbClr val="572D26"/>
-                </a:solidFill>
-                <a:latin typeface="微软雅黑"/>
-                <a:ea typeface="微软雅黑"/>
-                <a:cs typeface="微软雅黑"/>
-              </a:rPr>
-              <a:t>卡顿发生在哪段业务？
-Frame / Queue</a:t>
-            </a:r>
-          </a:p>
-        </p:txBody>
-      </p:sp>
-      <p:sp>
-        <p:nvSpPr>
-          <p:cNvPr id="28" name="TextBox 27"/>
-          <p:cNvSpPr txBox="1"/>
-          <p:nvPr/>
-        </p:nvSpPr>
-        <p:spPr>
-          <a:xfrm>
-            <a:off x="868680" y="5623560"/>
-            <a:ext cx="14520672" cy="411480"/>
-          </a:xfrm>
-          <a:prstGeom prst="rect">
-            <a:avLst/>
-          </a:prstGeom>
-          <a:noFill/>
-        </p:spPr>
-        <p:txBody>
-          <a:bodyPr wrap="square" lIns="0" rIns="0" tIns="0" bIns="0" anchor="t">
-            <a:spAutoFit/>
-          </a:bodyPr>
-          <a:lstStyle/>
-          <a:p>
-            <a:pPr algn="ctr"/>
-            <a:r>
-              <a:rPr sz="1800" b="1">
-                <a:solidFill>
-                  <a:srgbClr val="572D26"/>
-                </a:solidFill>
-                <a:latin typeface="微软雅黑"/>
-                <a:ea typeface="微软雅黑"/>
-                <a:cs typeface="微软雅黑"/>
-              </a:rPr>
-              <a:t>形成可信结论，需要同一异常时间窗的证据、相关调用路径和必要的对照验证。</a:t>
-            </a:r>
-          </a:p>
-        </p:txBody>
-      </p:sp>
-      <p:sp>
-        <p:nvSpPr>
-          <p:cNvPr id="29" name="TextBox 28"/>
-          <p:cNvSpPr txBox="1"/>
-          <p:nvPr/>
-        </p:nvSpPr>
-        <p:spPr>
-          <a:xfrm>
-            <a:off x="868680" y="6144768"/>
-            <a:ext cx="14520672" cy="320040"/>
-          </a:xfrm>
-          <a:prstGeom prst="rect">
-            <a:avLst/>
-          </a:prstGeom>
-          <a:noFill/>
-        </p:spPr>
-        <p:txBody>
-          <a:bodyPr wrap="square" lIns="0" rIns="0" tIns="0" bIns="0" anchor="t">
-            <a:spAutoFit/>
-          </a:bodyPr>
-          <a:lstStyle/>
-          <a:p>
-            <a:pPr algn="ctr"/>
-            <a:r>
-              <a:rPr sz="1400" b="0">
-                <a:solidFill>
-                  <a:srgbClr val="572D26"/>
+                  <a:srgbClr val="9A8578"/>
                 </a:solidFill>
                 <a:latin typeface="微软雅黑"/>
                 <a:ea typeface="微软雅黑"/>
                 <a:cs typeface="微软雅黑"/>
               </a:rPr>
               <a:t>一次诊断不一定调用全部模块；从最能区分假设的证据开始，缺什么再补。</a:t>
-            </a:r>
-          </a:p>
-        </p:txBody>
-      </p:sp>
-      <p:sp>
-        <p:nvSpPr>
-          <p:cNvPr id="30" name="TextBox 29"/>
-          <p:cNvSpPr txBox="1"/>
-          <p:nvPr/>
-        </p:nvSpPr>
-        <p:spPr>
-          <a:xfrm>
-            <a:off x="868680" y="6720840"/>
-            <a:ext cx="14520672" cy="274320"/>
-          </a:xfrm>
-          <a:prstGeom prst="rect">
-            <a:avLst/>
-          </a:prstGeom>
-          <a:noFill/>
-        </p:spPr>
-        <p:txBody>
-          <a:bodyPr wrap="square" lIns="0" rIns="0" tIns="0" bIns="0" anchor="t">
-            <a:spAutoFit/>
-          </a:bodyPr>
-          <a:lstStyle/>
-          <a:p>
-            <a:pPr algn="l"/>
-            <a:r>
-              <a:rPr sz="1200" b="0">
-                <a:solidFill>
-                  <a:srgbClr val="9A8578"/>
-                </a:solidFill>
-                <a:latin typeface="微软雅黑"/>
-                <a:ea typeface="微软雅黑"/>
-                <a:cs typeface="微软雅黑"/>
-              </a:rPr>
-              <a:t>这不是已完成的 worker_app 根因结论，而是联合诊断教学示例。</a:t>
             </a:r>
           </a:p>
         </p:txBody>

</xml_diff>